<commit_message>
AVANCES DEL DIA 03092020
</commit_message>
<xml_diff>
--- a/Docs/IT_DEV_PEARL_LEATHER_QA_INSPECCION_27082020.pptx
+++ b/Docs/IT_DEV_PEARL_LEATHER_QA_INSPECCION_27082020.pptx
@@ -5,12 +5,16 @@
     <p:sldMasterId id="2147483648" r:id="rId1"/>
   </p:sldMasterIdLst>
   <p:notesMasterIdLst>
-    <p:notesMasterId r:id="rId5"/>
+    <p:notesMasterId r:id="rId9"/>
   </p:notesMasterIdLst>
   <p:sldIdLst>
     <p:sldId id="344" r:id="rId2"/>
-    <p:sldId id="391" r:id="rId3"/>
-    <p:sldId id="392" r:id="rId4"/>
+    <p:sldId id="394" r:id="rId3"/>
+    <p:sldId id="395" r:id="rId4"/>
+    <p:sldId id="396" r:id="rId5"/>
+    <p:sldId id="393" r:id="rId6"/>
+    <p:sldId id="391" r:id="rId7"/>
+    <p:sldId id="392" r:id="rId8"/>
   </p:sldIdLst>
   <p:sldSz cx="9144000" cy="6858000" type="screen4x3"/>
   <p:notesSz cx="6858000" cy="9144000"/>
@@ -111,7 +115,7 @@
   </p:defaultTextStyle>
   <p:extLst>
     <p:ext uri="{EFAFB233-063F-42B5-8137-9DF3F51BA10A}">
-      <p15:sldGuideLst xmlns="" xmlns:p15="http://schemas.microsoft.com/office/powerpoint/2012/main">
+      <p15:sldGuideLst xmlns:p15="http://schemas.microsoft.com/office/powerpoint/2012/main" xmlns="">
         <p15:guide id="1" orient="horz" pos="2160">
           <p15:clr>
             <a:srgbClr val="A4A3A4"/>
@@ -210,7 +214,7 @@
           <a:p>
             <a:fld id="{A17B1792-3256-4E77-8442-3E205CD69EF5}" type="datetimeFigureOut">
               <a:rPr lang="en-US" smtClean="0"/>
-              <a:t>8/27/2020</a:t>
+              <a:t>9/3/2020</a:t>
             </a:fld>
             <a:endParaRPr lang="en-US"/>
           </a:p>
@@ -659,7 +663,7 @@
           <a:p>
             <a:fld id="{07558649-2619-44F9-8F30-2D6466E57529}" type="datetimeFigureOut">
               <a:rPr lang="en-US" smtClean="0"/>
-              <a:t>8/27/2020</a:t>
+              <a:t>9/3/2020</a:t>
             </a:fld>
             <a:endParaRPr lang="en-US"/>
           </a:p>
@@ -829,7 +833,7 @@
           <a:p>
             <a:fld id="{07558649-2619-44F9-8F30-2D6466E57529}" type="datetimeFigureOut">
               <a:rPr lang="en-US" smtClean="0"/>
-              <a:t>8/27/2020</a:t>
+              <a:t>9/3/2020</a:t>
             </a:fld>
             <a:endParaRPr lang="en-US"/>
           </a:p>
@@ -1009,7 +1013,7 @@
           <a:p>
             <a:fld id="{07558649-2619-44F9-8F30-2D6466E57529}" type="datetimeFigureOut">
               <a:rPr lang="en-US" smtClean="0"/>
-              <a:t>8/27/2020</a:t>
+              <a:t>9/3/2020</a:t>
             </a:fld>
             <a:endParaRPr lang="en-US"/>
           </a:p>
@@ -1179,7 +1183,7 @@
           <a:p>
             <a:fld id="{07558649-2619-44F9-8F30-2D6466E57529}" type="datetimeFigureOut">
               <a:rPr lang="en-US" smtClean="0"/>
-              <a:t>8/27/2020</a:t>
+              <a:t>9/3/2020</a:t>
             </a:fld>
             <a:endParaRPr lang="en-US"/>
           </a:p>
@@ -1425,7 +1429,7 @@
           <a:p>
             <a:fld id="{07558649-2619-44F9-8F30-2D6466E57529}" type="datetimeFigureOut">
               <a:rPr lang="en-US" smtClean="0"/>
-              <a:t>8/27/2020</a:t>
+              <a:t>9/3/2020</a:t>
             </a:fld>
             <a:endParaRPr lang="en-US"/>
           </a:p>
@@ -1713,7 +1717,7 @@
           <a:p>
             <a:fld id="{07558649-2619-44F9-8F30-2D6466E57529}" type="datetimeFigureOut">
               <a:rPr lang="en-US" smtClean="0"/>
-              <a:t>8/27/2020</a:t>
+              <a:t>9/3/2020</a:t>
             </a:fld>
             <a:endParaRPr lang="en-US"/>
           </a:p>
@@ -2135,7 +2139,7 @@
           <a:p>
             <a:fld id="{07558649-2619-44F9-8F30-2D6466E57529}" type="datetimeFigureOut">
               <a:rPr lang="en-US" smtClean="0"/>
-              <a:t>8/27/2020</a:t>
+              <a:t>9/3/2020</a:t>
             </a:fld>
             <a:endParaRPr lang="en-US"/>
           </a:p>
@@ -2253,7 +2257,7 @@
           <a:p>
             <a:fld id="{07558649-2619-44F9-8F30-2D6466E57529}" type="datetimeFigureOut">
               <a:rPr lang="en-US" smtClean="0"/>
-              <a:t>8/27/2020</a:t>
+              <a:t>9/3/2020</a:t>
             </a:fld>
             <a:endParaRPr lang="en-US"/>
           </a:p>
@@ -2348,7 +2352,7 @@
           <a:p>
             <a:fld id="{07558649-2619-44F9-8F30-2D6466E57529}" type="datetimeFigureOut">
               <a:rPr lang="en-US" smtClean="0"/>
-              <a:t>8/27/2020</a:t>
+              <a:t>9/3/2020</a:t>
             </a:fld>
             <a:endParaRPr lang="en-US"/>
           </a:p>
@@ -2625,7 +2629,7 @@
           <a:p>
             <a:fld id="{07558649-2619-44F9-8F30-2D6466E57529}" type="datetimeFigureOut">
               <a:rPr lang="en-US" smtClean="0"/>
-              <a:t>8/27/2020</a:t>
+              <a:t>9/3/2020</a:t>
             </a:fld>
             <a:endParaRPr lang="en-US"/>
           </a:p>
@@ -2878,7 +2882,7 @@
           <a:p>
             <a:fld id="{07558649-2619-44F9-8F30-2D6466E57529}" type="datetimeFigureOut">
               <a:rPr lang="en-US" smtClean="0"/>
-              <a:t>8/27/2020</a:t>
+              <a:t>9/3/2020</a:t>
             </a:fld>
             <a:endParaRPr lang="en-US"/>
           </a:p>
@@ -3100,7 +3104,7 @@
           <a:p>
             <a:fld id="{07558649-2619-44F9-8F30-2D6466E57529}" type="datetimeFigureOut">
               <a:rPr lang="en-US" smtClean="0"/>
-              <a:t>8/27/2020</a:t>
+              <a:t>9/3/2020</a:t>
             </a:fld>
             <a:endParaRPr lang="en-US"/>
           </a:p>
@@ -3514,16 +3518,22 @@
           </a:lstStyle>
           <a:p>
             <a:r>
+              <a:rPr lang="es-MX" b="1" dirty="0" smtClean="0">
+                <a:latin typeface="Century Gothic" panose="020B0502020202020204" pitchFamily="34" charset="0"/>
+              </a:rPr>
+              <a:t>2</a:t>
+            </a:r>
+            <a:r>
               <a:rPr lang="es-MX" b="1" dirty="0">
                 <a:latin typeface="Century Gothic" panose="020B0502020202020204" pitchFamily="34" charset="0"/>
               </a:rPr>
-              <a:t>2</a:t>
+              <a:t>8</a:t>
             </a:r>
             <a:r>
               <a:rPr lang="es-MX" b="1" dirty="0" smtClean="0">
                 <a:latin typeface="Century Gothic" panose="020B0502020202020204" pitchFamily="34" charset="0"/>
               </a:rPr>
-              <a:t>1/08/2020 </a:t>
+              <a:t>/08/2020 </a:t>
             </a:r>
             <a:r>
               <a:rPr lang="es-MX" b="1" dirty="0" smtClean="0">
@@ -3535,7 +3545,13 @@
               <a:rPr lang="es-MX" b="1" dirty="0" smtClean="0">
                 <a:latin typeface="Century Gothic" panose="020B0502020202020204" pitchFamily="34" charset="0"/>
               </a:rPr>
-              <a:t>27/08/2020</a:t>
+              <a:t>03</a:t>
+            </a:r>
+            <a:r>
+              <a:rPr lang="es-MX" b="1" dirty="0" smtClean="0">
+                <a:latin typeface="Century Gothic" panose="020B0502020202020204" pitchFamily="34" charset="0"/>
+              </a:rPr>
+              <a:t>/09/2020</a:t>
             </a:r>
             <a:endParaRPr lang="es-MX" dirty="0">
               <a:latin typeface="Century Gothic" panose="020B0502020202020204" pitchFamily="34" charset="0"/>
@@ -3809,6 +3825,1385 @@
         <p:spPr>
           <a:xfrm>
             <a:off x="1331640" y="1095133"/>
+            <a:ext cx="7632848" cy="461665"/>
+          </a:xfrm>
+          <a:prstGeom prst="rect">
+            <a:avLst/>
+          </a:prstGeom>
+        </p:spPr>
+        <p:txBody>
+          <a:bodyPr wrap="square">
+            <a:spAutoFit/>
+          </a:bodyPr>
+          <a:lstStyle/>
+          <a:p>
+            <a:pPr>
+              <a:buFont typeface="Arial" panose="020B0604020202020204" pitchFamily="34" charset="0"/>
+              <a:buChar char="•"/>
+            </a:pPr>
+            <a:r>
+              <a:rPr lang="es-ES" sz="1200" b="0" i="0" dirty="0" smtClean="0">
+                <a:solidFill>
+                  <a:srgbClr val="222222"/>
+                </a:solidFill>
+                <a:effectLst/>
+                <a:latin typeface="Segoe UI" panose="020B0502040204020203" pitchFamily="34" charset="0"/>
+              </a:rPr>
+              <a:t> </a:t>
+            </a:r>
+            <a:r>
+              <a:rPr lang="es-ES" sz="1200" b="0" i="0" dirty="0" smtClean="0">
+                <a:solidFill>
+                  <a:srgbClr val="222222"/>
+                </a:solidFill>
+                <a:effectLst/>
+                <a:latin typeface="Segoe UI" panose="020B0502040204020203" pitchFamily="34" charset="0"/>
+              </a:rPr>
+              <a:t>Se modifico</a:t>
+            </a:r>
+            <a:r>
+              <a:rPr lang="es-ES" sz="1200" dirty="0" smtClean="0">
+                <a:solidFill>
+                  <a:srgbClr val="222222"/>
+                </a:solidFill>
+                <a:latin typeface="Segoe UI" panose="020B0502040204020203" pitchFamily="34" charset="0"/>
+              </a:rPr>
+              <a:t> </a:t>
+            </a:r>
+            <a:r>
+              <a:rPr lang="es-ES" sz="1200" dirty="0" smtClean="0">
+                <a:solidFill>
+                  <a:srgbClr val="222222"/>
+                </a:solidFill>
+                <a:latin typeface="Segoe UI" panose="020B0502040204020203" pitchFamily="34" charset="0"/>
+              </a:rPr>
+              <a:t>Ficha para </a:t>
+            </a:r>
+            <a:r>
+              <a:rPr lang="es-ES" sz="1200" dirty="0" smtClean="0">
+                <a:solidFill>
+                  <a:srgbClr val="222222"/>
+                </a:solidFill>
+                <a:latin typeface="Segoe UI" panose="020B0502040204020203" pitchFamily="34" charset="0"/>
+              </a:rPr>
+              <a:t>la</a:t>
+            </a:r>
+            <a:r>
+              <a:rPr lang="es-ES" sz="1200" dirty="0" smtClean="0">
+                <a:solidFill>
+                  <a:srgbClr val="222222"/>
+                </a:solidFill>
+                <a:latin typeface="Segoe UI" panose="020B0502040204020203" pitchFamily="34" charset="0"/>
+              </a:rPr>
+              <a:t> captura de los porcentajes que tendrá la inspección y cada una de las opciones así como la sumatoria de los porcentajes para el numero de parte.</a:t>
+            </a:r>
+            <a:endParaRPr lang="es-ES" sz="1200" b="0" i="0" dirty="0">
+              <a:solidFill>
+                <a:srgbClr val="222222"/>
+              </a:solidFill>
+              <a:effectLst/>
+              <a:latin typeface="Segoe UI" panose="020B0502040204020203" pitchFamily="34" charset="0"/>
+            </a:endParaRPr>
+          </a:p>
+        </p:txBody>
+      </p:sp>
+      <p:pic>
+        <p:nvPicPr>
+          <p:cNvPr id="1027" name="Picture 3" descr="C:\Users\Francisco Esteban\Documents\CONTROL_QUALITY\imagenes\FICHA_V2.png"/>
+          <p:cNvPicPr>
+            <a:picLocks noChangeAspect="1" noChangeArrowheads="1"/>
+          </p:cNvPicPr>
+          <p:nvPr/>
+        </p:nvPicPr>
+        <p:blipFill>
+          <a:blip r:embed="rId2">
+            <a:extLst>
+              <a:ext uri="{28A0092B-C50C-407E-A947-70E740481C1C}">
+                <a14:useLocalDpi xmlns:a14="http://schemas.microsoft.com/office/drawing/2010/main" val="0"/>
+              </a:ext>
+            </a:extLst>
+          </a:blip>
+          <a:srcRect/>
+          <a:stretch>
+            <a:fillRect/>
+          </a:stretch>
+        </p:blipFill>
+        <p:spPr bwMode="auto">
+          <a:xfrm>
+            <a:off x="1403648" y="1556792"/>
+            <a:ext cx="7416502" cy="5112568"/>
+          </a:xfrm>
+          <a:prstGeom prst="rect">
+            <a:avLst/>
+          </a:prstGeom>
+          <a:noFill/>
+          <a:extLst>
+            <a:ext uri="{909E8E84-426E-40DD-AFC4-6F175D3DCCD1}">
+              <a14:hiddenFill xmlns:a14="http://schemas.microsoft.com/office/drawing/2010/main">
+                <a:solidFill>
+                  <a:srgbClr val="FFFFFF"/>
+                </a:solidFill>
+              </a14:hiddenFill>
+            </a:ext>
+          </a:extLst>
+        </p:spPr>
+      </p:pic>
+      <p:sp>
+        <p:nvSpPr>
+          <p:cNvPr id="2" name="Rectangle 1"/>
+          <p:cNvSpPr/>
+          <p:nvPr/>
+        </p:nvSpPr>
+        <p:spPr>
+          <a:xfrm>
+            <a:off x="7020272" y="3501008"/>
+            <a:ext cx="720080" cy="311429"/>
+          </a:xfrm>
+          <a:prstGeom prst="rect">
+            <a:avLst/>
+          </a:prstGeom>
+          <a:noFill/>
+          <a:ln>
+            <a:solidFill>
+              <a:srgbClr val="FF0000"/>
+            </a:solidFill>
+          </a:ln>
+        </p:spPr>
+        <p:style>
+          <a:lnRef idx="2">
+            <a:schemeClr val="accent1">
+              <a:shade val="50000"/>
+            </a:schemeClr>
+          </a:lnRef>
+          <a:fillRef idx="1">
+            <a:schemeClr val="accent1"/>
+          </a:fillRef>
+          <a:effectRef idx="0">
+            <a:schemeClr val="accent1"/>
+          </a:effectRef>
+          <a:fontRef idx="minor">
+            <a:schemeClr val="lt1"/>
+          </a:fontRef>
+        </p:style>
+        <p:txBody>
+          <a:bodyPr rtlCol="0" anchor="ctr"/>
+          <a:lstStyle/>
+          <a:p>
+            <a:pPr algn="ctr"/>
+            <a:endParaRPr lang="en-US"/>
+          </a:p>
+        </p:txBody>
+      </p:sp>
+      <p:sp>
+        <p:nvSpPr>
+          <p:cNvPr id="9" name="Rectangle 8"/>
+          <p:cNvSpPr/>
+          <p:nvPr/>
+        </p:nvSpPr>
+        <p:spPr>
+          <a:xfrm>
+            <a:off x="1691680" y="4293096"/>
+            <a:ext cx="5328592" cy="288032"/>
+          </a:xfrm>
+          <a:prstGeom prst="rect">
+            <a:avLst/>
+          </a:prstGeom>
+          <a:noFill/>
+          <a:ln>
+            <a:solidFill>
+              <a:srgbClr val="FF0000"/>
+            </a:solidFill>
+          </a:ln>
+        </p:spPr>
+        <p:style>
+          <a:lnRef idx="2">
+            <a:schemeClr val="accent1">
+              <a:shade val="50000"/>
+            </a:schemeClr>
+          </a:lnRef>
+          <a:fillRef idx="1">
+            <a:schemeClr val="accent1"/>
+          </a:fillRef>
+          <a:effectRef idx="0">
+            <a:schemeClr val="accent1"/>
+          </a:effectRef>
+          <a:fontRef idx="minor">
+            <a:schemeClr val="lt1"/>
+          </a:fontRef>
+        </p:style>
+        <p:txBody>
+          <a:bodyPr rtlCol="0" anchor="ctr"/>
+          <a:lstStyle/>
+          <a:p>
+            <a:pPr algn="ctr"/>
+            <a:endParaRPr lang="en-US"/>
+          </a:p>
+        </p:txBody>
+      </p:sp>
+      <p:sp>
+        <p:nvSpPr>
+          <p:cNvPr id="11" name="Rectangle 10"/>
+          <p:cNvSpPr/>
+          <p:nvPr/>
+        </p:nvSpPr>
+        <p:spPr>
+          <a:xfrm>
+            <a:off x="6804248" y="4725144"/>
+            <a:ext cx="1440160" cy="216024"/>
+          </a:xfrm>
+          <a:prstGeom prst="rect">
+            <a:avLst/>
+          </a:prstGeom>
+          <a:noFill/>
+          <a:ln>
+            <a:solidFill>
+              <a:srgbClr val="FF0000"/>
+            </a:solidFill>
+          </a:ln>
+        </p:spPr>
+        <p:style>
+          <a:lnRef idx="2">
+            <a:schemeClr val="accent1">
+              <a:shade val="50000"/>
+            </a:schemeClr>
+          </a:lnRef>
+          <a:fillRef idx="1">
+            <a:schemeClr val="accent1"/>
+          </a:fillRef>
+          <a:effectRef idx="0">
+            <a:schemeClr val="accent1"/>
+          </a:effectRef>
+          <a:fontRef idx="minor">
+            <a:schemeClr val="lt1"/>
+          </a:fontRef>
+        </p:style>
+        <p:txBody>
+          <a:bodyPr rtlCol="0" anchor="ctr"/>
+          <a:lstStyle/>
+          <a:p>
+            <a:pPr algn="ctr"/>
+            <a:endParaRPr lang="en-US"/>
+          </a:p>
+        </p:txBody>
+      </p:sp>
+    </p:spTree>
+    <p:extLst>
+      <p:ext uri="{BB962C8B-B14F-4D97-AF65-F5344CB8AC3E}">
+        <p14:creationId xmlns:p14="http://schemas.microsoft.com/office/powerpoint/2010/main" val="793512761"/>
+      </p:ext>
+    </p:extLst>
+  </p:cSld>
+  <p:clrMapOvr>
+    <a:masterClrMapping/>
+  </p:clrMapOvr>
+  <p:timing>
+    <p:tnLst>
+      <p:par>
+        <p:cTn id="1" dur="indefinite" restart="never" nodeType="tmRoot"/>
+      </p:par>
+    </p:tnLst>
+  </p:timing>
+</p:sld>
+</file>
+
+<file path=ppt/slides/slide3.xml><?xml version="1.0" encoding="utf-8"?>
+<p:sld xmlns:a="http://schemas.openxmlformats.org/drawingml/2006/main" xmlns:r="http://schemas.openxmlformats.org/officeDocument/2006/relationships" xmlns:p="http://schemas.openxmlformats.org/presentationml/2006/main">
+  <p:cSld>
+    <p:spTree>
+      <p:nvGrpSpPr>
+        <p:cNvPr id="1" name=""/>
+        <p:cNvGrpSpPr/>
+        <p:nvPr/>
+      </p:nvGrpSpPr>
+      <p:grpSpPr>
+        <a:xfrm>
+          <a:off x="0" y="0"/>
+          <a:ext cx="0" cy="0"/>
+          <a:chOff x="0" y="0"/>
+          <a:chExt cx="0" cy="0"/>
+        </a:xfrm>
+      </p:grpSpPr>
+      <p:sp>
+        <p:nvSpPr>
+          <p:cNvPr id="8" name="Title 1"/>
+          <p:cNvSpPr txBox="1">
+            <a:spLocks/>
+          </p:cNvSpPr>
+          <p:nvPr/>
+        </p:nvSpPr>
+        <p:spPr>
+          <a:xfrm>
+            <a:off x="1087408" y="274638"/>
+            <a:ext cx="7229008" cy="634082"/>
+          </a:xfrm>
+          <a:prstGeom prst="rect">
+            <a:avLst/>
+          </a:prstGeom>
+        </p:spPr>
+        <p:txBody>
+          <a:bodyPr/>
+          <a:lstStyle>
+            <a:lvl1pPr algn="ctr" defTabSz="914400" rtl="0" eaLnBrk="1" latinLnBrk="0" hangingPunct="1">
+              <a:spcBef>
+                <a:spcPct val="0"/>
+              </a:spcBef>
+              <a:buNone/>
+              <a:defRPr sz="4400" kern="1200">
+                <a:solidFill>
+                  <a:schemeClr val="tx1"/>
+                </a:solidFill>
+                <a:latin typeface="+mj-lt"/>
+                <a:ea typeface="+mj-ea"/>
+                <a:cs typeface="+mj-cs"/>
+              </a:defRPr>
+            </a:lvl1pPr>
+          </a:lstStyle>
+          <a:p>
+            <a:pPr algn="l"/>
+            <a:r>
+              <a:rPr lang="es-ES" sz="2000" dirty="0" smtClean="0">
+                <a:solidFill>
+                  <a:srgbClr val="3F1900"/>
+                </a:solidFill>
+              </a:rPr>
+              <a:t>QA: Inspección de Material Recibido.</a:t>
+            </a:r>
+            <a:endParaRPr lang="en-US" sz="2000" dirty="0">
+              <a:solidFill>
+                <a:srgbClr val="3F1900"/>
+              </a:solidFill>
+            </a:endParaRPr>
+          </a:p>
+        </p:txBody>
+      </p:sp>
+      <p:sp>
+        <p:nvSpPr>
+          <p:cNvPr id="4" name="Content Placeholder 3"/>
+          <p:cNvSpPr txBox="1">
+            <a:spLocks/>
+          </p:cNvSpPr>
+          <p:nvPr/>
+        </p:nvSpPr>
+        <p:spPr>
+          <a:xfrm>
+            <a:off x="1331640" y="1196753"/>
+            <a:ext cx="7488832" cy="5137780"/>
+          </a:xfrm>
+          <a:prstGeom prst="rect">
+            <a:avLst/>
+          </a:prstGeom>
+        </p:spPr>
+        <p:txBody>
+          <a:bodyPr>
+            <a:normAutofit/>
+          </a:bodyPr>
+          <a:lstStyle>
+            <a:lvl1pPr marL="342900" indent="-342900" algn="l" defTabSz="914400" rtl="0" eaLnBrk="1" latinLnBrk="0" hangingPunct="1">
+              <a:spcBef>
+                <a:spcPct val="20000"/>
+              </a:spcBef>
+              <a:buFont typeface="Arial" panose="020B0604020202020204" pitchFamily="34" charset="0"/>
+              <a:buChar char="•"/>
+              <a:defRPr sz="3200" kern="1200">
+                <a:solidFill>
+                  <a:schemeClr val="tx1"/>
+                </a:solidFill>
+                <a:latin typeface="+mn-lt"/>
+                <a:ea typeface="+mn-ea"/>
+                <a:cs typeface="+mn-cs"/>
+              </a:defRPr>
+            </a:lvl1pPr>
+            <a:lvl2pPr marL="742950" indent="-285750" algn="l" defTabSz="914400" rtl="0" eaLnBrk="1" latinLnBrk="0" hangingPunct="1">
+              <a:spcBef>
+                <a:spcPct val="20000"/>
+              </a:spcBef>
+              <a:buFont typeface="Arial" panose="020B0604020202020204" pitchFamily="34" charset="0"/>
+              <a:buChar char="–"/>
+              <a:defRPr sz="2800" kern="1200">
+                <a:solidFill>
+                  <a:schemeClr val="tx1"/>
+                </a:solidFill>
+                <a:latin typeface="+mn-lt"/>
+                <a:ea typeface="+mn-ea"/>
+                <a:cs typeface="+mn-cs"/>
+              </a:defRPr>
+            </a:lvl2pPr>
+            <a:lvl3pPr marL="1143000" indent="-228600" algn="l" defTabSz="914400" rtl="0" eaLnBrk="1" latinLnBrk="0" hangingPunct="1">
+              <a:spcBef>
+                <a:spcPct val="20000"/>
+              </a:spcBef>
+              <a:buFont typeface="Arial" panose="020B0604020202020204" pitchFamily="34" charset="0"/>
+              <a:buChar char="•"/>
+              <a:defRPr sz="2400" kern="1200">
+                <a:solidFill>
+                  <a:schemeClr val="tx1"/>
+                </a:solidFill>
+                <a:latin typeface="+mn-lt"/>
+                <a:ea typeface="+mn-ea"/>
+                <a:cs typeface="+mn-cs"/>
+              </a:defRPr>
+            </a:lvl3pPr>
+            <a:lvl4pPr marL="1600200" indent="-228600" algn="l" defTabSz="914400" rtl="0" eaLnBrk="1" latinLnBrk="0" hangingPunct="1">
+              <a:spcBef>
+                <a:spcPct val="20000"/>
+              </a:spcBef>
+              <a:buFont typeface="Arial" panose="020B0604020202020204" pitchFamily="34" charset="0"/>
+              <a:buChar char="–"/>
+              <a:defRPr sz="2000" kern="1200">
+                <a:solidFill>
+                  <a:schemeClr val="tx1"/>
+                </a:solidFill>
+                <a:latin typeface="+mn-lt"/>
+                <a:ea typeface="+mn-ea"/>
+                <a:cs typeface="+mn-cs"/>
+              </a:defRPr>
+            </a:lvl4pPr>
+            <a:lvl5pPr marL="2057400" indent="-228600" algn="l" defTabSz="914400" rtl="0" eaLnBrk="1" latinLnBrk="0" hangingPunct="1">
+              <a:spcBef>
+                <a:spcPct val="20000"/>
+              </a:spcBef>
+              <a:buFont typeface="Arial" panose="020B0604020202020204" pitchFamily="34" charset="0"/>
+              <a:buChar char="»"/>
+              <a:defRPr sz="2000" kern="1200">
+                <a:solidFill>
+                  <a:schemeClr val="tx1"/>
+                </a:solidFill>
+                <a:latin typeface="+mn-lt"/>
+                <a:ea typeface="+mn-ea"/>
+                <a:cs typeface="+mn-cs"/>
+              </a:defRPr>
+            </a:lvl5pPr>
+            <a:lvl6pPr marL="2514600" indent="-228600" algn="l" defTabSz="914400" rtl="0" eaLnBrk="1" latinLnBrk="0" hangingPunct="1">
+              <a:spcBef>
+                <a:spcPct val="20000"/>
+              </a:spcBef>
+              <a:buFont typeface="Arial" panose="020B0604020202020204" pitchFamily="34" charset="0"/>
+              <a:buChar char="•"/>
+              <a:defRPr sz="2000" kern="1200">
+                <a:solidFill>
+                  <a:schemeClr val="tx1"/>
+                </a:solidFill>
+                <a:latin typeface="+mn-lt"/>
+                <a:ea typeface="+mn-ea"/>
+                <a:cs typeface="+mn-cs"/>
+              </a:defRPr>
+            </a:lvl6pPr>
+            <a:lvl7pPr marL="2971800" indent="-228600" algn="l" defTabSz="914400" rtl="0" eaLnBrk="1" latinLnBrk="0" hangingPunct="1">
+              <a:spcBef>
+                <a:spcPct val="20000"/>
+              </a:spcBef>
+              <a:buFont typeface="Arial" panose="020B0604020202020204" pitchFamily="34" charset="0"/>
+              <a:buChar char="•"/>
+              <a:defRPr sz="2000" kern="1200">
+                <a:solidFill>
+                  <a:schemeClr val="tx1"/>
+                </a:solidFill>
+                <a:latin typeface="+mn-lt"/>
+                <a:ea typeface="+mn-ea"/>
+                <a:cs typeface="+mn-cs"/>
+              </a:defRPr>
+            </a:lvl7pPr>
+            <a:lvl8pPr marL="3429000" indent="-228600" algn="l" defTabSz="914400" rtl="0" eaLnBrk="1" latinLnBrk="0" hangingPunct="1">
+              <a:spcBef>
+                <a:spcPct val="20000"/>
+              </a:spcBef>
+              <a:buFont typeface="Arial" panose="020B0604020202020204" pitchFamily="34" charset="0"/>
+              <a:buChar char="•"/>
+              <a:defRPr sz="2000" kern="1200">
+                <a:solidFill>
+                  <a:schemeClr val="tx1"/>
+                </a:solidFill>
+                <a:latin typeface="+mn-lt"/>
+                <a:ea typeface="+mn-ea"/>
+                <a:cs typeface="+mn-cs"/>
+              </a:defRPr>
+            </a:lvl8pPr>
+            <a:lvl9pPr marL="3886200" indent="-228600" algn="l" defTabSz="914400" rtl="0" eaLnBrk="1" latinLnBrk="0" hangingPunct="1">
+              <a:spcBef>
+                <a:spcPct val="20000"/>
+              </a:spcBef>
+              <a:buFont typeface="Arial" panose="020B0604020202020204" pitchFamily="34" charset="0"/>
+              <a:buChar char="•"/>
+              <a:defRPr sz="2000" kern="1200">
+                <a:solidFill>
+                  <a:schemeClr val="tx1"/>
+                </a:solidFill>
+                <a:latin typeface="+mn-lt"/>
+                <a:ea typeface="+mn-ea"/>
+                <a:cs typeface="+mn-cs"/>
+              </a:defRPr>
+            </a:lvl9pPr>
+          </a:lstStyle>
+          <a:p>
+            <a:pPr marL="0" indent="0" algn="just">
+              <a:buFont typeface="Arial" panose="020B0604020202020204" pitchFamily="34" charset="0"/>
+              <a:buNone/>
+            </a:pPr>
+            <a:endParaRPr lang="en-US" sz="2000" i="1"/>
+          </a:p>
+        </p:txBody>
+      </p:sp>
+      <p:sp>
+        <p:nvSpPr>
+          <p:cNvPr id="10" name="Rectangle 9"/>
+          <p:cNvSpPr/>
+          <p:nvPr/>
+        </p:nvSpPr>
+        <p:spPr>
+          <a:xfrm>
+            <a:off x="1331640" y="1095133"/>
+            <a:ext cx="7632848" cy="461665"/>
+          </a:xfrm>
+          <a:prstGeom prst="rect">
+            <a:avLst/>
+          </a:prstGeom>
+        </p:spPr>
+        <p:txBody>
+          <a:bodyPr wrap="square">
+            <a:spAutoFit/>
+          </a:bodyPr>
+          <a:lstStyle/>
+          <a:p>
+            <a:pPr>
+              <a:buFont typeface="Arial" panose="020B0604020202020204" pitchFamily="34" charset="0"/>
+              <a:buChar char="•"/>
+            </a:pPr>
+            <a:r>
+              <a:rPr lang="es-ES" sz="1200" b="0" i="0" dirty="0" smtClean="0">
+                <a:solidFill>
+                  <a:srgbClr val="222222"/>
+                </a:solidFill>
+                <a:effectLst/>
+                <a:latin typeface="Segoe UI" panose="020B0502040204020203" pitchFamily="34" charset="0"/>
+              </a:rPr>
+              <a:t> Se </a:t>
+            </a:r>
+            <a:r>
+              <a:rPr lang="es-ES" sz="1200" dirty="0" smtClean="0">
+                <a:solidFill>
+                  <a:srgbClr val="222222"/>
+                </a:solidFill>
+                <a:latin typeface="Segoe UI" panose="020B0502040204020203" pitchFamily="34" charset="0"/>
+              </a:rPr>
+              <a:t>creo pantalla para </a:t>
+            </a:r>
+            <a:r>
+              <a:rPr lang="es-ES" sz="1200" dirty="0" smtClean="0">
+                <a:solidFill>
+                  <a:srgbClr val="222222"/>
+                </a:solidFill>
+                <a:latin typeface="Segoe UI" panose="020B0502040204020203" pitchFamily="34" charset="0"/>
+              </a:rPr>
+              <a:t>mostrar/Listar los artículos/No. Parte que contiene la orden de compra para su inspección.</a:t>
+            </a:r>
+            <a:endParaRPr lang="es-ES" sz="1200" b="0" i="0" dirty="0">
+              <a:solidFill>
+                <a:srgbClr val="222222"/>
+              </a:solidFill>
+              <a:effectLst/>
+              <a:latin typeface="Segoe UI" panose="020B0502040204020203" pitchFamily="34" charset="0"/>
+            </a:endParaRPr>
+          </a:p>
+        </p:txBody>
+      </p:sp>
+      <p:pic>
+        <p:nvPicPr>
+          <p:cNvPr id="2050" name="Picture 2" descr="C:\Users\Francisco Esteban\Documents\CONTROL_QUALITY\imagenes\LISTADO_ORDEN.png"/>
+          <p:cNvPicPr>
+            <a:picLocks noChangeAspect="1" noChangeArrowheads="1"/>
+          </p:cNvPicPr>
+          <p:nvPr/>
+        </p:nvPicPr>
+        <p:blipFill>
+          <a:blip r:embed="rId2">
+            <a:extLst>
+              <a:ext uri="{28A0092B-C50C-407E-A947-70E740481C1C}">
+                <a14:useLocalDpi xmlns:a14="http://schemas.microsoft.com/office/drawing/2010/main" val="0"/>
+              </a:ext>
+            </a:extLst>
+          </a:blip>
+          <a:srcRect/>
+          <a:stretch>
+            <a:fillRect/>
+          </a:stretch>
+        </p:blipFill>
+        <p:spPr bwMode="auto">
+          <a:xfrm>
+            <a:off x="1403648" y="1556798"/>
+            <a:ext cx="7416823" cy="5184570"/>
+          </a:xfrm>
+          <a:prstGeom prst="rect">
+            <a:avLst/>
+          </a:prstGeom>
+          <a:noFill/>
+          <a:extLst>
+            <a:ext uri="{909E8E84-426E-40DD-AFC4-6F175D3DCCD1}">
+              <a14:hiddenFill xmlns:a14="http://schemas.microsoft.com/office/drawing/2010/main">
+                <a:solidFill>
+                  <a:srgbClr val="FFFFFF"/>
+                </a:solidFill>
+              </a14:hiddenFill>
+            </a:ext>
+          </a:extLst>
+        </p:spPr>
+      </p:pic>
+    </p:spTree>
+    <p:extLst>
+      <p:ext uri="{BB962C8B-B14F-4D97-AF65-F5344CB8AC3E}">
+        <p14:creationId xmlns:p14="http://schemas.microsoft.com/office/powerpoint/2010/main" val="1651901033"/>
+      </p:ext>
+    </p:extLst>
+  </p:cSld>
+  <p:clrMapOvr>
+    <a:masterClrMapping/>
+  </p:clrMapOvr>
+  <p:timing>
+    <p:tnLst>
+      <p:par>
+        <p:cTn id="1" dur="indefinite" restart="never" nodeType="tmRoot"/>
+      </p:par>
+    </p:tnLst>
+  </p:timing>
+</p:sld>
+</file>
+
+<file path=ppt/slides/slide4.xml><?xml version="1.0" encoding="utf-8"?>
+<p:sld xmlns:a="http://schemas.openxmlformats.org/drawingml/2006/main" xmlns:r="http://schemas.openxmlformats.org/officeDocument/2006/relationships" xmlns:p="http://schemas.openxmlformats.org/presentationml/2006/main">
+  <p:cSld>
+    <p:spTree>
+      <p:nvGrpSpPr>
+        <p:cNvPr id="1" name=""/>
+        <p:cNvGrpSpPr/>
+        <p:nvPr/>
+      </p:nvGrpSpPr>
+      <p:grpSpPr>
+        <a:xfrm>
+          <a:off x="0" y="0"/>
+          <a:ext cx="0" cy="0"/>
+          <a:chOff x="0" y="0"/>
+          <a:chExt cx="0" cy="0"/>
+        </a:xfrm>
+      </p:grpSpPr>
+      <p:sp>
+        <p:nvSpPr>
+          <p:cNvPr id="8" name="Title 1"/>
+          <p:cNvSpPr txBox="1">
+            <a:spLocks/>
+          </p:cNvSpPr>
+          <p:nvPr/>
+        </p:nvSpPr>
+        <p:spPr>
+          <a:xfrm>
+            <a:off x="1087408" y="274638"/>
+            <a:ext cx="7229008" cy="634082"/>
+          </a:xfrm>
+          <a:prstGeom prst="rect">
+            <a:avLst/>
+          </a:prstGeom>
+        </p:spPr>
+        <p:txBody>
+          <a:bodyPr/>
+          <a:lstStyle>
+            <a:lvl1pPr algn="ctr" defTabSz="914400" rtl="0" eaLnBrk="1" latinLnBrk="0" hangingPunct="1">
+              <a:spcBef>
+                <a:spcPct val="0"/>
+              </a:spcBef>
+              <a:buNone/>
+              <a:defRPr sz="4400" kern="1200">
+                <a:solidFill>
+                  <a:schemeClr val="tx1"/>
+                </a:solidFill>
+                <a:latin typeface="+mj-lt"/>
+                <a:ea typeface="+mj-ea"/>
+                <a:cs typeface="+mj-cs"/>
+              </a:defRPr>
+            </a:lvl1pPr>
+          </a:lstStyle>
+          <a:p>
+            <a:pPr algn="l"/>
+            <a:r>
+              <a:rPr lang="es-ES" sz="2000" dirty="0" smtClean="0">
+                <a:solidFill>
+                  <a:srgbClr val="3F1900"/>
+                </a:solidFill>
+              </a:rPr>
+              <a:t>QA: Inspección de Material Recibido.</a:t>
+            </a:r>
+            <a:endParaRPr lang="en-US" sz="2000" dirty="0">
+              <a:solidFill>
+                <a:srgbClr val="3F1900"/>
+              </a:solidFill>
+            </a:endParaRPr>
+          </a:p>
+        </p:txBody>
+      </p:sp>
+      <p:sp>
+        <p:nvSpPr>
+          <p:cNvPr id="4" name="Content Placeholder 3"/>
+          <p:cNvSpPr txBox="1">
+            <a:spLocks/>
+          </p:cNvSpPr>
+          <p:nvPr/>
+        </p:nvSpPr>
+        <p:spPr>
+          <a:xfrm>
+            <a:off x="1331640" y="1196753"/>
+            <a:ext cx="7488832" cy="5137780"/>
+          </a:xfrm>
+          <a:prstGeom prst="rect">
+            <a:avLst/>
+          </a:prstGeom>
+        </p:spPr>
+        <p:txBody>
+          <a:bodyPr>
+            <a:normAutofit/>
+          </a:bodyPr>
+          <a:lstStyle>
+            <a:lvl1pPr marL="342900" indent="-342900" algn="l" defTabSz="914400" rtl="0" eaLnBrk="1" latinLnBrk="0" hangingPunct="1">
+              <a:spcBef>
+                <a:spcPct val="20000"/>
+              </a:spcBef>
+              <a:buFont typeface="Arial" panose="020B0604020202020204" pitchFamily="34" charset="0"/>
+              <a:buChar char="•"/>
+              <a:defRPr sz="3200" kern="1200">
+                <a:solidFill>
+                  <a:schemeClr val="tx1"/>
+                </a:solidFill>
+                <a:latin typeface="+mn-lt"/>
+                <a:ea typeface="+mn-ea"/>
+                <a:cs typeface="+mn-cs"/>
+              </a:defRPr>
+            </a:lvl1pPr>
+            <a:lvl2pPr marL="742950" indent="-285750" algn="l" defTabSz="914400" rtl="0" eaLnBrk="1" latinLnBrk="0" hangingPunct="1">
+              <a:spcBef>
+                <a:spcPct val="20000"/>
+              </a:spcBef>
+              <a:buFont typeface="Arial" panose="020B0604020202020204" pitchFamily="34" charset="0"/>
+              <a:buChar char="–"/>
+              <a:defRPr sz="2800" kern="1200">
+                <a:solidFill>
+                  <a:schemeClr val="tx1"/>
+                </a:solidFill>
+                <a:latin typeface="+mn-lt"/>
+                <a:ea typeface="+mn-ea"/>
+                <a:cs typeface="+mn-cs"/>
+              </a:defRPr>
+            </a:lvl2pPr>
+            <a:lvl3pPr marL="1143000" indent="-228600" algn="l" defTabSz="914400" rtl="0" eaLnBrk="1" latinLnBrk="0" hangingPunct="1">
+              <a:spcBef>
+                <a:spcPct val="20000"/>
+              </a:spcBef>
+              <a:buFont typeface="Arial" panose="020B0604020202020204" pitchFamily="34" charset="0"/>
+              <a:buChar char="•"/>
+              <a:defRPr sz="2400" kern="1200">
+                <a:solidFill>
+                  <a:schemeClr val="tx1"/>
+                </a:solidFill>
+                <a:latin typeface="+mn-lt"/>
+                <a:ea typeface="+mn-ea"/>
+                <a:cs typeface="+mn-cs"/>
+              </a:defRPr>
+            </a:lvl3pPr>
+            <a:lvl4pPr marL="1600200" indent="-228600" algn="l" defTabSz="914400" rtl="0" eaLnBrk="1" latinLnBrk="0" hangingPunct="1">
+              <a:spcBef>
+                <a:spcPct val="20000"/>
+              </a:spcBef>
+              <a:buFont typeface="Arial" panose="020B0604020202020204" pitchFamily="34" charset="0"/>
+              <a:buChar char="–"/>
+              <a:defRPr sz="2000" kern="1200">
+                <a:solidFill>
+                  <a:schemeClr val="tx1"/>
+                </a:solidFill>
+                <a:latin typeface="+mn-lt"/>
+                <a:ea typeface="+mn-ea"/>
+                <a:cs typeface="+mn-cs"/>
+              </a:defRPr>
+            </a:lvl4pPr>
+            <a:lvl5pPr marL="2057400" indent="-228600" algn="l" defTabSz="914400" rtl="0" eaLnBrk="1" latinLnBrk="0" hangingPunct="1">
+              <a:spcBef>
+                <a:spcPct val="20000"/>
+              </a:spcBef>
+              <a:buFont typeface="Arial" panose="020B0604020202020204" pitchFamily="34" charset="0"/>
+              <a:buChar char="»"/>
+              <a:defRPr sz="2000" kern="1200">
+                <a:solidFill>
+                  <a:schemeClr val="tx1"/>
+                </a:solidFill>
+                <a:latin typeface="+mn-lt"/>
+                <a:ea typeface="+mn-ea"/>
+                <a:cs typeface="+mn-cs"/>
+              </a:defRPr>
+            </a:lvl5pPr>
+            <a:lvl6pPr marL="2514600" indent="-228600" algn="l" defTabSz="914400" rtl="0" eaLnBrk="1" latinLnBrk="0" hangingPunct="1">
+              <a:spcBef>
+                <a:spcPct val="20000"/>
+              </a:spcBef>
+              <a:buFont typeface="Arial" panose="020B0604020202020204" pitchFamily="34" charset="0"/>
+              <a:buChar char="•"/>
+              <a:defRPr sz="2000" kern="1200">
+                <a:solidFill>
+                  <a:schemeClr val="tx1"/>
+                </a:solidFill>
+                <a:latin typeface="+mn-lt"/>
+                <a:ea typeface="+mn-ea"/>
+                <a:cs typeface="+mn-cs"/>
+              </a:defRPr>
+            </a:lvl6pPr>
+            <a:lvl7pPr marL="2971800" indent="-228600" algn="l" defTabSz="914400" rtl="0" eaLnBrk="1" latinLnBrk="0" hangingPunct="1">
+              <a:spcBef>
+                <a:spcPct val="20000"/>
+              </a:spcBef>
+              <a:buFont typeface="Arial" panose="020B0604020202020204" pitchFamily="34" charset="0"/>
+              <a:buChar char="•"/>
+              <a:defRPr sz="2000" kern="1200">
+                <a:solidFill>
+                  <a:schemeClr val="tx1"/>
+                </a:solidFill>
+                <a:latin typeface="+mn-lt"/>
+                <a:ea typeface="+mn-ea"/>
+                <a:cs typeface="+mn-cs"/>
+              </a:defRPr>
+            </a:lvl7pPr>
+            <a:lvl8pPr marL="3429000" indent="-228600" algn="l" defTabSz="914400" rtl="0" eaLnBrk="1" latinLnBrk="0" hangingPunct="1">
+              <a:spcBef>
+                <a:spcPct val="20000"/>
+              </a:spcBef>
+              <a:buFont typeface="Arial" panose="020B0604020202020204" pitchFamily="34" charset="0"/>
+              <a:buChar char="•"/>
+              <a:defRPr sz="2000" kern="1200">
+                <a:solidFill>
+                  <a:schemeClr val="tx1"/>
+                </a:solidFill>
+                <a:latin typeface="+mn-lt"/>
+                <a:ea typeface="+mn-ea"/>
+                <a:cs typeface="+mn-cs"/>
+              </a:defRPr>
+            </a:lvl8pPr>
+            <a:lvl9pPr marL="3886200" indent="-228600" algn="l" defTabSz="914400" rtl="0" eaLnBrk="1" latinLnBrk="0" hangingPunct="1">
+              <a:spcBef>
+                <a:spcPct val="20000"/>
+              </a:spcBef>
+              <a:buFont typeface="Arial" panose="020B0604020202020204" pitchFamily="34" charset="0"/>
+              <a:buChar char="•"/>
+              <a:defRPr sz="2000" kern="1200">
+                <a:solidFill>
+                  <a:schemeClr val="tx1"/>
+                </a:solidFill>
+                <a:latin typeface="+mn-lt"/>
+                <a:ea typeface="+mn-ea"/>
+                <a:cs typeface="+mn-cs"/>
+              </a:defRPr>
+            </a:lvl9pPr>
+          </a:lstStyle>
+          <a:p>
+            <a:pPr marL="0" indent="0" algn="just">
+              <a:buFont typeface="Arial" panose="020B0604020202020204" pitchFamily="34" charset="0"/>
+              <a:buNone/>
+            </a:pPr>
+            <a:endParaRPr lang="en-US" sz="2000" i="1"/>
+          </a:p>
+        </p:txBody>
+      </p:sp>
+      <p:sp>
+        <p:nvSpPr>
+          <p:cNvPr id="10" name="Rectangle 9"/>
+          <p:cNvSpPr/>
+          <p:nvPr/>
+        </p:nvSpPr>
+        <p:spPr>
+          <a:xfrm>
+            <a:off x="1331640" y="1095133"/>
+            <a:ext cx="7632848" cy="276999"/>
+          </a:xfrm>
+          <a:prstGeom prst="rect">
+            <a:avLst/>
+          </a:prstGeom>
+        </p:spPr>
+        <p:txBody>
+          <a:bodyPr wrap="square">
+            <a:spAutoFit/>
+          </a:bodyPr>
+          <a:lstStyle/>
+          <a:p>
+            <a:pPr>
+              <a:buFont typeface="Arial" panose="020B0604020202020204" pitchFamily="34" charset="0"/>
+              <a:buChar char="•"/>
+            </a:pPr>
+            <a:r>
+              <a:rPr lang="es-ES" sz="1200" b="0" i="0" dirty="0" smtClean="0">
+                <a:solidFill>
+                  <a:srgbClr val="222222"/>
+                </a:solidFill>
+                <a:effectLst/>
+                <a:latin typeface="Segoe UI" panose="020B0502040204020203" pitchFamily="34" charset="0"/>
+              </a:rPr>
+              <a:t> </a:t>
+            </a:r>
+            <a:r>
+              <a:rPr lang="es-ES" sz="1200" b="0" i="0" dirty="0" smtClean="0">
+                <a:solidFill>
+                  <a:srgbClr val="222222"/>
+                </a:solidFill>
+                <a:effectLst/>
+                <a:latin typeface="Segoe UI" panose="020B0502040204020203" pitchFamily="34" charset="0"/>
+              </a:rPr>
+              <a:t>Se </a:t>
+            </a:r>
+            <a:r>
+              <a:rPr lang="es-ES" sz="1200" dirty="0" smtClean="0">
+                <a:solidFill>
+                  <a:srgbClr val="222222"/>
+                </a:solidFill>
+                <a:latin typeface="Segoe UI" panose="020B0502040204020203" pitchFamily="34" charset="0"/>
+              </a:rPr>
+              <a:t>creo </a:t>
+            </a:r>
+            <a:r>
+              <a:rPr lang="es-ES" sz="1200" dirty="0" smtClean="0">
+                <a:solidFill>
+                  <a:srgbClr val="222222"/>
+                </a:solidFill>
+                <a:latin typeface="Segoe UI" panose="020B0502040204020203" pitchFamily="34" charset="0"/>
+              </a:rPr>
+              <a:t>Ficha </a:t>
+            </a:r>
+            <a:r>
+              <a:rPr lang="es-ES" sz="1200" dirty="0" smtClean="0">
+                <a:solidFill>
+                  <a:srgbClr val="222222"/>
+                </a:solidFill>
+                <a:latin typeface="Segoe UI" panose="020B0502040204020203" pitchFamily="34" charset="0"/>
+              </a:rPr>
+              <a:t>para </a:t>
+            </a:r>
+            <a:r>
+              <a:rPr lang="es-ES" sz="1200" dirty="0" smtClean="0">
+                <a:solidFill>
+                  <a:srgbClr val="222222"/>
+                </a:solidFill>
+                <a:latin typeface="Segoe UI" panose="020B0502040204020203" pitchFamily="34" charset="0"/>
+              </a:rPr>
+              <a:t>la</a:t>
+            </a:r>
+            <a:r>
+              <a:rPr lang="es-ES" sz="1200" dirty="0" smtClean="0">
+                <a:solidFill>
+                  <a:srgbClr val="222222"/>
+                </a:solidFill>
+                <a:latin typeface="Segoe UI" panose="020B0502040204020203" pitchFamily="34" charset="0"/>
+              </a:rPr>
+              <a:t> realización de las diferentes inspecciones para cada numero de parte en la orden.</a:t>
+            </a:r>
+            <a:endParaRPr lang="es-ES" sz="1200" b="0" i="0" dirty="0">
+              <a:solidFill>
+                <a:srgbClr val="222222"/>
+              </a:solidFill>
+              <a:effectLst/>
+              <a:latin typeface="Segoe UI" panose="020B0502040204020203" pitchFamily="34" charset="0"/>
+            </a:endParaRPr>
+          </a:p>
+        </p:txBody>
+      </p:sp>
+      <p:pic>
+        <p:nvPicPr>
+          <p:cNvPr id="3074" name="Picture 2" descr="C:\Users\Francisco Esteban\Documents\CONTROL_QUALITY\imagenes\FICHA_INSPECCION.png"/>
+          <p:cNvPicPr>
+            <a:picLocks noChangeAspect="1" noChangeArrowheads="1"/>
+          </p:cNvPicPr>
+          <p:nvPr/>
+        </p:nvPicPr>
+        <p:blipFill>
+          <a:blip r:embed="rId2">
+            <a:extLst>
+              <a:ext uri="{28A0092B-C50C-407E-A947-70E740481C1C}">
+                <a14:useLocalDpi xmlns:a14="http://schemas.microsoft.com/office/drawing/2010/main" val="0"/>
+              </a:ext>
+            </a:extLst>
+          </a:blip>
+          <a:srcRect/>
+          <a:stretch>
+            <a:fillRect/>
+          </a:stretch>
+        </p:blipFill>
+        <p:spPr bwMode="auto">
+          <a:xfrm>
+            <a:off x="1403648" y="1412777"/>
+            <a:ext cx="7488832" cy="5256584"/>
+          </a:xfrm>
+          <a:prstGeom prst="rect">
+            <a:avLst/>
+          </a:prstGeom>
+          <a:noFill/>
+          <a:extLst>
+            <a:ext uri="{909E8E84-426E-40DD-AFC4-6F175D3DCCD1}">
+              <a14:hiddenFill xmlns:a14="http://schemas.microsoft.com/office/drawing/2010/main">
+                <a:solidFill>
+                  <a:srgbClr val="FFFFFF"/>
+                </a:solidFill>
+              </a14:hiddenFill>
+            </a:ext>
+          </a:extLst>
+        </p:spPr>
+      </p:pic>
+    </p:spTree>
+    <p:extLst>
+      <p:ext uri="{BB962C8B-B14F-4D97-AF65-F5344CB8AC3E}">
+        <p14:creationId xmlns:p14="http://schemas.microsoft.com/office/powerpoint/2010/main" val="2151361561"/>
+      </p:ext>
+    </p:extLst>
+  </p:cSld>
+  <p:clrMapOvr>
+    <a:masterClrMapping/>
+  </p:clrMapOvr>
+  <p:timing>
+    <p:tnLst>
+      <p:par>
+        <p:cTn id="1" dur="indefinite" restart="never" nodeType="tmRoot"/>
+      </p:par>
+    </p:tnLst>
+  </p:timing>
+</p:sld>
+</file>
+
+<file path=ppt/slides/slide5.xml><?xml version="1.0" encoding="utf-8"?>
+<p:sld xmlns:a="http://schemas.openxmlformats.org/drawingml/2006/main" xmlns:r="http://schemas.openxmlformats.org/officeDocument/2006/relationships" xmlns:p="http://schemas.openxmlformats.org/presentationml/2006/main">
+  <p:cSld>
+    <p:spTree>
+      <p:nvGrpSpPr>
+        <p:cNvPr id="1" name=""/>
+        <p:cNvGrpSpPr/>
+        <p:nvPr/>
+      </p:nvGrpSpPr>
+      <p:grpSpPr>
+        <a:xfrm>
+          <a:off x="0" y="0"/>
+          <a:ext cx="0" cy="0"/>
+          <a:chOff x="0" y="0"/>
+          <a:chExt cx="0" cy="0"/>
+        </a:xfrm>
+      </p:grpSpPr>
+      <p:sp>
+        <p:nvSpPr>
+          <p:cNvPr id="5" name="Title 1"/>
+          <p:cNvSpPr txBox="1">
+            <a:spLocks/>
+          </p:cNvSpPr>
+          <p:nvPr/>
+        </p:nvSpPr>
+        <p:spPr>
+          <a:xfrm>
+            <a:off x="1187624" y="2564904"/>
+            <a:ext cx="7772400" cy="1470025"/>
+          </a:xfrm>
+          <a:prstGeom prst="rect">
+            <a:avLst/>
+          </a:prstGeom>
+        </p:spPr>
+        <p:txBody>
+          <a:bodyPr vert="horz" lIns="91440" tIns="45720" rIns="91440" bIns="45720" rtlCol="0" anchor="ctr">
+            <a:normAutofit/>
+          </a:bodyPr>
+          <a:lstStyle>
+            <a:lvl1pPr algn="ctr" defTabSz="914400" rtl="0" eaLnBrk="1" latinLnBrk="0" hangingPunct="1">
+              <a:spcBef>
+                <a:spcPct val="0"/>
+              </a:spcBef>
+              <a:buNone/>
+              <a:defRPr sz="4400" kern="1200">
+                <a:solidFill>
+                  <a:schemeClr val="tx1"/>
+                </a:solidFill>
+                <a:latin typeface="+mj-lt"/>
+                <a:ea typeface="+mj-ea"/>
+                <a:cs typeface="+mj-cs"/>
+              </a:defRPr>
+            </a:lvl1pPr>
+          </a:lstStyle>
+          <a:p>
+            <a:r>
+              <a:rPr lang="es-MX" b="1" dirty="0">
+                <a:latin typeface="Century Gothic" panose="020B0502020202020204" pitchFamily="34" charset="0"/>
+              </a:rPr>
+              <a:t>2</a:t>
+            </a:r>
+            <a:r>
+              <a:rPr lang="es-MX" b="1" dirty="0" smtClean="0">
+                <a:latin typeface="Century Gothic" panose="020B0502020202020204" pitchFamily="34" charset="0"/>
+              </a:rPr>
+              <a:t>1/08/2020 – 27/08/2020</a:t>
+            </a:r>
+            <a:endParaRPr lang="es-MX" dirty="0">
+              <a:latin typeface="Century Gothic" panose="020B0502020202020204" pitchFamily="34" charset="0"/>
+            </a:endParaRPr>
+          </a:p>
+        </p:txBody>
+      </p:sp>
+    </p:spTree>
+    <p:extLst>
+      <p:ext uri="{BB962C8B-B14F-4D97-AF65-F5344CB8AC3E}">
+        <p14:creationId xmlns:p14="http://schemas.microsoft.com/office/powerpoint/2010/main" val="2896469538"/>
+      </p:ext>
+    </p:extLst>
+  </p:cSld>
+  <p:clrMapOvr>
+    <a:masterClrMapping/>
+  </p:clrMapOvr>
+  <p:timing>
+    <p:tnLst>
+      <p:par>
+        <p:cTn id="1" dur="indefinite" restart="never" nodeType="tmRoot"/>
+      </p:par>
+    </p:tnLst>
+  </p:timing>
+</p:sld>
+</file>
+
+<file path=ppt/slides/slide6.xml><?xml version="1.0" encoding="utf-8"?>
+<p:sld xmlns:a="http://schemas.openxmlformats.org/drawingml/2006/main" xmlns:r="http://schemas.openxmlformats.org/officeDocument/2006/relationships" xmlns:p="http://schemas.openxmlformats.org/presentationml/2006/main">
+  <p:cSld>
+    <p:spTree>
+      <p:nvGrpSpPr>
+        <p:cNvPr id="1" name=""/>
+        <p:cNvGrpSpPr/>
+        <p:nvPr/>
+      </p:nvGrpSpPr>
+      <p:grpSpPr>
+        <a:xfrm>
+          <a:off x="0" y="0"/>
+          <a:ext cx="0" cy="0"/>
+          <a:chOff x="0" y="0"/>
+          <a:chExt cx="0" cy="0"/>
+        </a:xfrm>
+      </p:grpSpPr>
+      <p:sp>
+        <p:nvSpPr>
+          <p:cNvPr id="8" name="Title 1"/>
+          <p:cNvSpPr txBox="1">
+            <a:spLocks/>
+          </p:cNvSpPr>
+          <p:nvPr/>
+        </p:nvSpPr>
+        <p:spPr>
+          <a:xfrm>
+            <a:off x="1087408" y="274638"/>
+            <a:ext cx="7229008" cy="634082"/>
+          </a:xfrm>
+          <a:prstGeom prst="rect">
+            <a:avLst/>
+          </a:prstGeom>
+        </p:spPr>
+        <p:txBody>
+          <a:bodyPr/>
+          <a:lstStyle>
+            <a:lvl1pPr algn="ctr" defTabSz="914400" rtl="0" eaLnBrk="1" latinLnBrk="0" hangingPunct="1">
+              <a:spcBef>
+                <a:spcPct val="0"/>
+              </a:spcBef>
+              <a:buNone/>
+              <a:defRPr sz="4400" kern="1200">
+                <a:solidFill>
+                  <a:schemeClr val="tx1"/>
+                </a:solidFill>
+                <a:latin typeface="+mj-lt"/>
+                <a:ea typeface="+mj-ea"/>
+                <a:cs typeface="+mj-cs"/>
+              </a:defRPr>
+            </a:lvl1pPr>
+          </a:lstStyle>
+          <a:p>
+            <a:pPr algn="l"/>
+            <a:r>
+              <a:rPr lang="es-ES" sz="2000" dirty="0" smtClean="0">
+                <a:solidFill>
+                  <a:srgbClr val="3F1900"/>
+                </a:solidFill>
+              </a:rPr>
+              <a:t>QA: Inspección de Material Recibido.</a:t>
+            </a:r>
+            <a:endParaRPr lang="en-US" sz="2000" dirty="0">
+              <a:solidFill>
+                <a:srgbClr val="3F1900"/>
+              </a:solidFill>
+            </a:endParaRPr>
+          </a:p>
+        </p:txBody>
+      </p:sp>
+      <p:sp>
+        <p:nvSpPr>
+          <p:cNvPr id="4" name="Content Placeholder 3"/>
+          <p:cNvSpPr txBox="1">
+            <a:spLocks/>
+          </p:cNvSpPr>
+          <p:nvPr/>
+        </p:nvSpPr>
+        <p:spPr>
+          <a:xfrm>
+            <a:off x="1331640" y="1196753"/>
+            <a:ext cx="7488832" cy="5137780"/>
+          </a:xfrm>
+          <a:prstGeom prst="rect">
+            <a:avLst/>
+          </a:prstGeom>
+        </p:spPr>
+        <p:txBody>
+          <a:bodyPr>
+            <a:normAutofit/>
+          </a:bodyPr>
+          <a:lstStyle>
+            <a:lvl1pPr marL="342900" indent="-342900" algn="l" defTabSz="914400" rtl="0" eaLnBrk="1" latinLnBrk="0" hangingPunct="1">
+              <a:spcBef>
+                <a:spcPct val="20000"/>
+              </a:spcBef>
+              <a:buFont typeface="Arial" panose="020B0604020202020204" pitchFamily="34" charset="0"/>
+              <a:buChar char="•"/>
+              <a:defRPr sz="3200" kern="1200">
+                <a:solidFill>
+                  <a:schemeClr val="tx1"/>
+                </a:solidFill>
+                <a:latin typeface="+mn-lt"/>
+                <a:ea typeface="+mn-ea"/>
+                <a:cs typeface="+mn-cs"/>
+              </a:defRPr>
+            </a:lvl1pPr>
+            <a:lvl2pPr marL="742950" indent="-285750" algn="l" defTabSz="914400" rtl="0" eaLnBrk="1" latinLnBrk="0" hangingPunct="1">
+              <a:spcBef>
+                <a:spcPct val="20000"/>
+              </a:spcBef>
+              <a:buFont typeface="Arial" panose="020B0604020202020204" pitchFamily="34" charset="0"/>
+              <a:buChar char="–"/>
+              <a:defRPr sz="2800" kern="1200">
+                <a:solidFill>
+                  <a:schemeClr val="tx1"/>
+                </a:solidFill>
+                <a:latin typeface="+mn-lt"/>
+                <a:ea typeface="+mn-ea"/>
+                <a:cs typeface="+mn-cs"/>
+              </a:defRPr>
+            </a:lvl2pPr>
+            <a:lvl3pPr marL="1143000" indent="-228600" algn="l" defTabSz="914400" rtl="0" eaLnBrk="1" latinLnBrk="0" hangingPunct="1">
+              <a:spcBef>
+                <a:spcPct val="20000"/>
+              </a:spcBef>
+              <a:buFont typeface="Arial" panose="020B0604020202020204" pitchFamily="34" charset="0"/>
+              <a:buChar char="•"/>
+              <a:defRPr sz="2400" kern="1200">
+                <a:solidFill>
+                  <a:schemeClr val="tx1"/>
+                </a:solidFill>
+                <a:latin typeface="+mn-lt"/>
+                <a:ea typeface="+mn-ea"/>
+                <a:cs typeface="+mn-cs"/>
+              </a:defRPr>
+            </a:lvl3pPr>
+            <a:lvl4pPr marL="1600200" indent="-228600" algn="l" defTabSz="914400" rtl="0" eaLnBrk="1" latinLnBrk="0" hangingPunct="1">
+              <a:spcBef>
+                <a:spcPct val="20000"/>
+              </a:spcBef>
+              <a:buFont typeface="Arial" panose="020B0604020202020204" pitchFamily="34" charset="0"/>
+              <a:buChar char="–"/>
+              <a:defRPr sz="2000" kern="1200">
+                <a:solidFill>
+                  <a:schemeClr val="tx1"/>
+                </a:solidFill>
+                <a:latin typeface="+mn-lt"/>
+                <a:ea typeface="+mn-ea"/>
+                <a:cs typeface="+mn-cs"/>
+              </a:defRPr>
+            </a:lvl4pPr>
+            <a:lvl5pPr marL="2057400" indent="-228600" algn="l" defTabSz="914400" rtl="0" eaLnBrk="1" latinLnBrk="0" hangingPunct="1">
+              <a:spcBef>
+                <a:spcPct val="20000"/>
+              </a:spcBef>
+              <a:buFont typeface="Arial" panose="020B0604020202020204" pitchFamily="34" charset="0"/>
+              <a:buChar char="»"/>
+              <a:defRPr sz="2000" kern="1200">
+                <a:solidFill>
+                  <a:schemeClr val="tx1"/>
+                </a:solidFill>
+                <a:latin typeface="+mn-lt"/>
+                <a:ea typeface="+mn-ea"/>
+                <a:cs typeface="+mn-cs"/>
+              </a:defRPr>
+            </a:lvl5pPr>
+            <a:lvl6pPr marL="2514600" indent="-228600" algn="l" defTabSz="914400" rtl="0" eaLnBrk="1" latinLnBrk="0" hangingPunct="1">
+              <a:spcBef>
+                <a:spcPct val="20000"/>
+              </a:spcBef>
+              <a:buFont typeface="Arial" panose="020B0604020202020204" pitchFamily="34" charset="0"/>
+              <a:buChar char="•"/>
+              <a:defRPr sz="2000" kern="1200">
+                <a:solidFill>
+                  <a:schemeClr val="tx1"/>
+                </a:solidFill>
+                <a:latin typeface="+mn-lt"/>
+                <a:ea typeface="+mn-ea"/>
+                <a:cs typeface="+mn-cs"/>
+              </a:defRPr>
+            </a:lvl6pPr>
+            <a:lvl7pPr marL="2971800" indent="-228600" algn="l" defTabSz="914400" rtl="0" eaLnBrk="1" latinLnBrk="0" hangingPunct="1">
+              <a:spcBef>
+                <a:spcPct val="20000"/>
+              </a:spcBef>
+              <a:buFont typeface="Arial" panose="020B0604020202020204" pitchFamily="34" charset="0"/>
+              <a:buChar char="•"/>
+              <a:defRPr sz="2000" kern="1200">
+                <a:solidFill>
+                  <a:schemeClr val="tx1"/>
+                </a:solidFill>
+                <a:latin typeface="+mn-lt"/>
+                <a:ea typeface="+mn-ea"/>
+                <a:cs typeface="+mn-cs"/>
+              </a:defRPr>
+            </a:lvl7pPr>
+            <a:lvl8pPr marL="3429000" indent="-228600" algn="l" defTabSz="914400" rtl="0" eaLnBrk="1" latinLnBrk="0" hangingPunct="1">
+              <a:spcBef>
+                <a:spcPct val="20000"/>
+              </a:spcBef>
+              <a:buFont typeface="Arial" panose="020B0604020202020204" pitchFamily="34" charset="0"/>
+              <a:buChar char="•"/>
+              <a:defRPr sz="2000" kern="1200">
+                <a:solidFill>
+                  <a:schemeClr val="tx1"/>
+                </a:solidFill>
+                <a:latin typeface="+mn-lt"/>
+                <a:ea typeface="+mn-ea"/>
+                <a:cs typeface="+mn-cs"/>
+              </a:defRPr>
+            </a:lvl8pPr>
+            <a:lvl9pPr marL="3886200" indent="-228600" algn="l" defTabSz="914400" rtl="0" eaLnBrk="1" latinLnBrk="0" hangingPunct="1">
+              <a:spcBef>
+                <a:spcPct val="20000"/>
+              </a:spcBef>
+              <a:buFont typeface="Arial" panose="020B0604020202020204" pitchFamily="34" charset="0"/>
+              <a:buChar char="•"/>
+              <a:defRPr sz="2000" kern="1200">
+                <a:solidFill>
+                  <a:schemeClr val="tx1"/>
+                </a:solidFill>
+                <a:latin typeface="+mn-lt"/>
+                <a:ea typeface="+mn-ea"/>
+                <a:cs typeface="+mn-cs"/>
+              </a:defRPr>
+            </a:lvl9pPr>
+          </a:lstStyle>
+          <a:p>
+            <a:pPr marL="0" indent="0" algn="just">
+              <a:buFont typeface="Arial" panose="020B0604020202020204" pitchFamily="34" charset="0"/>
+              <a:buNone/>
+            </a:pPr>
+            <a:endParaRPr lang="en-US" sz="2000" i="1"/>
+          </a:p>
+        </p:txBody>
+      </p:sp>
+      <p:sp>
+        <p:nvSpPr>
+          <p:cNvPr id="10" name="Rectangle 9"/>
+          <p:cNvSpPr/>
+          <p:nvPr/>
+        </p:nvSpPr>
+        <p:spPr>
+          <a:xfrm>
+            <a:off x="1331640" y="1095133"/>
             <a:ext cx="7632848" cy="276999"/>
           </a:xfrm>
           <a:prstGeom prst="rect">
@@ -3915,7 +5310,7 @@
 </p:sld>
 </file>
 
-<file path=ppt/slides/slide3.xml><?xml version="1.0" encoding="utf-8"?>
+<file path=ppt/slides/slide7.xml><?xml version="1.0" encoding="utf-8"?>
 <p:sld xmlns:a="http://schemas.openxmlformats.org/drawingml/2006/main" xmlns:r="http://schemas.openxmlformats.org/officeDocument/2006/relationships" xmlns:p="http://schemas.openxmlformats.org/presentationml/2006/main">
   <p:cSld>
     <p:spTree>
@@ -4807,7 +6202,7 @@
   <a:extraClrSchemeLst/>
   <a:extLst>
     <a:ext uri="{05A4C25C-085E-4340-85A3-A5531E510DB2}">
-      <thm15:themeFamily xmlns="" xmlns:thm15="http://schemas.microsoft.com/office/thememl/2012/main" name="Office Theme" id="{62F939B6-93AF-4DB8-9C6B-D6C7DFDC589F}" vid="{4A3C46E8-61CC-4603-A589-7422A47A8E4A}"/>
+      <thm15:themeFamily xmlns:thm15="http://schemas.microsoft.com/office/thememl/2012/main" xmlns="" name="Office Theme" id="{62F939B6-93AF-4DB8-9C6B-D6C7DFDC589F}" vid="{4A3C46E8-61CC-4603-A589-7422A47A8E4A}"/>
     </a:ext>
   </a:extLst>
 </a:theme>

</xml_diff>

<commit_message>
CAMBIOS DEL DIA 09092020
</commit_message>
<xml_diff>
--- a/Docs/IT_DEV_PEARL_LEATHER_QA_INSPECCION_27082020.pptx
+++ b/Docs/IT_DEV_PEARL_LEATHER_QA_INSPECCION_27082020.pptx
@@ -5,16 +5,24 @@
     <p:sldMasterId id="2147483648" r:id="rId1"/>
   </p:sldMasterIdLst>
   <p:notesMasterIdLst>
-    <p:notesMasterId r:id="rId9"/>
+    <p:notesMasterId r:id="rId17"/>
   </p:notesMasterIdLst>
   <p:sldIdLst>
-    <p:sldId id="344" r:id="rId2"/>
-    <p:sldId id="394" r:id="rId3"/>
-    <p:sldId id="395" r:id="rId4"/>
-    <p:sldId id="396" r:id="rId5"/>
-    <p:sldId id="393" r:id="rId6"/>
-    <p:sldId id="391" r:id="rId7"/>
-    <p:sldId id="392" r:id="rId8"/>
+    <p:sldId id="397" r:id="rId2"/>
+    <p:sldId id="399" r:id="rId3"/>
+    <p:sldId id="398" r:id="rId4"/>
+    <p:sldId id="400" r:id="rId5"/>
+    <p:sldId id="401" r:id="rId6"/>
+    <p:sldId id="402" r:id="rId7"/>
+    <p:sldId id="403" r:id="rId8"/>
+    <p:sldId id="404" r:id="rId9"/>
+    <p:sldId id="344" r:id="rId10"/>
+    <p:sldId id="394" r:id="rId11"/>
+    <p:sldId id="395" r:id="rId12"/>
+    <p:sldId id="396" r:id="rId13"/>
+    <p:sldId id="393" r:id="rId14"/>
+    <p:sldId id="391" r:id="rId15"/>
+    <p:sldId id="392" r:id="rId16"/>
   </p:sldIdLst>
   <p:sldSz cx="9144000" cy="6858000" type="screen4x3"/>
   <p:notesSz cx="6858000" cy="9144000"/>
@@ -115,7 +123,7 @@
   </p:defaultTextStyle>
   <p:extLst>
     <p:ext uri="{EFAFB233-063F-42B5-8137-9DF3F51BA10A}">
-      <p15:sldGuideLst xmlns:p15="http://schemas.microsoft.com/office/powerpoint/2012/main" xmlns="">
+      <p15:sldGuideLst xmlns="" xmlns:p15="http://schemas.microsoft.com/office/powerpoint/2012/main">
         <p15:guide id="1" orient="horz" pos="2160">
           <p15:clr>
             <a:srgbClr val="A4A3A4"/>
@@ -214,7 +222,7 @@
           <a:p>
             <a:fld id="{A17B1792-3256-4E77-8442-3E205CD69EF5}" type="datetimeFigureOut">
               <a:rPr lang="en-US" smtClean="0"/>
-              <a:t>9/3/2020</a:t>
+              <a:t>9/9/2020</a:t>
             </a:fld>
             <a:endParaRPr lang="en-US"/>
           </a:p>
@@ -663,7 +671,7 @@
           <a:p>
             <a:fld id="{07558649-2619-44F9-8F30-2D6466E57529}" type="datetimeFigureOut">
               <a:rPr lang="en-US" smtClean="0"/>
-              <a:t>9/3/2020</a:t>
+              <a:t>9/9/2020</a:t>
             </a:fld>
             <a:endParaRPr lang="en-US"/>
           </a:p>
@@ -833,7 +841,7 @@
           <a:p>
             <a:fld id="{07558649-2619-44F9-8F30-2D6466E57529}" type="datetimeFigureOut">
               <a:rPr lang="en-US" smtClean="0"/>
-              <a:t>9/3/2020</a:t>
+              <a:t>9/9/2020</a:t>
             </a:fld>
             <a:endParaRPr lang="en-US"/>
           </a:p>
@@ -1013,7 +1021,7 @@
           <a:p>
             <a:fld id="{07558649-2619-44F9-8F30-2D6466E57529}" type="datetimeFigureOut">
               <a:rPr lang="en-US" smtClean="0"/>
-              <a:t>9/3/2020</a:t>
+              <a:t>9/9/2020</a:t>
             </a:fld>
             <a:endParaRPr lang="en-US"/>
           </a:p>
@@ -1183,7 +1191,7 @@
           <a:p>
             <a:fld id="{07558649-2619-44F9-8F30-2D6466E57529}" type="datetimeFigureOut">
               <a:rPr lang="en-US" smtClean="0"/>
-              <a:t>9/3/2020</a:t>
+              <a:t>9/9/2020</a:t>
             </a:fld>
             <a:endParaRPr lang="en-US"/>
           </a:p>
@@ -1429,7 +1437,7 @@
           <a:p>
             <a:fld id="{07558649-2619-44F9-8F30-2D6466E57529}" type="datetimeFigureOut">
               <a:rPr lang="en-US" smtClean="0"/>
-              <a:t>9/3/2020</a:t>
+              <a:t>9/9/2020</a:t>
             </a:fld>
             <a:endParaRPr lang="en-US"/>
           </a:p>
@@ -1717,7 +1725,7 @@
           <a:p>
             <a:fld id="{07558649-2619-44F9-8F30-2D6466E57529}" type="datetimeFigureOut">
               <a:rPr lang="en-US" smtClean="0"/>
-              <a:t>9/3/2020</a:t>
+              <a:t>9/9/2020</a:t>
             </a:fld>
             <a:endParaRPr lang="en-US"/>
           </a:p>
@@ -2139,7 +2147,7 @@
           <a:p>
             <a:fld id="{07558649-2619-44F9-8F30-2D6466E57529}" type="datetimeFigureOut">
               <a:rPr lang="en-US" smtClean="0"/>
-              <a:t>9/3/2020</a:t>
+              <a:t>9/9/2020</a:t>
             </a:fld>
             <a:endParaRPr lang="en-US"/>
           </a:p>
@@ -2257,7 +2265,7 @@
           <a:p>
             <a:fld id="{07558649-2619-44F9-8F30-2D6466E57529}" type="datetimeFigureOut">
               <a:rPr lang="en-US" smtClean="0"/>
-              <a:t>9/3/2020</a:t>
+              <a:t>9/9/2020</a:t>
             </a:fld>
             <a:endParaRPr lang="en-US"/>
           </a:p>
@@ -2352,7 +2360,7 @@
           <a:p>
             <a:fld id="{07558649-2619-44F9-8F30-2D6466E57529}" type="datetimeFigureOut">
               <a:rPr lang="en-US" smtClean="0"/>
-              <a:t>9/3/2020</a:t>
+              <a:t>9/9/2020</a:t>
             </a:fld>
             <a:endParaRPr lang="en-US"/>
           </a:p>
@@ -2629,7 +2637,7 @@
           <a:p>
             <a:fld id="{07558649-2619-44F9-8F30-2D6466E57529}" type="datetimeFigureOut">
               <a:rPr lang="en-US" smtClean="0"/>
-              <a:t>9/3/2020</a:t>
+              <a:t>9/9/2020</a:t>
             </a:fld>
             <a:endParaRPr lang="en-US"/>
           </a:p>
@@ -2882,7 +2890,7 @@
           <a:p>
             <a:fld id="{07558649-2619-44F9-8F30-2D6466E57529}" type="datetimeFigureOut">
               <a:rPr lang="en-US" smtClean="0"/>
-              <a:t>9/3/2020</a:t>
+              <a:t>9/9/2020</a:t>
             </a:fld>
             <a:endParaRPr lang="en-US"/>
           </a:p>
@@ -3104,7 +3112,7 @@
           <a:p>
             <a:fld id="{07558649-2619-44F9-8F30-2D6466E57529}" type="datetimeFigureOut">
               <a:rPr lang="en-US" smtClean="0"/>
-              <a:t>9/3/2020</a:t>
+              <a:t>9/9/2020</a:t>
             </a:fld>
             <a:endParaRPr lang="en-US"/>
           </a:p>
@@ -3521,19 +3529,13 @@
               <a:rPr lang="es-MX" b="1" dirty="0" smtClean="0">
                 <a:latin typeface="Century Gothic" panose="020B0502020202020204" pitchFamily="34" charset="0"/>
               </a:rPr>
-              <a:t>2</a:t>
-            </a:r>
-            <a:r>
-              <a:rPr lang="es-MX" b="1" dirty="0">
-                <a:latin typeface="Century Gothic" panose="020B0502020202020204" pitchFamily="34" charset="0"/>
-              </a:rPr>
-              <a:t>8</a:t>
+              <a:t>04</a:t>
             </a:r>
             <a:r>
               <a:rPr lang="es-MX" b="1" dirty="0" smtClean="0">
                 <a:latin typeface="Century Gothic" panose="020B0502020202020204" pitchFamily="34" charset="0"/>
               </a:rPr>
-              <a:t>/08/2020 </a:t>
+              <a:t>/09/2020 </a:t>
             </a:r>
             <a:r>
               <a:rPr lang="es-MX" b="1" dirty="0" smtClean="0">
@@ -3545,7 +3547,7 @@
               <a:rPr lang="es-MX" b="1" dirty="0" smtClean="0">
                 <a:latin typeface="Century Gothic" panose="020B0502020202020204" pitchFamily="34" charset="0"/>
               </a:rPr>
-              <a:t>03</a:t>
+              <a:t>10</a:t>
             </a:r>
             <a:r>
               <a:rPr lang="es-MX" b="1" dirty="0" smtClean="0">
@@ -3562,7 +3564,1998 @@
     </p:spTree>
     <p:extLst>
       <p:ext uri="{BB962C8B-B14F-4D97-AF65-F5344CB8AC3E}">
-        <p14:creationId xmlns:p14="http://schemas.microsoft.com/office/powerpoint/2010/main" val="1449075767"/>
+        <p14:creationId xmlns:p14="http://schemas.microsoft.com/office/powerpoint/2010/main" val="2159160589"/>
+      </p:ext>
+    </p:extLst>
+  </p:cSld>
+  <p:clrMapOvr>
+    <a:masterClrMapping/>
+  </p:clrMapOvr>
+  <p:timing>
+    <p:tnLst>
+      <p:par>
+        <p:cTn id="1" dur="indefinite" restart="never" nodeType="tmRoot"/>
+      </p:par>
+    </p:tnLst>
+  </p:timing>
+</p:sld>
+</file>
+
+<file path=ppt/slides/slide10.xml><?xml version="1.0" encoding="utf-8"?>
+<p:sld xmlns:a="http://schemas.openxmlformats.org/drawingml/2006/main" xmlns:r="http://schemas.openxmlformats.org/officeDocument/2006/relationships" xmlns:p="http://schemas.openxmlformats.org/presentationml/2006/main">
+  <p:cSld>
+    <p:spTree>
+      <p:nvGrpSpPr>
+        <p:cNvPr id="1" name=""/>
+        <p:cNvGrpSpPr/>
+        <p:nvPr/>
+      </p:nvGrpSpPr>
+      <p:grpSpPr>
+        <a:xfrm>
+          <a:off x="0" y="0"/>
+          <a:ext cx="0" cy="0"/>
+          <a:chOff x="0" y="0"/>
+          <a:chExt cx="0" cy="0"/>
+        </a:xfrm>
+      </p:grpSpPr>
+      <p:sp>
+        <p:nvSpPr>
+          <p:cNvPr id="8" name="Title 1"/>
+          <p:cNvSpPr txBox="1">
+            <a:spLocks/>
+          </p:cNvSpPr>
+          <p:nvPr/>
+        </p:nvSpPr>
+        <p:spPr>
+          <a:xfrm>
+            <a:off x="1087408" y="274638"/>
+            <a:ext cx="7229008" cy="634082"/>
+          </a:xfrm>
+          <a:prstGeom prst="rect">
+            <a:avLst/>
+          </a:prstGeom>
+        </p:spPr>
+        <p:txBody>
+          <a:bodyPr/>
+          <a:lstStyle>
+            <a:lvl1pPr algn="ctr" defTabSz="914400" rtl="0" eaLnBrk="1" latinLnBrk="0" hangingPunct="1">
+              <a:spcBef>
+                <a:spcPct val="0"/>
+              </a:spcBef>
+              <a:buNone/>
+              <a:defRPr sz="4400" kern="1200">
+                <a:solidFill>
+                  <a:schemeClr val="tx1"/>
+                </a:solidFill>
+                <a:latin typeface="+mj-lt"/>
+                <a:ea typeface="+mj-ea"/>
+                <a:cs typeface="+mj-cs"/>
+              </a:defRPr>
+            </a:lvl1pPr>
+          </a:lstStyle>
+          <a:p>
+            <a:pPr algn="l"/>
+            <a:r>
+              <a:rPr lang="es-ES" sz="2000" dirty="0" smtClean="0">
+                <a:solidFill>
+                  <a:srgbClr val="3F1900"/>
+                </a:solidFill>
+              </a:rPr>
+              <a:t>QA: Inspección de Material Recibido.</a:t>
+            </a:r>
+            <a:endParaRPr lang="en-US" sz="2000" dirty="0">
+              <a:solidFill>
+                <a:srgbClr val="3F1900"/>
+              </a:solidFill>
+            </a:endParaRPr>
+          </a:p>
+        </p:txBody>
+      </p:sp>
+      <p:sp>
+        <p:nvSpPr>
+          <p:cNvPr id="4" name="Content Placeholder 3"/>
+          <p:cNvSpPr txBox="1">
+            <a:spLocks/>
+          </p:cNvSpPr>
+          <p:nvPr/>
+        </p:nvSpPr>
+        <p:spPr>
+          <a:xfrm>
+            <a:off x="1331640" y="1196753"/>
+            <a:ext cx="7488832" cy="5137780"/>
+          </a:xfrm>
+          <a:prstGeom prst="rect">
+            <a:avLst/>
+          </a:prstGeom>
+        </p:spPr>
+        <p:txBody>
+          <a:bodyPr>
+            <a:normAutofit/>
+          </a:bodyPr>
+          <a:lstStyle>
+            <a:lvl1pPr marL="342900" indent="-342900" algn="l" defTabSz="914400" rtl="0" eaLnBrk="1" latinLnBrk="0" hangingPunct="1">
+              <a:spcBef>
+                <a:spcPct val="20000"/>
+              </a:spcBef>
+              <a:buFont typeface="Arial" panose="020B0604020202020204" pitchFamily="34" charset="0"/>
+              <a:buChar char="•"/>
+              <a:defRPr sz="3200" kern="1200">
+                <a:solidFill>
+                  <a:schemeClr val="tx1"/>
+                </a:solidFill>
+                <a:latin typeface="+mn-lt"/>
+                <a:ea typeface="+mn-ea"/>
+                <a:cs typeface="+mn-cs"/>
+              </a:defRPr>
+            </a:lvl1pPr>
+            <a:lvl2pPr marL="742950" indent="-285750" algn="l" defTabSz="914400" rtl="0" eaLnBrk="1" latinLnBrk="0" hangingPunct="1">
+              <a:spcBef>
+                <a:spcPct val="20000"/>
+              </a:spcBef>
+              <a:buFont typeface="Arial" panose="020B0604020202020204" pitchFamily="34" charset="0"/>
+              <a:buChar char="–"/>
+              <a:defRPr sz="2800" kern="1200">
+                <a:solidFill>
+                  <a:schemeClr val="tx1"/>
+                </a:solidFill>
+                <a:latin typeface="+mn-lt"/>
+                <a:ea typeface="+mn-ea"/>
+                <a:cs typeface="+mn-cs"/>
+              </a:defRPr>
+            </a:lvl2pPr>
+            <a:lvl3pPr marL="1143000" indent="-228600" algn="l" defTabSz="914400" rtl="0" eaLnBrk="1" latinLnBrk="0" hangingPunct="1">
+              <a:spcBef>
+                <a:spcPct val="20000"/>
+              </a:spcBef>
+              <a:buFont typeface="Arial" panose="020B0604020202020204" pitchFamily="34" charset="0"/>
+              <a:buChar char="•"/>
+              <a:defRPr sz="2400" kern="1200">
+                <a:solidFill>
+                  <a:schemeClr val="tx1"/>
+                </a:solidFill>
+                <a:latin typeface="+mn-lt"/>
+                <a:ea typeface="+mn-ea"/>
+                <a:cs typeface="+mn-cs"/>
+              </a:defRPr>
+            </a:lvl3pPr>
+            <a:lvl4pPr marL="1600200" indent="-228600" algn="l" defTabSz="914400" rtl="0" eaLnBrk="1" latinLnBrk="0" hangingPunct="1">
+              <a:spcBef>
+                <a:spcPct val="20000"/>
+              </a:spcBef>
+              <a:buFont typeface="Arial" panose="020B0604020202020204" pitchFamily="34" charset="0"/>
+              <a:buChar char="–"/>
+              <a:defRPr sz="2000" kern="1200">
+                <a:solidFill>
+                  <a:schemeClr val="tx1"/>
+                </a:solidFill>
+                <a:latin typeface="+mn-lt"/>
+                <a:ea typeface="+mn-ea"/>
+                <a:cs typeface="+mn-cs"/>
+              </a:defRPr>
+            </a:lvl4pPr>
+            <a:lvl5pPr marL="2057400" indent="-228600" algn="l" defTabSz="914400" rtl="0" eaLnBrk="1" latinLnBrk="0" hangingPunct="1">
+              <a:spcBef>
+                <a:spcPct val="20000"/>
+              </a:spcBef>
+              <a:buFont typeface="Arial" panose="020B0604020202020204" pitchFamily="34" charset="0"/>
+              <a:buChar char="»"/>
+              <a:defRPr sz="2000" kern="1200">
+                <a:solidFill>
+                  <a:schemeClr val="tx1"/>
+                </a:solidFill>
+                <a:latin typeface="+mn-lt"/>
+                <a:ea typeface="+mn-ea"/>
+                <a:cs typeface="+mn-cs"/>
+              </a:defRPr>
+            </a:lvl5pPr>
+            <a:lvl6pPr marL="2514600" indent="-228600" algn="l" defTabSz="914400" rtl="0" eaLnBrk="1" latinLnBrk="0" hangingPunct="1">
+              <a:spcBef>
+                <a:spcPct val="20000"/>
+              </a:spcBef>
+              <a:buFont typeface="Arial" panose="020B0604020202020204" pitchFamily="34" charset="0"/>
+              <a:buChar char="•"/>
+              <a:defRPr sz="2000" kern="1200">
+                <a:solidFill>
+                  <a:schemeClr val="tx1"/>
+                </a:solidFill>
+                <a:latin typeface="+mn-lt"/>
+                <a:ea typeface="+mn-ea"/>
+                <a:cs typeface="+mn-cs"/>
+              </a:defRPr>
+            </a:lvl6pPr>
+            <a:lvl7pPr marL="2971800" indent="-228600" algn="l" defTabSz="914400" rtl="0" eaLnBrk="1" latinLnBrk="0" hangingPunct="1">
+              <a:spcBef>
+                <a:spcPct val="20000"/>
+              </a:spcBef>
+              <a:buFont typeface="Arial" panose="020B0604020202020204" pitchFamily="34" charset="0"/>
+              <a:buChar char="•"/>
+              <a:defRPr sz="2000" kern="1200">
+                <a:solidFill>
+                  <a:schemeClr val="tx1"/>
+                </a:solidFill>
+                <a:latin typeface="+mn-lt"/>
+                <a:ea typeface="+mn-ea"/>
+                <a:cs typeface="+mn-cs"/>
+              </a:defRPr>
+            </a:lvl7pPr>
+            <a:lvl8pPr marL="3429000" indent="-228600" algn="l" defTabSz="914400" rtl="0" eaLnBrk="1" latinLnBrk="0" hangingPunct="1">
+              <a:spcBef>
+                <a:spcPct val="20000"/>
+              </a:spcBef>
+              <a:buFont typeface="Arial" panose="020B0604020202020204" pitchFamily="34" charset="0"/>
+              <a:buChar char="•"/>
+              <a:defRPr sz="2000" kern="1200">
+                <a:solidFill>
+                  <a:schemeClr val="tx1"/>
+                </a:solidFill>
+                <a:latin typeface="+mn-lt"/>
+                <a:ea typeface="+mn-ea"/>
+                <a:cs typeface="+mn-cs"/>
+              </a:defRPr>
+            </a:lvl8pPr>
+            <a:lvl9pPr marL="3886200" indent="-228600" algn="l" defTabSz="914400" rtl="0" eaLnBrk="1" latinLnBrk="0" hangingPunct="1">
+              <a:spcBef>
+                <a:spcPct val="20000"/>
+              </a:spcBef>
+              <a:buFont typeface="Arial" panose="020B0604020202020204" pitchFamily="34" charset="0"/>
+              <a:buChar char="•"/>
+              <a:defRPr sz="2000" kern="1200">
+                <a:solidFill>
+                  <a:schemeClr val="tx1"/>
+                </a:solidFill>
+                <a:latin typeface="+mn-lt"/>
+                <a:ea typeface="+mn-ea"/>
+                <a:cs typeface="+mn-cs"/>
+              </a:defRPr>
+            </a:lvl9pPr>
+          </a:lstStyle>
+          <a:p>
+            <a:pPr marL="0" indent="0" algn="just">
+              <a:buFont typeface="Arial" panose="020B0604020202020204" pitchFamily="34" charset="0"/>
+              <a:buNone/>
+            </a:pPr>
+            <a:endParaRPr lang="en-US" sz="2000" i="1"/>
+          </a:p>
+        </p:txBody>
+      </p:sp>
+      <p:sp>
+        <p:nvSpPr>
+          <p:cNvPr id="10" name="Rectangle 9"/>
+          <p:cNvSpPr/>
+          <p:nvPr/>
+        </p:nvSpPr>
+        <p:spPr>
+          <a:xfrm>
+            <a:off x="1331640" y="1095133"/>
+            <a:ext cx="7632848" cy="461665"/>
+          </a:xfrm>
+          <a:prstGeom prst="rect">
+            <a:avLst/>
+          </a:prstGeom>
+        </p:spPr>
+        <p:txBody>
+          <a:bodyPr wrap="square">
+            <a:spAutoFit/>
+          </a:bodyPr>
+          <a:lstStyle/>
+          <a:p>
+            <a:pPr>
+              <a:buFont typeface="Arial" panose="020B0604020202020204" pitchFamily="34" charset="0"/>
+              <a:buChar char="•"/>
+            </a:pPr>
+            <a:r>
+              <a:rPr lang="es-ES" sz="1200" b="0" i="0" dirty="0" smtClean="0">
+                <a:solidFill>
+                  <a:srgbClr val="222222"/>
+                </a:solidFill>
+                <a:effectLst/>
+                <a:latin typeface="Segoe UI" panose="020B0502040204020203" pitchFamily="34" charset="0"/>
+              </a:rPr>
+              <a:t> Se modifico</a:t>
+            </a:r>
+            <a:r>
+              <a:rPr lang="es-ES" sz="1200" dirty="0" smtClean="0">
+                <a:solidFill>
+                  <a:srgbClr val="222222"/>
+                </a:solidFill>
+                <a:latin typeface="Segoe UI" panose="020B0502040204020203" pitchFamily="34" charset="0"/>
+              </a:rPr>
+              <a:t> Ficha para la captura de los porcentajes que tendrá la inspección y cada una de las opciones así como la sumatoria de los porcentajes para el numero de parte.</a:t>
+            </a:r>
+            <a:endParaRPr lang="es-ES" sz="1200" b="0" i="0" dirty="0">
+              <a:solidFill>
+                <a:srgbClr val="222222"/>
+              </a:solidFill>
+              <a:effectLst/>
+              <a:latin typeface="Segoe UI" panose="020B0502040204020203" pitchFamily="34" charset="0"/>
+            </a:endParaRPr>
+          </a:p>
+        </p:txBody>
+      </p:sp>
+      <p:pic>
+        <p:nvPicPr>
+          <p:cNvPr id="1027" name="Picture 3" descr="C:\Users\Francisco Esteban\Documents\CONTROL_QUALITY\imagenes\FICHA_V2.png"/>
+          <p:cNvPicPr>
+            <a:picLocks noChangeAspect="1" noChangeArrowheads="1"/>
+          </p:cNvPicPr>
+          <p:nvPr/>
+        </p:nvPicPr>
+        <p:blipFill>
+          <a:blip r:embed="rId2">
+            <a:extLst>
+              <a:ext uri="{28A0092B-C50C-407E-A947-70E740481C1C}">
+                <a14:useLocalDpi xmlns:a14="http://schemas.microsoft.com/office/drawing/2010/main" val="0"/>
+              </a:ext>
+            </a:extLst>
+          </a:blip>
+          <a:srcRect/>
+          <a:stretch>
+            <a:fillRect/>
+          </a:stretch>
+        </p:blipFill>
+        <p:spPr bwMode="auto">
+          <a:xfrm>
+            <a:off x="1403648" y="1556792"/>
+            <a:ext cx="7416502" cy="5112568"/>
+          </a:xfrm>
+          <a:prstGeom prst="rect">
+            <a:avLst/>
+          </a:prstGeom>
+          <a:noFill/>
+          <a:extLst>
+            <a:ext uri="{909E8E84-426E-40DD-AFC4-6F175D3DCCD1}">
+              <a14:hiddenFill xmlns:a14="http://schemas.microsoft.com/office/drawing/2010/main">
+                <a:solidFill>
+                  <a:srgbClr val="FFFFFF"/>
+                </a:solidFill>
+              </a14:hiddenFill>
+            </a:ext>
+          </a:extLst>
+        </p:spPr>
+      </p:pic>
+      <p:sp>
+        <p:nvSpPr>
+          <p:cNvPr id="2" name="Rectangle 1"/>
+          <p:cNvSpPr/>
+          <p:nvPr/>
+        </p:nvSpPr>
+        <p:spPr>
+          <a:xfrm>
+            <a:off x="7020272" y="3501008"/>
+            <a:ext cx="720080" cy="311429"/>
+          </a:xfrm>
+          <a:prstGeom prst="rect">
+            <a:avLst/>
+          </a:prstGeom>
+          <a:noFill/>
+          <a:ln>
+            <a:solidFill>
+              <a:srgbClr val="FF0000"/>
+            </a:solidFill>
+          </a:ln>
+        </p:spPr>
+        <p:style>
+          <a:lnRef idx="2">
+            <a:schemeClr val="accent1">
+              <a:shade val="50000"/>
+            </a:schemeClr>
+          </a:lnRef>
+          <a:fillRef idx="1">
+            <a:schemeClr val="accent1"/>
+          </a:fillRef>
+          <a:effectRef idx="0">
+            <a:schemeClr val="accent1"/>
+          </a:effectRef>
+          <a:fontRef idx="minor">
+            <a:schemeClr val="lt1"/>
+          </a:fontRef>
+        </p:style>
+        <p:txBody>
+          <a:bodyPr rtlCol="0" anchor="ctr"/>
+          <a:lstStyle/>
+          <a:p>
+            <a:pPr algn="ctr"/>
+            <a:endParaRPr lang="en-US"/>
+          </a:p>
+        </p:txBody>
+      </p:sp>
+      <p:sp>
+        <p:nvSpPr>
+          <p:cNvPr id="9" name="Rectangle 8"/>
+          <p:cNvSpPr/>
+          <p:nvPr/>
+        </p:nvSpPr>
+        <p:spPr>
+          <a:xfrm>
+            <a:off x="1691680" y="4293096"/>
+            <a:ext cx="5328592" cy="288032"/>
+          </a:xfrm>
+          <a:prstGeom prst="rect">
+            <a:avLst/>
+          </a:prstGeom>
+          <a:noFill/>
+          <a:ln>
+            <a:solidFill>
+              <a:srgbClr val="FF0000"/>
+            </a:solidFill>
+          </a:ln>
+        </p:spPr>
+        <p:style>
+          <a:lnRef idx="2">
+            <a:schemeClr val="accent1">
+              <a:shade val="50000"/>
+            </a:schemeClr>
+          </a:lnRef>
+          <a:fillRef idx="1">
+            <a:schemeClr val="accent1"/>
+          </a:fillRef>
+          <a:effectRef idx="0">
+            <a:schemeClr val="accent1"/>
+          </a:effectRef>
+          <a:fontRef idx="minor">
+            <a:schemeClr val="lt1"/>
+          </a:fontRef>
+        </p:style>
+        <p:txBody>
+          <a:bodyPr rtlCol="0" anchor="ctr"/>
+          <a:lstStyle/>
+          <a:p>
+            <a:pPr algn="ctr"/>
+            <a:endParaRPr lang="en-US"/>
+          </a:p>
+        </p:txBody>
+      </p:sp>
+      <p:sp>
+        <p:nvSpPr>
+          <p:cNvPr id="11" name="Rectangle 10"/>
+          <p:cNvSpPr/>
+          <p:nvPr/>
+        </p:nvSpPr>
+        <p:spPr>
+          <a:xfrm>
+            <a:off x="6804248" y="4725144"/>
+            <a:ext cx="1440160" cy="216024"/>
+          </a:xfrm>
+          <a:prstGeom prst="rect">
+            <a:avLst/>
+          </a:prstGeom>
+          <a:noFill/>
+          <a:ln>
+            <a:solidFill>
+              <a:srgbClr val="FF0000"/>
+            </a:solidFill>
+          </a:ln>
+        </p:spPr>
+        <p:style>
+          <a:lnRef idx="2">
+            <a:schemeClr val="accent1">
+              <a:shade val="50000"/>
+            </a:schemeClr>
+          </a:lnRef>
+          <a:fillRef idx="1">
+            <a:schemeClr val="accent1"/>
+          </a:fillRef>
+          <a:effectRef idx="0">
+            <a:schemeClr val="accent1"/>
+          </a:effectRef>
+          <a:fontRef idx="minor">
+            <a:schemeClr val="lt1"/>
+          </a:fontRef>
+        </p:style>
+        <p:txBody>
+          <a:bodyPr rtlCol="0" anchor="ctr"/>
+          <a:lstStyle/>
+          <a:p>
+            <a:pPr algn="ctr"/>
+            <a:endParaRPr lang="en-US"/>
+          </a:p>
+        </p:txBody>
+      </p:sp>
+    </p:spTree>
+    <p:extLst>
+      <p:ext uri="{BB962C8B-B14F-4D97-AF65-F5344CB8AC3E}">
+        <p14:creationId xmlns:p14="http://schemas.microsoft.com/office/powerpoint/2010/main" val="793512761"/>
+      </p:ext>
+    </p:extLst>
+  </p:cSld>
+  <p:clrMapOvr>
+    <a:masterClrMapping/>
+  </p:clrMapOvr>
+  <p:timing>
+    <p:tnLst>
+      <p:par>
+        <p:cTn id="1" dur="indefinite" restart="never" nodeType="tmRoot"/>
+      </p:par>
+    </p:tnLst>
+  </p:timing>
+</p:sld>
+</file>
+
+<file path=ppt/slides/slide11.xml><?xml version="1.0" encoding="utf-8"?>
+<p:sld xmlns:a="http://schemas.openxmlformats.org/drawingml/2006/main" xmlns:r="http://schemas.openxmlformats.org/officeDocument/2006/relationships" xmlns:p="http://schemas.openxmlformats.org/presentationml/2006/main">
+  <p:cSld>
+    <p:spTree>
+      <p:nvGrpSpPr>
+        <p:cNvPr id="1" name=""/>
+        <p:cNvGrpSpPr/>
+        <p:nvPr/>
+      </p:nvGrpSpPr>
+      <p:grpSpPr>
+        <a:xfrm>
+          <a:off x="0" y="0"/>
+          <a:ext cx="0" cy="0"/>
+          <a:chOff x="0" y="0"/>
+          <a:chExt cx="0" cy="0"/>
+        </a:xfrm>
+      </p:grpSpPr>
+      <p:sp>
+        <p:nvSpPr>
+          <p:cNvPr id="8" name="Title 1"/>
+          <p:cNvSpPr txBox="1">
+            <a:spLocks/>
+          </p:cNvSpPr>
+          <p:nvPr/>
+        </p:nvSpPr>
+        <p:spPr>
+          <a:xfrm>
+            <a:off x="1087408" y="274638"/>
+            <a:ext cx="7229008" cy="634082"/>
+          </a:xfrm>
+          <a:prstGeom prst="rect">
+            <a:avLst/>
+          </a:prstGeom>
+        </p:spPr>
+        <p:txBody>
+          <a:bodyPr/>
+          <a:lstStyle>
+            <a:lvl1pPr algn="ctr" defTabSz="914400" rtl="0" eaLnBrk="1" latinLnBrk="0" hangingPunct="1">
+              <a:spcBef>
+                <a:spcPct val="0"/>
+              </a:spcBef>
+              <a:buNone/>
+              <a:defRPr sz="4400" kern="1200">
+                <a:solidFill>
+                  <a:schemeClr val="tx1"/>
+                </a:solidFill>
+                <a:latin typeface="+mj-lt"/>
+                <a:ea typeface="+mj-ea"/>
+                <a:cs typeface="+mj-cs"/>
+              </a:defRPr>
+            </a:lvl1pPr>
+          </a:lstStyle>
+          <a:p>
+            <a:pPr algn="l"/>
+            <a:r>
+              <a:rPr lang="es-ES" sz="2000" dirty="0" smtClean="0">
+                <a:solidFill>
+                  <a:srgbClr val="3F1900"/>
+                </a:solidFill>
+              </a:rPr>
+              <a:t>QA: Inspección de Material Recibido.</a:t>
+            </a:r>
+            <a:endParaRPr lang="en-US" sz="2000" dirty="0">
+              <a:solidFill>
+                <a:srgbClr val="3F1900"/>
+              </a:solidFill>
+            </a:endParaRPr>
+          </a:p>
+        </p:txBody>
+      </p:sp>
+      <p:sp>
+        <p:nvSpPr>
+          <p:cNvPr id="4" name="Content Placeholder 3"/>
+          <p:cNvSpPr txBox="1">
+            <a:spLocks/>
+          </p:cNvSpPr>
+          <p:nvPr/>
+        </p:nvSpPr>
+        <p:spPr>
+          <a:xfrm>
+            <a:off x="1331640" y="1196753"/>
+            <a:ext cx="7488832" cy="5137780"/>
+          </a:xfrm>
+          <a:prstGeom prst="rect">
+            <a:avLst/>
+          </a:prstGeom>
+        </p:spPr>
+        <p:txBody>
+          <a:bodyPr>
+            <a:normAutofit/>
+          </a:bodyPr>
+          <a:lstStyle>
+            <a:lvl1pPr marL="342900" indent="-342900" algn="l" defTabSz="914400" rtl="0" eaLnBrk="1" latinLnBrk="0" hangingPunct="1">
+              <a:spcBef>
+                <a:spcPct val="20000"/>
+              </a:spcBef>
+              <a:buFont typeface="Arial" panose="020B0604020202020204" pitchFamily="34" charset="0"/>
+              <a:buChar char="•"/>
+              <a:defRPr sz="3200" kern="1200">
+                <a:solidFill>
+                  <a:schemeClr val="tx1"/>
+                </a:solidFill>
+                <a:latin typeface="+mn-lt"/>
+                <a:ea typeface="+mn-ea"/>
+                <a:cs typeface="+mn-cs"/>
+              </a:defRPr>
+            </a:lvl1pPr>
+            <a:lvl2pPr marL="742950" indent="-285750" algn="l" defTabSz="914400" rtl="0" eaLnBrk="1" latinLnBrk="0" hangingPunct="1">
+              <a:spcBef>
+                <a:spcPct val="20000"/>
+              </a:spcBef>
+              <a:buFont typeface="Arial" panose="020B0604020202020204" pitchFamily="34" charset="0"/>
+              <a:buChar char="–"/>
+              <a:defRPr sz="2800" kern="1200">
+                <a:solidFill>
+                  <a:schemeClr val="tx1"/>
+                </a:solidFill>
+                <a:latin typeface="+mn-lt"/>
+                <a:ea typeface="+mn-ea"/>
+                <a:cs typeface="+mn-cs"/>
+              </a:defRPr>
+            </a:lvl2pPr>
+            <a:lvl3pPr marL="1143000" indent="-228600" algn="l" defTabSz="914400" rtl="0" eaLnBrk="1" latinLnBrk="0" hangingPunct="1">
+              <a:spcBef>
+                <a:spcPct val="20000"/>
+              </a:spcBef>
+              <a:buFont typeface="Arial" panose="020B0604020202020204" pitchFamily="34" charset="0"/>
+              <a:buChar char="•"/>
+              <a:defRPr sz="2400" kern="1200">
+                <a:solidFill>
+                  <a:schemeClr val="tx1"/>
+                </a:solidFill>
+                <a:latin typeface="+mn-lt"/>
+                <a:ea typeface="+mn-ea"/>
+                <a:cs typeface="+mn-cs"/>
+              </a:defRPr>
+            </a:lvl3pPr>
+            <a:lvl4pPr marL="1600200" indent="-228600" algn="l" defTabSz="914400" rtl="0" eaLnBrk="1" latinLnBrk="0" hangingPunct="1">
+              <a:spcBef>
+                <a:spcPct val="20000"/>
+              </a:spcBef>
+              <a:buFont typeface="Arial" panose="020B0604020202020204" pitchFamily="34" charset="0"/>
+              <a:buChar char="–"/>
+              <a:defRPr sz="2000" kern="1200">
+                <a:solidFill>
+                  <a:schemeClr val="tx1"/>
+                </a:solidFill>
+                <a:latin typeface="+mn-lt"/>
+                <a:ea typeface="+mn-ea"/>
+                <a:cs typeface="+mn-cs"/>
+              </a:defRPr>
+            </a:lvl4pPr>
+            <a:lvl5pPr marL="2057400" indent="-228600" algn="l" defTabSz="914400" rtl="0" eaLnBrk="1" latinLnBrk="0" hangingPunct="1">
+              <a:spcBef>
+                <a:spcPct val="20000"/>
+              </a:spcBef>
+              <a:buFont typeface="Arial" panose="020B0604020202020204" pitchFamily="34" charset="0"/>
+              <a:buChar char="»"/>
+              <a:defRPr sz="2000" kern="1200">
+                <a:solidFill>
+                  <a:schemeClr val="tx1"/>
+                </a:solidFill>
+                <a:latin typeface="+mn-lt"/>
+                <a:ea typeface="+mn-ea"/>
+                <a:cs typeface="+mn-cs"/>
+              </a:defRPr>
+            </a:lvl5pPr>
+            <a:lvl6pPr marL="2514600" indent="-228600" algn="l" defTabSz="914400" rtl="0" eaLnBrk="1" latinLnBrk="0" hangingPunct="1">
+              <a:spcBef>
+                <a:spcPct val="20000"/>
+              </a:spcBef>
+              <a:buFont typeface="Arial" panose="020B0604020202020204" pitchFamily="34" charset="0"/>
+              <a:buChar char="•"/>
+              <a:defRPr sz="2000" kern="1200">
+                <a:solidFill>
+                  <a:schemeClr val="tx1"/>
+                </a:solidFill>
+                <a:latin typeface="+mn-lt"/>
+                <a:ea typeface="+mn-ea"/>
+                <a:cs typeface="+mn-cs"/>
+              </a:defRPr>
+            </a:lvl6pPr>
+            <a:lvl7pPr marL="2971800" indent="-228600" algn="l" defTabSz="914400" rtl="0" eaLnBrk="1" latinLnBrk="0" hangingPunct="1">
+              <a:spcBef>
+                <a:spcPct val="20000"/>
+              </a:spcBef>
+              <a:buFont typeface="Arial" panose="020B0604020202020204" pitchFamily="34" charset="0"/>
+              <a:buChar char="•"/>
+              <a:defRPr sz="2000" kern="1200">
+                <a:solidFill>
+                  <a:schemeClr val="tx1"/>
+                </a:solidFill>
+                <a:latin typeface="+mn-lt"/>
+                <a:ea typeface="+mn-ea"/>
+                <a:cs typeface="+mn-cs"/>
+              </a:defRPr>
+            </a:lvl7pPr>
+            <a:lvl8pPr marL="3429000" indent="-228600" algn="l" defTabSz="914400" rtl="0" eaLnBrk="1" latinLnBrk="0" hangingPunct="1">
+              <a:spcBef>
+                <a:spcPct val="20000"/>
+              </a:spcBef>
+              <a:buFont typeface="Arial" panose="020B0604020202020204" pitchFamily="34" charset="0"/>
+              <a:buChar char="•"/>
+              <a:defRPr sz="2000" kern="1200">
+                <a:solidFill>
+                  <a:schemeClr val="tx1"/>
+                </a:solidFill>
+                <a:latin typeface="+mn-lt"/>
+                <a:ea typeface="+mn-ea"/>
+                <a:cs typeface="+mn-cs"/>
+              </a:defRPr>
+            </a:lvl8pPr>
+            <a:lvl9pPr marL="3886200" indent="-228600" algn="l" defTabSz="914400" rtl="0" eaLnBrk="1" latinLnBrk="0" hangingPunct="1">
+              <a:spcBef>
+                <a:spcPct val="20000"/>
+              </a:spcBef>
+              <a:buFont typeface="Arial" panose="020B0604020202020204" pitchFamily="34" charset="0"/>
+              <a:buChar char="•"/>
+              <a:defRPr sz="2000" kern="1200">
+                <a:solidFill>
+                  <a:schemeClr val="tx1"/>
+                </a:solidFill>
+                <a:latin typeface="+mn-lt"/>
+                <a:ea typeface="+mn-ea"/>
+                <a:cs typeface="+mn-cs"/>
+              </a:defRPr>
+            </a:lvl9pPr>
+          </a:lstStyle>
+          <a:p>
+            <a:pPr marL="0" indent="0" algn="just">
+              <a:buFont typeface="Arial" panose="020B0604020202020204" pitchFamily="34" charset="0"/>
+              <a:buNone/>
+            </a:pPr>
+            <a:endParaRPr lang="en-US" sz="2000" i="1"/>
+          </a:p>
+        </p:txBody>
+      </p:sp>
+      <p:sp>
+        <p:nvSpPr>
+          <p:cNvPr id="10" name="Rectangle 9"/>
+          <p:cNvSpPr/>
+          <p:nvPr/>
+        </p:nvSpPr>
+        <p:spPr>
+          <a:xfrm>
+            <a:off x="1331640" y="1095133"/>
+            <a:ext cx="7632848" cy="461665"/>
+          </a:xfrm>
+          <a:prstGeom prst="rect">
+            <a:avLst/>
+          </a:prstGeom>
+        </p:spPr>
+        <p:txBody>
+          <a:bodyPr wrap="square">
+            <a:spAutoFit/>
+          </a:bodyPr>
+          <a:lstStyle/>
+          <a:p>
+            <a:pPr>
+              <a:buFont typeface="Arial" panose="020B0604020202020204" pitchFamily="34" charset="0"/>
+              <a:buChar char="•"/>
+            </a:pPr>
+            <a:r>
+              <a:rPr lang="es-ES" sz="1200" b="0" i="0" dirty="0" smtClean="0">
+                <a:solidFill>
+                  <a:srgbClr val="222222"/>
+                </a:solidFill>
+                <a:effectLst/>
+                <a:latin typeface="Segoe UI" panose="020B0502040204020203" pitchFamily="34" charset="0"/>
+              </a:rPr>
+              <a:t> Se </a:t>
+            </a:r>
+            <a:r>
+              <a:rPr lang="es-ES" sz="1200" dirty="0" smtClean="0">
+                <a:solidFill>
+                  <a:srgbClr val="222222"/>
+                </a:solidFill>
+                <a:latin typeface="Segoe UI" panose="020B0502040204020203" pitchFamily="34" charset="0"/>
+              </a:rPr>
+              <a:t>creo pantalla para mostrar/Listar los artículos/No. Parte que contiene la orden de compra para su inspección.</a:t>
+            </a:r>
+            <a:endParaRPr lang="es-ES" sz="1200" b="0" i="0" dirty="0">
+              <a:solidFill>
+                <a:srgbClr val="222222"/>
+              </a:solidFill>
+              <a:effectLst/>
+              <a:latin typeface="Segoe UI" panose="020B0502040204020203" pitchFamily="34" charset="0"/>
+            </a:endParaRPr>
+          </a:p>
+        </p:txBody>
+      </p:sp>
+      <p:pic>
+        <p:nvPicPr>
+          <p:cNvPr id="2050" name="Picture 2" descr="C:\Users\Francisco Esteban\Documents\CONTROL_QUALITY\imagenes\LISTADO_ORDEN.png"/>
+          <p:cNvPicPr>
+            <a:picLocks noChangeAspect="1" noChangeArrowheads="1"/>
+          </p:cNvPicPr>
+          <p:nvPr/>
+        </p:nvPicPr>
+        <p:blipFill>
+          <a:blip r:embed="rId2">
+            <a:extLst>
+              <a:ext uri="{28A0092B-C50C-407E-A947-70E740481C1C}">
+                <a14:useLocalDpi xmlns:a14="http://schemas.microsoft.com/office/drawing/2010/main" val="0"/>
+              </a:ext>
+            </a:extLst>
+          </a:blip>
+          <a:srcRect/>
+          <a:stretch>
+            <a:fillRect/>
+          </a:stretch>
+        </p:blipFill>
+        <p:spPr bwMode="auto">
+          <a:xfrm>
+            <a:off x="1403648" y="1556798"/>
+            <a:ext cx="7416823" cy="5184570"/>
+          </a:xfrm>
+          <a:prstGeom prst="rect">
+            <a:avLst/>
+          </a:prstGeom>
+          <a:noFill/>
+          <a:extLst>
+            <a:ext uri="{909E8E84-426E-40DD-AFC4-6F175D3DCCD1}">
+              <a14:hiddenFill xmlns:a14="http://schemas.microsoft.com/office/drawing/2010/main">
+                <a:solidFill>
+                  <a:srgbClr val="FFFFFF"/>
+                </a:solidFill>
+              </a14:hiddenFill>
+            </a:ext>
+          </a:extLst>
+        </p:spPr>
+      </p:pic>
+    </p:spTree>
+    <p:extLst>
+      <p:ext uri="{BB962C8B-B14F-4D97-AF65-F5344CB8AC3E}">
+        <p14:creationId xmlns:p14="http://schemas.microsoft.com/office/powerpoint/2010/main" val="1651901033"/>
+      </p:ext>
+    </p:extLst>
+  </p:cSld>
+  <p:clrMapOvr>
+    <a:masterClrMapping/>
+  </p:clrMapOvr>
+  <p:timing>
+    <p:tnLst>
+      <p:par>
+        <p:cTn id="1" dur="indefinite" restart="never" nodeType="tmRoot"/>
+      </p:par>
+    </p:tnLst>
+  </p:timing>
+</p:sld>
+</file>
+
+<file path=ppt/slides/slide12.xml><?xml version="1.0" encoding="utf-8"?>
+<p:sld xmlns:a="http://schemas.openxmlformats.org/drawingml/2006/main" xmlns:r="http://schemas.openxmlformats.org/officeDocument/2006/relationships" xmlns:p="http://schemas.openxmlformats.org/presentationml/2006/main">
+  <p:cSld>
+    <p:spTree>
+      <p:nvGrpSpPr>
+        <p:cNvPr id="1" name=""/>
+        <p:cNvGrpSpPr/>
+        <p:nvPr/>
+      </p:nvGrpSpPr>
+      <p:grpSpPr>
+        <a:xfrm>
+          <a:off x="0" y="0"/>
+          <a:ext cx="0" cy="0"/>
+          <a:chOff x="0" y="0"/>
+          <a:chExt cx="0" cy="0"/>
+        </a:xfrm>
+      </p:grpSpPr>
+      <p:sp>
+        <p:nvSpPr>
+          <p:cNvPr id="8" name="Title 1"/>
+          <p:cNvSpPr txBox="1">
+            <a:spLocks/>
+          </p:cNvSpPr>
+          <p:nvPr/>
+        </p:nvSpPr>
+        <p:spPr>
+          <a:xfrm>
+            <a:off x="1087408" y="274638"/>
+            <a:ext cx="7229008" cy="634082"/>
+          </a:xfrm>
+          <a:prstGeom prst="rect">
+            <a:avLst/>
+          </a:prstGeom>
+        </p:spPr>
+        <p:txBody>
+          <a:bodyPr/>
+          <a:lstStyle>
+            <a:lvl1pPr algn="ctr" defTabSz="914400" rtl="0" eaLnBrk="1" latinLnBrk="0" hangingPunct="1">
+              <a:spcBef>
+                <a:spcPct val="0"/>
+              </a:spcBef>
+              <a:buNone/>
+              <a:defRPr sz="4400" kern="1200">
+                <a:solidFill>
+                  <a:schemeClr val="tx1"/>
+                </a:solidFill>
+                <a:latin typeface="+mj-lt"/>
+                <a:ea typeface="+mj-ea"/>
+                <a:cs typeface="+mj-cs"/>
+              </a:defRPr>
+            </a:lvl1pPr>
+          </a:lstStyle>
+          <a:p>
+            <a:pPr algn="l"/>
+            <a:r>
+              <a:rPr lang="es-ES" sz="2000" dirty="0" smtClean="0">
+                <a:solidFill>
+                  <a:srgbClr val="3F1900"/>
+                </a:solidFill>
+              </a:rPr>
+              <a:t>QA: Inspección de Material Recibido.</a:t>
+            </a:r>
+            <a:endParaRPr lang="en-US" sz="2000" dirty="0">
+              <a:solidFill>
+                <a:srgbClr val="3F1900"/>
+              </a:solidFill>
+            </a:endParaRPr>
+          </a:p>
+        </p:txBody>
+      </p:sp>
+      <p:sp>
+        <p:nvSpPr>
+          <p:cNvPr id="4" name="Content Placeholder 3"/>
+          <p:cNvSpPr txBox="1">
+            <a:spLocks/>
+          </p:cNvSpPr>
+          <p:nvPr/>
+        </p:nvSpPr>
+        <p:spPr>
+          <a:xfrm>
+            <a:off x="1331640" y="1196753"/>
+            <a:ext cx="7488832" cy="5137780"/>
+          </a:xfrm>
+          <a:prstGeom prst="rect">
+            <a:avLst/>
+          </a:prstGeom>
+        </p:spPr>
+        <p:txBody>
+          <a:bodyPr>
+            <a:normAutofit/>
+          </a:bodyPr>
+          <a:lstStyle>
+            <a:lvl1pPr marL="342900" indent="-342900" algn="l" defTabSz="914400" rtl="0" eaLnBrk="1" latinLnBrk="0" hangingPunct="1">
+              <a:spcBef>
+                <a:spcPct val="20000"/>
+              </a:spcBef>
+              <a:buFont typeface="Arial" panose="020B0604020202020204" pitchFamily="34" charset="0"/>
+              <a:buChar char="•"/>
+              <a:defRPr sz="3200" kern="1200">
+                <a:solidFill>
+                  <a:schemeClr val="tx1"/>
+                </a:solidFill>
+                <a:latin typeface="+mn-lt"/>
+                <a:ea typeface="+mn-ea"/>
+                <a:cs typeface="+mn-cs"/>
+              </a:defRPr>
+            </a:lvl1pPr>
+            <a:lvl2pPr marL="742950" indent="-285750" algn="l" defTabSz="914400" rtl="0" eaLnBrk="1" latinLnBrk="0" hangingPunct="1">
+              <a:spcBef>
+                <a:spcPct val="20000"/>
+              </a:spcBef>
+              <a:buFont typeface="Arial" panose="020B0604020202020204" pitchFamily="34" charset="0"/>
+              <a:buChar char="–"/>
+              <a:defRPr sz="2800" kern="1200">
+                <a:solidFill>
+                  <a:schemeClr val="tx1"/>
+                </a:solidFill>
+                <a:latin typeface="+mn-lt"/>
+                <a:ea typeface="+mn-ea"/>
+                <a:cs typeface="+mn-cs"/>
+              </a:defRPr>
+            </a:lvl2pPr>
+            <a:lvl3pPr marL="1143000" indent="-228600" algn="l" defTabSz="914400" rtl="0" eaLnBrk="1" latinLnBrk="0" hangingPunct="1">
+              <a:spcBef>
+                <a:spcPct val="20000"/>
+              </a:spcBef>
+              <a:buFont typeface="Arial" panose="020B0604020202020204" pitchFamily="34" charset="0"/>
+              <a:buChar char="•"/>
+              <a:defRPr sz="2400" kern="1200">
+                <a:solidFill>
+                  <a:schemeClr val="tx1"/>
+                </a:solidFill>
+                <a:latin typeface="+mn-lt"/>
+                <a:ea typeface="+mn-ea"/>
+                <a:cs typeface="+mn-cs"/>
+              </a:defRPr>
+            </a:lvl3pPr>
+            <a:lvl4pPr marL="1600200" indent="-228600" algn="l" defTabSz="914400" rtl="0" eaLnBrk="1" latinLnBrk="0" hangingPunct="1">
+              <a:spcBef>
+                <a:spcPct val="20000"/>
+              </a:spcBef>
+              <a:buFont typeface="Arial" panose="020B0604020202020204" pitchFamily="34" charset="0"/>
+              <a:buChar char="–"/>
+              <a:defRPr sz="2000" kern="1200">
+                <a:solidFill>
+                  <a:schemeClr val="tx1"/>
+                </a:solidFill>
+                <a:latin typeface="+mn-lt"/>
+                <a:ea typeface="+mn-ea"/>
+                <a:cs typeface="+mn-cs"/>
+              </a:defRPr>
+            </a:lvl4pPr>
+            <a:lvl5pPr marL="2057400" indent="-228600" algn="l" defTabSz="914400" rtl="0" eaLnBrk="1" latinLnBrk="0" hangingPunct="1">
+              <a:spcBef>
+                <a:spcPct val="20000"/>
+              </a:spcBef>
+              <a:buFont typeface="Arial" panose="020B0604020202020204" pitchFamily="34" charset="0"/>
+              <a:buChar char="»"/>
+              <a:defRPr sz="2000" kern="1200">
+                <a:solidFill>
+                  <a:schemeClr val="tx1"/>
+                </a:solidFill>
+                <a:latin typeface="+mn-lt"/>
+                <a:ea typeface="+mn-ea"/>
+                <a:cs typeface="+mn-cs"/>
+              </a:defRPr>
+            </a:lvl5pPr>
+            <a:lvl6pPr marL="2514600" indent="-228600" algn="l" defTabSz="914400" rtl="0" eaLnBrk="1" latinLnBrk="0" hangingPunct="1">
+              <a:spcBef>
+                <a:spcPct val="20000"/>
+              </a:spcBef>
+              <a:buFont typeface="Arial" panose="020B0604020202020204" pitchFamily="34" charset="0"/>
+              <a:buChar char="•"/>
+              <a:defRPr sz="2000" kern="1200">
+                <a:solidFill>
+                  <a:schemeClr val="tx1"/>
+                </a:solidFill>
+                <a:latin typeface="+mn-lt"/>
+                <a:ea typeface="+mn-ea"/>
+                <a:cs typeface="+mn-cs"/>
+              </a:defRPr>
+            </a:lvl6pPr>
+            <a:lvl7pPr marL="2971800" indent="-228600" algn="l" defTabSz="914400" rtl="0" eaLnBrk="1" latinLnBrk="0" hangingPunct="1">
+              <a:spcBef>
+                <a:spcPct val="20000"/>
+              </a:spcBef>
+              <a:buFont typeface="Arial" panose="020B0604020202020204" pitchFamily="34" charset="0"/>
+              <a:buChar char="•"/>
+              <a:defRPr sz="2000" kern="1200">
+                <a:solidFill>
+                  <a:schemeClr val="tx1"/>
+                </a:solidFill>
+                <a:latin typeface="+mn-lt"/>
+                <a:ea typeface="+mn-ea"/>
+                <a:cs typeface="+mn-cs"/>
+              </a:defRPr>
+            </a:lvl7pPr>
+            <a:lvl8pPr marL="3429000" indent="-228600" algn="l" defTabSz="914400" rtl="0" eaLnBrk="1" latinLnBrk="0" hangingPunct="1">
+              <a:spcBef>
+                <a:spcPct val="20000"/>
+              </a:spcBef>
+              <a:buFont typeface="Arial" panose="020B0604020202020204" pitchFamily="34" charset="0"/>
+              <a:buChar char="•"/>
+              <a:defRPr sz="2000" kern="1200">
+                <a:solidFill>
+                  <a:schemeClr val="tx1"/>
+                </a:solidFill>
+                <a:latin typeface="+mn-lt"/>
+                <a:ea typeface="+mn-ea"/>
+                <a:cs typeface="+mn-cs"/>
+              </a:defRPr>
+            </a:lvl8pPr>
+            <a:lvl9pPr marL="3886200" indent="-228600" algn="l" defTabSz="914400" rtl="0" eaLnBrk="1" latinLnBrk="0" hangingPunct="1">
+              <a:spcBef>
+                <a:spcPct val="20000"/>
+              </a:spcBef>
+              <a:buFont typeface="Arial" panose="020B0604020202020204" pitchFamily="34" charset="0"/>
+              <a:buChar char="•"/>
+              <a:defRPr sz="2000" kern="1200">
+                <a:solidFill>
+                  <a:schemeClr val="tx1"/>
+                </a:solidFill>
+                <a:latin typeface="+mn-lt"/>
+                <a:ea typeface="+mn-ea"/>
+                <a:cs typeface="+mn-cs"/>
+              </a:defRPr>
+            </a:lvl9pPr>
+          </a:lstStyle>
+          <a:p>
+            <a:pPr marL="0" indent="0" algn="just">
+              <a:buFont typeface="Arial" panose="020B0604020202020204" pitchFamily="34" charset="0"/>
+              <a:buNone/>
+            </a:pPr>
+            <a:endParaRPr lang="en-US" sz="2000" i="1"/>
+          </a:p>
+        </p:txBody>
+      </p:sp>
+      <p:sp>
+        <p:nvSpPr>
+          <p:cNvPr id="10" name="Rectangle 9"/>
+          <p:cNvSpPr/>
+          <p:nvPr/>
+        </p:nvSpPr>
+        <p:spPr>
+          <a:xfrm>
+            <a:off x="1331640" y="1095133"/>
+            <a:ext cx="7632848" cy="276999"/>
+          </a:xfrm>
+          <a:prstGeom prst="rect">
+            <a:avLst/>
+          </a:prstGeom>
+        </p:spPr>
+        <p:txBody>
+          <a:bodyPr wrap="square">
+            <a:spAutoFit/>
+          </a:bodyPr>
+          <a:lstStyle/>
+          <a:p>
+            <a:pPr>
+              <a:buFont typeface="Arial" panose="020B0604020202020204" pitchFamily="34" charset="0"/>
+              <a:buChar char="•"/>
+            </a:pPr>
+            <a:r>
+              <a:rPr lang="es-ES" sz="1200" b="0" i="0" dirty="0" smtClean="0">
+                <a:solidFill>
+                  <a:srgbClr val="222222"/>
+                </a:solidFill>
+                <a:effectLst/>
+                <a:latin typeface="Segoe UI" panose="020B0502040204020203" pitchFamily="34" charset="0"/>
+              </a:rPr>
+              <a:t> Se </a:t>
+            </a:r>
+            <a:r>
+              <a:rPr lang="es-ES" sz="1200" dirty="0" smtClean="0">
+                <a:solidFill>
+                  <a:srgbClr val="222222"/>
+                </a:solidFill>
+                <a:latin typeface="Segoe UI" panose="020B0502040204020203" pitchFamily="34" charset="0"/>
+              </a:rPr>
+              <a:t>creo Ficha para la realización de las diferentes inspecciones para cada numero de parte en la orden.</a:t>
+            </a:r>
+            <a:endParaRPr lang="es-ES" sz="1200" b="0" i="0" dirty="0">
+              <a:solidFill>
+                <a:srgbClr val="222222"/>
+              </a:solidFill>
+              <a:effectLst/>
+              <a:latin typeface="Segoe UI" panose="020B0502040204020203" pitchFamily="34" charset="0"/>
+            </a:endParaRPr>
+          </a:p>
+        </p:txBody>
+      </p:sp>
+      <p:pic>
+        <p:nvPicPr>
+          <p:cNvPr id="3074" name="Picture 2" descr="C:\Users\Francisco Esteban\Documents\CONTROL_QUALITY\imagenes\FICHA_INSPECCION.png"/>
+          <p:cNvPicPr>
+            <a:picLocks noChangeAspect="1" noChangeArrowheads="1"/>
+          </p:cNvPicPr>
+          <p:nvPr/>
+        </p:nvPicPr>
+        <p:blipFill>
+          <a:blip r:embed="rId2">
+            <a:extLst>
+              <a:ext uri="{28A0092B-C50C-407E-A947-70E740481C1C}">
+                <a14:useLocalDpi xmlns:a14="http://schemas.microsoft.com/office/drawing/2010/main" val="0"/>
+              </a:ext>
+            </a:extLst>
+          </a:blip>
+          <a:srcRect/>
+          <a:stretch>
+            <a:fillRect/>
+          </a:stretch>
+        </p:blipFill>
+        <p:spPr bwMode="auto">
+          <a:xfrm>
+            <a:off x="1403648" y="1412777"/>
+            <a:ext cx="7488832" cy="5256584"/>
+          </a:xfrm>
+          <a:prstGeom prst="rect">
+            <a:avLst/>
+          </a:prstGeom>
+          <a:noFill/>
+          <a:extLst>
+            <a:ext uri="{909E8E84-426E-40DD-AFC4-6F175D3DCCD1}">
+              <a14:hiddenFill xmlns:a14="http://schemas.microsoft.com/office/drawing/2010/main">
+                <a:solidFill>
+                  <a:srgbClr val="FFFFFF"/>
+                </a:solidFill>
+              </a14:hiddenFill>
+            </a:ext>
+          </a:extLst>
+        </p:spPr>
+      </p:pic>
+    </p:spTree>
+    <p:extLst>
+      <p:ext uri="{BB962C8B-B14F-4D97-AF65-F5344CB8AC3E}">
+        <p14:creationId xmlns:p14="http://schemas.microsoft.com/office/powerpoint/2010/main" val="2151361561"/>
+      </p:ext>
+    </p:extLst>
+  </p:cSld>
+  <p:clrMapOvr>
+    <a:masterClrMapping/>
+  </p:clrMapOvr>
+  <p:timing>
+    <p:tnLst>
+      <p:par>
+        <p:cTn id="1" dur="indefinite" restart="never" nodeType="tmRoot"/>
+      </p:par>
+    </p:tnLst>
+  </p:timing>
+</p:sld>
+</file>
+
+<file path=ppt/slides/slide13.xml><?xml version="1.0" encoding="utf-8"?>
+<p:sld xmlns:a="http://schemas.openxmlformats.org/drawingml/2006/main" xmlns:r="http://schemas.openxmlformats.org/officeDocument/2006/relationships" xmlns:p="http://schemas.openxmlformats.org/presentationml/2006/main">
+  <p:cSld>
+    <p:spTree>
+      <p:nvGrpSpPr>
+        <p:cNvPr id="1" name=""/>
+        <p:cNvGrpSpPr/>
+        <p:nvPr/>
+      </p:nvGrpSpPr>
+      <p:grpSpPr>
+        <a:xfrm>
+          <a:off x="0" y="0"/>
+          <a:ext cx="0" cy="0"/>
+          <a:chOff x="0" y="0"/>
+          <a:chExt cx="0" cy="0"/>
+        </a:xfrm>
+      </p:grpSpPr>
+      <p:sp>
+        <p:nvSpPr>
+          <p:cNvPr id="5" name="Title 1"/>
+          <p:cNvSpPr txBox="1">
+            <a:spLocks/>
+          </p:cNvSpPr>
+          <p:nvPr/>
+        </p:nvSpPr>
+        <p:spPr>
+          <a:xfrm>
+            <a:off x="1187624" y="2564904"/>
+            <a:ext cx="7772400" cy="1470025"/>
+          </a:xfrm>
+          <a:prstGeom prst="rect">
+            <a:avLst/>
+          </a:prstGeom>
+        </p:spPr>
+        <p:txBody>
+          <a:bodyPr vert="horz" lIns="91440" tIns="45720" rIns="91440" bIns="45720" rtlCol="0" anchor="ctr">
+            <a:normAutofit/>
+          </a:bodyPr>
+          <a:lstStyle>
+            <a:lvl1pPr algn="ctr" defTabSz="914400" rtl="0" eaLnBrk="1" latinLnBrk="0" hangingPunct="1">
+              <a:spcBef>
+                <a:spcPct val="0"/>
+              </a:spcBef>
+              <a:buNone/>
+              <a:defRPr sz="4400" kern="1200">
+                <a:solidFill>
+                  <a:schemeClr val="tx1"/>
+                </a:solidFill>
+                <a:latin typeface="+mj-lt"/>
+                <a:ea typeface="+mj-ea"/>
+                <a:cs typeface="+mj-cs"/>
+              </a:defRPr>
+            </a:lvl1pPr>
+          </a:lstStyle>
+          <a:p>
+            <a:r>
+              <a:rPr lang="es-MX" b="1" dirty="0">
+                <a:latin typeface="Century Gothic" panose="020B0502020202020204" pitchFamily="34" charset="0"/>
+              </a:rPr>
+              <a:t>2</a:t>
+            </a:r>
+            <a:r>
+              <a:rPr lang="es-MX" b="1" dirty="0" smtClean="0">
+                <a:latin typeface="Century Gothic" panose="020B0502020202020204" pitchFamily="34" charset="0"/>
+              </a:rPr>
+              <a:t>1/08/2020 – 27/08/2020</a:t>
+            </a:r>
+            <a:endParaRPr lang="es-MX" dirty="0">
+              <a:latin typeface="Century Gothic" panose="020B0502020202020204" pitchFamily="34" charset="0"/>
+            </a:endParaRPr>
+          </a:p>
+        </p:txBody>
+      </p:sp>
+    </p:spTree>
+    <p:extLst>
+      <p:ext uri="{BB962C8B-B14F-4D97-AF65-F5344CB8AC3E}">
+        <p14:creationId xmlns:p14="http://schemas.microsoft.com/office/powerpoint/2010/main" val="2896469538"/>
+      </p:ext>
+    </p:extLst>
+  </p:cSld>
+  <p:clrMapOvr>
+    <a:masterClrMapping/>
+  </p:clrMapOvr>
+  <p:timing>
+    <p:tnLst>
+      <p:par>
+        <p:cTn id="1" dur="indefinite" restart="never" nodeType="tmRoot"/>
+      </p:par>
+    </p:tnLst>
+  </p:timing>
+</p:sld>
+</file>
+
+<file path=ppt/slides/slide14.xml><?xml version="1.0" encoding="utf-8"?>
+<p:sld xmlns:a="http://schemas.openxmlformats.org/drawingml/2006/main" xmlns:r="http://schemas.openxmlformats.org/officeDocument/2006/relationships" xmlns:p="http://schemas.openxmlformats.org/presentationml/2006/main">
+  <p:cSld>
+    <p:spTree>
+      <p:nvGrpSpPr>
+        <p:cNvPr id="1" name=""/>
+        <p:cNvGrpSpPr/>
+        <p:nvPr/>
+      </p:nvGrpSpPr>
+      <p:grpSpPr>
+        <a:xfrm>
+          <a:off x="0" y="0"/>
+          <a:ext cx="0" cy="0"/>
+          <a:chOff x="0" y="0"/>
+          <a:chExt cx="0" cy="0"/>
+        </a:xfrm>
+      </p:grpSpPr>
+      <p:sp>
+        <p:nvSpPr>
+          <p:cNvPr id="8" name="Title 1"/>
+          <p:cNvSpPr txBox="1">
+            <a:spLocks/>
+          </p:cNvSpPr>
+          <p:nvPr/>
+        </p:nvSpPr>
+        <p:spPr>
+          <a:xfrm>
+            <a:off x="1087408" y="274638"/>
+            <a:ext cx="7229008" cy="634082"/>
+          </a:xfrm>
+          <a:prstGeom prst="rect">
+            <a:avLst/>
+          </a:prstGeom>
+        </p:spPr>
+        <p:txBody>
+          <a:bodyPr/>
+          <a:lstStyle>
+            <a:lvl1pPr algn="ctr" defTabSz="914400" rtl="0" eaLnBrk="1" latinLnBrk="0" hangingPunct="1">
+              <a:spcBef>
+                <a:spcPct val="0"/>
+              </a:spcBef>
+              <a:buNone/>
+              <a:defRPr sz="4400" kern="1200">
+                <a:solidFill>
+                  <a:schemeClr val="tx1"/>
+                </a:solidFill>
+                <a:latin typeface="+mj-lt"/>
+                <a:ea typeface="+mj-ea"/>
+                <a:cs typeface="+mj-cs"/>
+              </a:defRPr>
+            </a:lvl1pPr>
+          </a:lstStyle>
+          <a:p>
+            <a:pPr algn="l"/>
+            <a:r>
+              <a:rPr lang="es-ES" sz="2000" dirty="0" smtClean="0">
+                <a:solidFill>
+                  <a:srgbClr val="3F1900"/>
+                </a:solidFill>
+              </a:rPr>
+              <a:t>QA: Inspección de Material Recibido.</a:t>
+            </a:r>
+            <a:endParaRPr lang="en-US" sz="2000" dirty="0">
+              <a:solidFill>
+                <a:srgbClr val="3F1900"/>
+              </a:solidFill>
+            </a:endParaRPr>
+          </a:p>
+        </p:txBody>
+      </p:sp>
+      <p:sp>
+        <p:nvSpPr>
+          <p:cNvPr id="4" name="Content Placeholder 3"/>
+          <p:cNvSpPr txBox="1">
+            <a:spLocks/>
+          </p:cNvSpPr>
+          <p:nvPr/>
+        </p:nvSpPr>
+        <p:spPr>
+          <a:xfrm>
+            <a:off x="1331640" y="1196753"/>
+            <a:ext cx="7488832" cy="5137780"/>
+          </a:xfrm>
+          <a:prstGeom prst="rect">
+            <a:avLst/>
+          </a:prstGeom>
+        </p:spPr>
+        <p:txBody>
+          <a:bodyPr>
+            <a:normAutofit/>
+          </a:bodyPr>
+          <a:lstStyle>
+            <a:lvl1pPr marL="342900" indent="-342900" algn="l" defTabSz="914400" rtl="0" eaLnBrk="1" latinLnBrk="0" hangingPunct="1">
+              <a:spcBef>
+                <a:spcPct val="20000"/>
+              </a:spcBef>
+              <a:buFont typeface="Arial" panose="020B0604020202020204" pitchFamily="34" charset="0"/>
+              <a:buChar char="•"/>
+              <a:defRPr sz="3200" kern="1200">
+                <a:solidFill>
+                  <a:schemeClr val="tx1"/>
+                </a:solidFill>
+                <a:latin typeface="+mn-lt"/>
+                <a:ea typeface="+mn-ea"/>
+                <a:cs typeface="+mn-cs"/>
+              </a:defRPr>
+            </a:lvl1pPr>
+            <a:lvl2pPr marL="742950" indent="-285750" algn="l" defTabSz="914400" rtl="0" eaLnBrk="1" latinLnBrk="0" hangingPunct="1">
+              <a:spcBef>
+                <a:spcPct val="20000"/>
+              </a:spcBef>
+              <a:buFont typeface="Arial" panose="020B0604020202020204" pitchFamily="34" charset="0"/>
+              <a:buChar char="–"/>
+              <a:defRPr sz="2800" kern="1200">
+                <a:solidFill>
+                  <a:schemeClr val="tx1"/>
+                </a:solidFill>
+                <a:latin typeface="+mn-lt"/>
+                <a:ea typeface="+mn-ea"/>
+                <a:cs typeface="+mn-cs"/>
+              </a:defRPr>
+            </a:lvl2pPr>
+            <a:lvl3pPr marL="1143000" indent="-228600" algn="l" defTabSz="914400" rtl="0" eaLnBrk="1" latinLnBrk="0" hangingPunct="1">
+              <a:spcBef>
+                <a:spcPct val="20000"/>
+              </a:spcBef>
+              <a:buFont typeface="Arial" panose="020B0604020202020204" pitchFamily="34" charset="0"/>
+              <a:buChar char="•"/>
+              <a:defRPr sz="2400" kern="1200">
+                <a:solidFill>
+                  <a:schemeClr val="tx1"/>
+                </a:solidFill>
+                <a:latin typeface="+mn-lt"/>
+                <a:ea typeface="+mn-ea"/>
+                <a:cs typeface="+mn-cs"/>
+              </a:defRPr>
+            </a:lvl3pPr>
+            <a:lvl4pPr marL="1600200" indent="-228600" algn="l" defTabSz="914400" rtl="0" eaLnBrk="1" latinLnBrk="0" hangingPunct="1">
+              <a:spcBef>
+                <a:spcPct val="20000"/>
+              </a:spcBef>
+              <a:buFont typeface="Arial" panose="020B0604020202020204" pitchFamily="34" charset="0"/>
+              <a:buChar char="–"/>
+              <a:defRPr sz="2000" kern="1200">
+                <a:solidFill>
+                  <a:schemeClr val="tx1"/>
+                </a:solidFill>
+                <a:latin typeface="+mn-lt"/>
+                <a:ea typeface="+mn-ea"/>
+                <a:cs typeface="+mn-cs"/>
+              </a:defRPr>
+            </a:lvl4pPr>
+            <a:lvl5pPr marL="2057400" indent="-228600" algn="l" defTabSz="914400" rtl="0" eaLnBrk="1" latinLnBrk="0" hangingPunct="1">
+              <a:spcBef>
+                <a:spcPct val="20000"/>
+              </a:spcBef>
+              <a:buFont typeface="Arial" panose="020B0604020202020204" pitchFamily="34" charset="0"/>
+              <a:buChar char="»"/>
+              <a:defRPr sz="2000" kern="1200">
+                <a:solidFill>
+                  <a:schemeClr val="tx1"/>
+                </a:solidFill>
+                <a:latin typeface="+mn-lt"/>
+                <a:ea typeface="+mn-ea"/>
+                <a:cs typeface="+mn-cs"/>
+              </a:defRPr>
+            </a:lvl5pPr>
+            <a:lvl6pPr marL="2514600" indent="-228600" algn="l" defTabSz="914400" rtl="0" eaLnBrk="1" latinLnBrk="0" hangingPunct="1">
+              <a:spcBef>
+                <a:spcPct val="20000"/>
+              </a:spcBef>
+              <a:buFont typeface="Arial" panose="020B0604020202020204" pitchFamily="34" charset="0"/>
+              <a:buChar char="•"/>
+              <a:defRPr sz="2000" kern="1200">
+                <a:solidFill>
+                  <a:schemeClr val="tx1"/>
+                </a:solidFill>
+                <a:latin typeface="+mn-lt"/>
+                <a:ea typeface="+mn-ea"/>
+                <a:cs typeface="+mn-cs"/>
+              </a:defRPr>
+            </a:lvl6pPr>
+            <a:lvl7pPr marL="2971800" indent="-228600" algn="l" defTabSz="914400" rtl="0" eaLnBrk="1" latinLnBrk="0" hangingPunct="1">
+              <a:spcBef>
+                <a:spcPct val="20000"/>
+              </a:spcBef>
+              <a:buFont typeface="Arial" panose="020B0604020202020204" pitchFamily="34" charset="0"/>
+              <a:buChar char="•"/>
+              <a:defRPr sz="2000" kern="1200">
+                <a:solidFill>
+                  <a:schemeClr val="tx1"/>
+                </a:solidFill>
+                <a:latin typeface="+mn-lt"/>
+                <a:ea typeface="+mn-ea"/>
+                <a:cs typeface="+mn-cs"/>
+              </a:defRPr>
+            </a:lvl7pPr>
+            <a:lvl8pPr marL="3429000" indent="-228600" algn="l" defTabSz="914400" rtl="0" eaLnBrk="1" latinLnBrk="0" hangingPunct="1">
+              <a:spcBef>
+                <a:spcPct val="20000"/>
+              </a:spcBef>
+              <a:buFont typeface="Arial" panose="020B0604020202020204" pitchFamily="34" charset="0"/>
+              <a:buChar char="•"/>
+              <a:defRPr sz="2000" kern="1200">
+                <a:solidFill>
+                  <a:schemeClr val="tx1"/>
+                </a:solidFill>
+                <a:latin typeface="+mn-lt"/>
+                <a:ea typeface="+mn-ea"/>
+                <a:cs typeface="+mn-cs"/>
+              </a:defRPr>
+            </a:lvl8pPr>
+            <a:lvl9pPr marL="3886200" indent="-228600" algn="l" defTabSz="914400" rtl="0" eaLnBrk="1" latinLnBrk="0" hangingPunct="1">
+              <a:spcBef>
+                <a:spcPct val="20000"/>
+              </a:spcBef>
+              <a:buFont typeface="Arial" panose="020B0604020202020204" pitchFamily="34" charset="0"/>
+              <a:buChar char="•"/>
+              <a:defRPr sz="2000" kern="1200">
+                <a:solidFill>
+                  <a:schemeClr val="tx1"/>
+                </a:solidFill>
+                <a:latin typeface="+mn-lt"/>
+                <a:ea typeface="+mn-ea"/>
+                <a:cs typeface="+mn-cs"/>
+              </a:defRPr>
+            </a:lvl9pPr>
+          </a:lstStyle>
+          <a:p>
+            <a:pPr marL="0" indent="0" algn="just">
+              <a:buFont typeface="Arial" panose="020B0604020202020204" pitchFamily="34" charset="0"/>
+              <a:buNone/>
+            </a:pPr>
+            <a:endParaRPr lang="en-US" sz="2000" i="1"/>
+          </a:p>
+        </p:txBody>
+      </p:sp>
+      <p:sp>
+        <p:nvSpPr>
+          <p:cNvPr id="10" name="Rectangle 9"/>
+          <p:cNvSpPr/>
+          <p:nvPr/>
+        </p:nvSpPr>
+        <p:spPr>
+          <a:xfrm>
+            <a:off x="1331640" y="1095133"/>
+            <a:ext cx="7632848" cy="276999"/>
+          </a:xfrm>
+          <a:prstGeom prst="rect">
+            <a:avLst/>
+          </a:prstGeom>
+        </p:spPr>
+        <p:txBody>
+          <a:bodyPr wrap="square">
+            <a:spAutoFit/>
+          </a:bodyPr>
+          <a:lstStyle/>
+          <a:p>
+            <a:pPr>
+              <a:buFont typeface="Arial" panose="020B0604020202020204" pitchFamily="34" charset="0"/>
+              <a:buChar char="•"/>
+            </a:pPr>
+            <a:r>
+              <a:rPr lang="es-ES" sz="1200" b="0" i="0" dirty="0" smtClean="0">
+                <a:solidFill>
+                  <a:srgbClr val="222222"/>
+                </a:solidFill>
+                <a:effectLst/>
+                <a:latin typeface="Segoe UI" panose="020B0502040204020203" pitchFamily="34" charset="0"/>
+              </a:rPr>
+              <a:t> Se </a:t>
+            </a:r>
+            <a:r>
+              <a:rPr lang="es-ES" sz="1200" dirty="0" smtClean="0">
+                <a:solidFill>
+                  <a:srgbClr val="222222"/>
+                </a:solidFill>
+                <a:latin typeface="Segoe UI" panose="020B0502040204020203" pitchFamily="34" charset="0"/>
+              </a:rPr>
+              <a:t>creo pantalla para mostrar los mostrar los números de parte que serán configurados para inspección.</a:t>
+            </a:r>
+            <a:endParaRPr lang="es-ES" sz="1200" b="0" i="0" dirty="0">
+              <a:solidFill>
+                <a:srgbClr val="222222"/>
+              </a:solidFill>
+              <a:effectLst/>
+              <a:latin typeface="Segoe UI" panose="020B0502040204020203" pitchFamily="34" charset="0"/>
+            </a:endParaRPr>
+          </a:p>
+        </p:txBody>
+      </p:sp>
+      <p:pic>
+        <p:nvPicPr>
+          <p:cNvPr id="1027" name="Picture 3" descr="C:\Users\Francisco Esteban\Documents\CONTROL_QUALITY\imagenes\LISTADO.png"/>
+          <p:cNvPicPr>
+            <a:picLocks noChangeAspect="1" noChangeArrowheads="1"/>
+          </p:cNvPicPr>
+          <p:nvPr/>
+        </p:nvPicPr>
+        <p:blipFill>
+          <a:blip r:embed="rId2">
+            <a:extLst>
+              <a:ext uri="{28A0092B-C50C-407E-A947-70E740481C1C}">
+                <a14:useLocalDpi xmlns:a14="http://schemas.microsoft.com/office/drawing/2010/main" val="0"/>
+              </a:ext>
+            </a:extLst>
+          </a:blip>
+          <a:srcRect/>
+          <a:stretch>
+            <a:fillRect/>
+          </a:stretch>
+        </p:blipFill>
+        <p:spPr bwMode="auto">
+          <a:xfrm>
+            <a:off x="1346634" y="1372132"/>
+            <a:ext cx="7458844" cy="5190480"/>
+          </a:xfrm>
+          <a:prstGeom prst="rect">
+            <a:avLst/>
+          </a:prstGeom>
+          <a:noFill/>
+          <a:extLst>
+            <a:ext uri="{909E8E84-426E-40DD-AFC4-6F175D3DCCD1}">
+              <a14:hiddenFill xmlns:a14="http://schemas.microsoft.com/office/drawing/2010/main">
+                <a:solidFill>
+                  <a:srgbClr val="FFFFFF"/>
+                </a:solidFill>
+              </a14:hiddenFill>
+            </a:ext>
+          </a:extLst>
+        </p:spPr>
+      </p:pic>
+    </p:spTree>
+    <p:extLst>
+      <p:ext uri="{BB962C8B-B14F-4D97-AF65-F5344CB8AC3E}">
+        <p14:creationId xmlns:p14="http://schemas.microsoft.com/office/powerpoint/2010/main" val="866398614"/>
+      </p:ext>
+    </p:extLst>
+  </p:cSld>
+  <p:clrMapOvr>
+    <a:masterClrMapping/>
+  </p:clrMapOvr>
+  <p:timing>
+    <p:tnLst>
+      <p:par>
+        <p:cTn id="1" dur="indefinite" restart="never" nodeType="tmRoot"/>
+      </p:par>
+    </p:tnLst>
+  </p:timing>
+</p:sld>
+</file>
+
+<file path=ppt/slides/slide15.xml><?xml version="1.0" encoding="utf-8"?>
+<p:sld xmlns:a="http://schemas.openxmlformats.org/drawingml/2006/main" xmlns:r="http://schemas.openxmlformats.org/officeDocument/2006/relationships" xmlns:p="http://schemas.openxmlformats.org/presentationml/2006/main">
+  <p:cSld>
+    <p:spTree>
+      <p:nvGrpSpPr>
+        <p:cNvPr id="1" name=""/>
+        <p:cNvGrpSpPr/>
+        <p:nvPr/>
+      </p:nvGrpSpPr>
+      <p:grpSpPr>
+        <a:xfrm>
+          <a:off x="0" y="0"/>
+          <a:ext cx="0" cy="0"/>
+          <a:chOff x="0" y="0"/>
+          <a:chExt cx="0" cy="0"/>
+        </a:xfrm>
+      </p:grpSpPr>
+      <p:sp>
+        <p:nvSpPr>
+          <p:cNvPr id="8" name="Title 1"/>
+          <p:cNvSpPr txBox="1">
+            <a:spLocks/>
+          </p:cNvSpPr>
+          <p:nvPr/>
+        </p:nvSpPr>
+        <p:spPr>
+          <a:xfrm>
+            <a:off x="1087408" y="274638"/>
+            <a:ext cx="7229008" cy="634082"/>
+          </a:xfrm>
+          <a:prstGeom prst="rect">
+            <a:avLst/>
+          </a:prstGeom>
+        </p:spPr>
+        <p:txBody>
+          <a:bodyPr/>
+          <a:lstStyle>
+            <a:lvl1pPr algn="ctr" defTabSz="914400" rtl="0" eaLnBrk="1" latinLnBrk="0" hangingPunct="1">
+              <a:spcBef>
+                <a:spcPct val="0"/>
+              </a:spcBef>
+              <a:buNone/>
+              <a:defRPr sz="4400" kern="1200">
+                <a:solidFill>
+                  <a:schemeClr val="tx1"/>
+                </a:solidFill>
+                <a:latin typeface="+mj-lt"/>
+                <a:ea typeface="+mj-ea"/>
+                <a:cs typeface="+mj-cs"/>
+              </a:defRPr>
+            </a:lvl1pPr>
+          </a:lstStyle>
+          <a:p>
+            <a:pPr algn="l"/>
+            <a:r>
+              <a:rPr lang="es-ES" sz="2000" dirty="0" smtClean="0">
+                <a:solidFill>
+                  <a:srgbClr val="3F1900"/>
+                </a:solidFill>
+              </a:rPr>
+              <a:t>QA: Inspección de Material Recibido.</a:t>
+            </a:r>
+            <a:endParaRPr lang="en-US" sz="2000" dirty="0">
+              <a:solidFill>
+                <a:srgbClr val="3F1900"/>
+              </a:solidFill>
+            </a:endParaRPr>
+          </a:p>
+        </p:txBody>
+      </p:sp>
+      <p:sp>
+        <p:nvSpPr>
+          <p:cNvPr id="4" name="Content Placeholder 3"/>
+          <p:cNvSpPr txBox="1">
+            <a:spLocks/>
+          </p:cNvSpPr>
+          <p:nvPr/>
+        </p:nvSpPr>
+        <p:spPr>
+          <a:xfrm>
+            <a:off x="1331640" y="1196753"/>
+            <a:ext cx="7488832" cy="5137780"/>
+          </a:xfrm>
+          <a:prstGeom prst="rect">
+            <a:avLst/>
+          </a:prstGeom>
+        </p:spPr>
+        <p:txBody>
+          <a:bodyPr>
+            <a:normAutofit/>
+          </a:bodyPr>
+          <a:lstStyle>
+            <a:lvl1pPr marL="342900" indent="-342900" algn="l" defTabSz="914400" rtl="0" eaLnBrk="1" latinLnBrk="0" hangingPunct="1">
+              <a:spcBef>
+                <a:spcPct val="20000"/>
+              </a:spcBef>
+              <a:buFont typeface="Arial" panose="020B0604020202020204" pitchFamily="34" charset="0"/>
+              <a:buChar char="•"/>
+              <a:defRPr sz="3200" kern="1200">
+                <a:solidFill>
+                  <a:schemeClr val="tx1"/>
+                </a:solidFill>
+                <a:latin typeface="+mn-lt"/>
+                <a:ea typeface="+mn-ea"/>
+                <a:cs typeface="+mn-cs"/>
+              </a:defRPr>
+            </a:lvl1pPr>
+            <a:lvl2pPr marL="742950" indent="-285750" algn="l" defTabSz="914400" rtl="0" eaLnBrk="1" latinLnBrk="0" hangingPunct="1">
+              <a:spcBef>
+                <a:spcPct val="20000"/>
+              </a:spcBef>
+              <a:buFont typeface="Arial" panose="020B0604020202020204" pitchFamily="34" charset="0"/>
+              <a:buChar char="–"/>
+              <a:defRPr sz="2800" kern="1200">
+                <a:solidFill>
+                  <a:schemeClr val="tx1"/>
+                </a:solidFill>
+                <a:latin typeface="+mn-lt"/>
+                <a:ea typeface="+mn-ea"/>
+                <a:cs typeface="+mn-cs"/>
+              </a:defRPr>
+            </a:lvl2pPr>
+            <a:lvl3pPr marL="1143000" indent="-228600" algn="l" defTabSz="914400" rtl="0" eaLnBrk="1" latinLnBrk="0" hangingPunct="1">
+              <a:spcBef>
+                <a:spcPct val="20000"/>
+              </a:spcBef>
+              <a:buFont typeface="Arial" panose="020B0604020202020204" pitchFamily="34" charset="0"/>
+              <a:buChar char="•"/>
+              <a:defRPr sz="2400" kern="1200">
+                <a:solidFill>
+                  <a:schemeClr val="tx1"/>
+                </a:solidFill>
+                <a:latin typeface="+mn-lt"/>
+                <a:ea typeface="+mn-ea"/>
+                <a:cs typeface="+mn-cs"/>
+              </a:defRPr>
+            </a:lvl3pPr>
+            <a:lvl4pPr marL="1600200" indent="-228600" algn="l" defTabSz="914400" rtl="0" eaLnBrk="1" latinLnBrk="0" hangingPunct="1">
+              <a:spcBef>
+                <a:spcPct val="20000"/>
+              </a:spcBef>
+              <a:buFont typeface="Arial" panose="020B0604020202020204" pitchFamily="34" charset="0"/>
+              <a:buChar char="–"/>
+              <a:defRPr sz="2000" kern="1200">
+                <a:solidFill>
+                  <a:schemeClr val="tx1"/>
+                </a:solidFill>
+                <a:latin typeface="+mn-lt"/>
+                <a:ea typeface="+mn-ea"/>
+                <a:cs typeface="+mn-cs"/>
+              </a:defRPr>
+            </a:lvl4pPr>
+            <a:lvl5pPr marL="2057400" indent="-228600" algn="l" defTabSz="914400" rtl="0" eaLnBrk="1" latinLnBrk="0" hangingPunct="1">
+              <a:spcBef>
+                <a:spcPct val="20000"/>
+              </a:spcBef>
+              <a:buFont typeface="Arial" panose="020B0604020202020204" pitchFamily="34" charset="0"/>
+              <a:buChar char="»"/>
+              <a:defRPr sz="2000" kern="1200">
+                <a:solidFill>
+                  <a:schemeClr val="tx1"/>
+                </a:solidFill>
+                <a:latin typeface="+mn-lt"/>
+                <a:ea typeface="+mn-ea"/>
+                <a:cs typeface="+mn-cs"/>
+              </a:defRPr>
+            </a:lvl5pPr>
+            <a:lvl6pPr marL="2514600" indent="-228600" algn="l" defTabSz="914400" rtl="0" eaLnBrk="1" latinLnBrk="0" hangingPunct="1">
+              <a:spcBef>
+                <a:spcPct val="20000"/>
+              </a:spcBef>
+              <a:buFont typeface="Arial" panose="020B0604020202020204" pitchFamily="34" charset="0"/>
+              <a:buChar char="•"/>
+              <a:defRPr sz="2000" kern="1200">
+                <a:solidFill>
+                  <a:schemeClr val="tx1"/>
+                </a:solidFill>
+                <a:latin typeface="+mn-lt"/>
+                <a:ea typeface="+mn-ea"/>
+                <a:cs typeface="+mn-cs"/>
+              </a:defRPr>
+            </a:lvl6pPr>
+            <a:lvl7pPr marL="2971800" indent="-228600" algn="l" defTabSz="914400" rtl="0" eaLnBrk="1" latinLnBrk="0" hangingPunct="1">
+              <a:spcBef>
+                <a:spcPct val="20000"/>
+              </a:spcBef>
+              <a:buFont typeface="Arial" panose="020B0604020202020204" pitchFamily="34" charset="0"/>
+              <a:buChar char="•"/>
+              <a:defRPr sz="2000" kern="1200">
+                <a:solidFill>
+                  <a:schemeClr val="tx1"/>
+                </a:solidFill>
+                <a:latin typeface="+mn-lt"/>
+                <a:ea typeface="+mn-ea"/>
+                <a:cs typeface="+mn-cs"/>
+              </a:defRPr>
+            </a:lvl7pPr>
+            <a:lvl8pPr marL="3429000" indent="-228600" algn="l" defTabSz="914400" rtl="0" eaLnBrk="1" latinLnBrk="0" hangingPunct="1">
+              <a:spcBef>
+                <a:spcPct val="20000"/>
+              </a:spcBef>
+              <a:buFont typeface="Arial" panose="020B0604020202020204" pitchFamily="34" charset="0"/>
+              <a:buChar char="•"/>
+              <a:defRPr sz="2000" kern="1200">
+                <a:solidFill>
+                  <a:schemeClr val="tx1"/>
+                </a:solidFill>
+                <a:latin typeface="+mn-lt"/>
+                <a:ea typeface="+mn-ea"/>
+                <a:cs typeface="+mn-cs"/>
+              </a:defRPr>
+            </a:lvl8pPr>
+            <a:lvl9pPr marL="3886200" indent="-228600" algn="l" defTabSz="914400" rtl="0" eaLnBrk="1" latinLnBrk="0" hangingPunct="1">
+              <a:spcBef>
+                <a:spcPct val="20000"/>
+              </a:spcBef>
+              <a:buFont typeface="Arial" panose="020B0604020202020204" pitchFamily="34" charset="0"/>
+              <a:buChar char="•"/>
+              <a:defRPr sz="2000" kern="1200">
+                <a:solidFill>
+                  <a:schemeClr val="tx1"/>
+                </a:solidFill>
+                <a:latin typeface="+mn-lt"/>
+                <a:ea typeface="+mn-ea"/>
+                <a:cs typeface="+mn-cs"/>
+              </a:defRPr>
+            </a:lvl9pPr>
+          </a:lstStyle>
+          <a:p>
+            <a:pPr marL="0" indent="0" algn="just">
+              <a:buFont typeface="Arial" panose="020B0604020202020204" pitchFamily="34" charset="0"/>
+              <a:buNone/>
+            </a:pPr>
+            <a:endParaRPr lang="en-US" sz="2000" i="1"/>
+          </a:p>
+        </p:txBody>
+      </p:sp>
+      <p:sp>
+        <p:nvSpPr>
+          <p:cNvPr id="10" name="Rectangle 9"/>
+          <p:cNvSpPr/>
+          <p:nvPr/>
+        </p:nvSpPr>
+        <p:spPr>
+          <a:xfrm>
+            <a:off x="1331640" y="1095133"/>
+            <a:ext cx="7632848" cy="276999"/>
+          </a:xfrm>
+          <a:prstGeom prst="rect">
+            <a:avLst/>
+          </a:prstGeom>
+        </p:spPr>
+        <p:txBody>
+          <a:bodyPr wrap="square">
+            <a:spAutoFit/>
+          </a:bodyPr>
+          <a:lstStyle/>
+          <a:p>
+            <a:pPr>
+              <a:buFont typeface="Arial" panose="020B0604020202020204" pitchFamily="34" charset="0"/>
+              <a:buChar char="•"/>
+            </a:pPr>
+            <a:r>
+              <a:rPr lang="es-ES" sz="1200" b="0" i="0" dirty="0" smtClean="0">
+                <a:solidFill>
+                  <a:srgbClr val="222222"/>
+                </a:solidFill>
+                <a:effectLst/>
+                <a:latin typeface="Segoe UI" panose="020B0502040204020203" pitchFamily="34" charset="0"/>
+              </a:rPr>
+              <a:t> Se </a:t>
+            </a:r>
+            <a:r>
+              <a:rPr lang="es-ES" sz="1200" dirty="0" smtClean="0">
+                <a:solidFill>
+                  <a:srgbClr val="222222"/>
+                </a:solidFill>
+                <a:latin typeface="Segoe UI" panose="020B0502040204020203" pitchFamily="34" charset="0"/>
+              </a:rPr>
+              <a:t>creo Ficha para capturar revisiones/inspección que se le realizara al numero de parte.</a:t>
+            </a:r>
+            <a:endParaRPr lang="es-ES" sz="1200" b="0" i="0" dirty="0">
+              <a:solidFill>
+                <a:srgbClr val="222222"/>
+              </a:solidFill>
+              <a:effectLst/>
+              <a:latin typeface="Segoe UI" panose="020B0502040204020203" pitchFamily="34" charset="0"/>
+            </a:endParaRPr>
+          </a:p>
+        </p:txBody>
+      </p:sp>
+      <p:pic>
+        <p:nvPicPr>
+          <p:cNvPr id="2050" name="Picture 2" descr="C:\Users\Francisco Esteban\Documents\CONTROL_QUALITY\imagenes\FICHA.png"/>
+          <p:cNvPicPr>
+            <a:picLocks noChangeAspect="1" noChangeArrowheads="1"/>
+          </p:cNvPicPr>
+          <p:nvPr/>
+        </p:nvPicPr>
+        <p:blipFill>
+          <a:blip r:embed="rId2">
+            <a:extLst>
+              <a:ext uri="{28A0092B-C50C-407E-A947-70E740481C1C}">
+                <a14:useLocalDpi xmlns:a14="http://schemas.microsoft.com/office/drawing/2010/main" val="0"/>
+              </a:ext>
+            </a:extLst>
+          </a:blip>
+          <a:srcRect/>
+          <a:stretch>
+            <a:fillRect/>
+          </a:stretch>
+        </p:blipFill>
+        <p:spPr bwMode="auto">
+          <a:xfrm>
+            <a:off x="1259632" y="1422344"/>
+            <a:ext cx="7634179" cy="5247016"/>
+          </a:xfrm>
+          <a:prstGeom prst="rect">
+            <a:avLst/>
+          </a:prstGeom>
+          <a:noFill/>
+          <a:extLst>
+            <a:ext uri="{909E8E84-426E-40DD-AFC4-6F175D3DCCD1}">
+              <a14:hiddenFill xmlns:a14="http://schemas.microsoft.com/office/drawing/2010/main">
+                <a:solidFill>
+                  <a:srgbClr val="FFFFFF"/>
+                </a:solidFill>
+              </a14:hiddenFill>
+            </a:ext>
+          </a:extLst>
+        </p:spPr>
+      </p:pic>
+    </p:spTree>
+    <p:extLst>
+      <p:ext uri="{BB962C8B-B14F-4D97-AF65-F5344CB8AC3E}">
+        <p14:creationId xmlns:p14="http://schemas.microsoft.com/office/powerpoint/2010/main" val="1233991869"/>
       </p:ext>
     </p:extLst>
   </p:cSld>
@@ -3825,7 +5818,7 @@
         <p:spPr>
           <a:xfrm>
             <a:off x="1331640" y="1095133"/>
-            <a:ext cx="7632848" cy="461665"/>
+            <a:ext cx="7632848" cy="276999"/>
           </a:xfrm>
           <a:prstGeom prst="rect">
             <a:avLst/>
@@ -3852,14 +5845,13 @@
               <a:t> </a:t>
             </a:r>
             <a:r>
-              <a:rPr lang="es-ES" sz="1200" b="0" i="0" dirty="0" smtClean="0">
+              <a:rPr lang="es-ES" sz="1200" dirty="0">
                 <a:solidFill>
                   <a:srgbClr val="222222"/>
                 </a:solidFill>
-                <a:effectLst/>
                 <a:latin typeface="Segoe UI" panose="020B0502040204020203" pitchFamily="34" charset="0"/>
               </a:rPr>
-              <a:t>Se modifico</a:t>
+              <a:t>P</a:t>
             </a:r>
             <a:r>
               <a:rPr lang="es-ES" sz="1200" dirty="0" smtClean="0">
@@ -3868,7 +5860,7 @@
                 </a:solidFill>
                 <a:latin typeface="Segoe UI" panose="020B0502040204020203" pitchFamily="34" charset="0"/>
               </a:rPr>
-              <a:t> </a:t>
+              <a:t>antalla </a:t>
             </a:r>
             <a:r>
               <a:rPr lang="es-ES" sz="1200" dirty="0" smtClean="0">
@@ -3877,7 +5869,7 @@
                 </a:solidFill>
                 <a:latin typeface="Segoe UI" panose="020B0502040204020203" pitchFamily="34" charset="0"/>
               </a:rPr>
-              <a:t>Ficha para </a:t>
+              <a:t>para </a:t>
             </a:r>
             <a:r>
               <a:rPr lang="es-ES" sz="1200" dirty="0" smtClean="0">
@@ -3886,7 +5878,7 @@
                 </a:solidFill>
                 <a:latin typeface="Segoe UI" panose="020B0502040204020203" pitchFamily="34" charset="0"/>
               </a:rPr>
-              <a:t>la</a:t>
+              <a:t>M</a:t>
             </a:r>
             <a:r>
               <a:rPr lang="es-ES" sz="1200" dirty="0" smtClean="0">
@@ -3895,7 +5887,16 @@
                 </a:solidFill>
                 <a:latin typeface="Segoe UI" panose="020B0502040204020203" pitchFamily="34" charset="0"/>
               </a:rPr>
-              <a:t> captura de los porcentajes que tendrá la inspección y cada una de las opciones así como la sumatoria de los porcentajes para el numero de parte.</a:t>
+              <a:t>ostrar/Listar los </a:t>
+            </a:r>
+            <a:r>
+              <a:rPr lang="es-ES" sz="1200" dirty="0" smtClean="0">
+                <a:solidFill>
+                  <a:srgbClr val="222222"/>
+                </a:solidFill>
+                <a:latin typeface="Segoe UI" panose="020B0502040204020203" pitchFamily="34" charset="0"/>
+              </a:rPr>
+              <a:t>números de parte que serán configurados para inspección.</a:t>
             </a:r>
             <a:endParaRPr lang="es-ES" sz="1200" b="0" i="0" dirty="0">
               <a:solidFill>
@@ -3909,7 +5910,7 @@
       </p:sp>
       <p:pic>
         <p:nvPicPr>
-          <p:cNvPr id="1027" name="Picture 3" descr="C:\Users\Francisco Esteban\Documents\CONTROL_QUALITY\imagenes\FICHA_V2.png"/>
+          <p:cNvPr id="1027" name="Picture 3" descr="C:\Users\Francisco Esteban\Documents\CONTROL_QUALITY\imagenes\LISTADO.png"/>
           <p:cNvPicPr>
             <a:picLocks noChangeAspect="1" noChangeArrowheads="1"/>
           </p:cNvPicPr>
@@ -3930,8 +5931,8 @@
         </p:blipFill>
         <p:spPr bwMode="auto">
           <a:xfrm>
-            <a:off x="1403648" y="1556792"/>
-            <a:ext cx="7416502" cy="5112568"/>
+            <a:off x="1346634" y="1372132"/>
+            <a:ext cx="7617854" cy="5369236"/>
           </a:xfrm>
           <a:prstGeom prst="rect">
             <a:avLst/>
@@ -3948,148 +5949,10 @@
           </a:extLst>
         </p:spPr>
       </p:pic>
-      <p:sp>
-        <p:nvSpPr>
-          <p:cNvPr id="2" name="Rectangle 1"/>
-          <p:cNvSpPr/>
-          <p:nvPr/>
-        </p:nvSpPr>
-        <p:spPr>
-          <a:xfrm>
-            <a:off x="7020272" y="3501008"/>
-            <a:ext cx="720080" cy="311429"/>
-          </a:xfrm>
-          <a:prstGeom prst="rect">
-            <a:avLst/>
-          </a:prstGeom>
-          <a:noFill/>
-          <a:ln>
-            <a:solidFill>
-              <a:srgbClr val="FF0000"/>
-            </a:solidFill>
-          </a:ln>
-        </p:spPr>
-        <p:style>
-          <a:lnRef idx="2">
-            <a:schemeClr val="accent1">
-              <a:shade val="50000"/>
-            </a:schemeClr>
-          </a:lnRef>
-          <a:fillRef idx="1">
-            <a:schemeClr val="accent1"/>
-          </a:fillRef>
-          <a:effectRef idx="0">
-            <a:schemeClr val="accent1"/>
-          </a:effectRef>
-          <a:fontRef idx="minor">
-            <a:schemeClr val="lt1"/>
-          </a:fontRef>
-        </p:style>
-        <p:txBody>
-          <a:bodyPr rtlCol="0" anchor="ctr"/>
-          <a:lstStyle/>
-          <a:p>
-            <a:pPr algn="ctr"/>
-            <a:endParaRPr lang="en-US"/>
-          </a:p>
-        </p:txBody>
-      </p:sp>
-      <p:sp>
-        <p:nvSpPr>
-          <p:cNvPr id="9" name="Rectangle 8"/>
-          <p:cNvSpPr/>
-          <p:nvPr/>
-        </p:nvSpPr>
-        <p:spPr>
-          <a:xfrm>
-            <a:off x="1691680" y="4293096"/>
-            <a:ext cx="5328592" cy="288032"/>
-          </a:xfrm>
-          <a:prstGeom prst="rect">
-            <a:avLst/>
-          </a:prstGeom>
-          <a:noFill/>
-          <a:ln>
-            <a:solidFill>
-              <a:srgbClr val="FF0000"/>
-            </a:solidFill>
-          </a:ln>
-        </p:spPr>
-        <p:style>
-          <a:lnRef idx="2">
-            <a:schemeClr val="accent1">
-              <a:shade val="50000"/>
-            </a:schemeClr>
-          </a:lnRef>
-          <a:fillRef idx="1">
-            <a:schemeClr val="accent1"/>
-          </a:fillRef>
-          <a:effectRef idx="0">
-            <a:schemeClr val="accent1"/>
-          </a:effectRef>
-          <a:fontRef idx="minor">
-            <a:schemeClr val="lt1"/>
-          </a:fontRef>
-        </p:style>
-        <p:txBody>
-          <a:bodyPr rtlCol="0" anchor="ctr"/>
-          <a:lstStyle/>
-          <a:p>
-            <a:pPr algn="ctr"/>
-            <a:endParaRPr lang="en-US"/>
-          </a:p>
-        </p:txBody>
-      </p:sp>
-      <p:sp>
-        <p:nvSpPr>
-          <p:cNvPr id="11" name="Rectangle 10"/>
-          <p:cNvSpPr/>
-          <p:nvPr/>
-        </p:nvSpPr>
-        <p:spPr>
-          <a:xfrm>
-            <a:off x="6804248" y="4725144"/>
-            <a:ext cx="1440160" cy="216024"/>
-          </a:xfrm>
-          <a:prstGeom prst="rect">
-            <a:avLst/>
-          </a:prstGeom>
-          <a:noFill/>
-          <a:ln>
-            <a:solidFill>
-              <a:srgbClr val="FF0000"/>
-            </a:solidFill>
-          </a:ln>
-        </p:spPr>
-        <p:style>
-          <a:lnRef idx="2">
-            <a:schemeClr val="accent1">
-              <a:shade val="50000"/>
-            </a:schemeClr>
-          </a:lnRef>
-          <a:fillRef idx="1">
-            <a:schemeClr val="accent1"/>
-          </a:fillRef>
-          <a:effectRef idx="0">
-            <a:schemeClr val="accent1"/>
-          </a:effectRef>
-          <a:fontRef idx="minor">
-            <a:schemeClr val="lt1"/>
-          </a:fontRef>
-        </p:style>
-        <p:txBody>
-          <a:bodyPr rtlCol="0" anchor="ctr"/>
-          <a:lstStyle/>
-          <a:p>
-            <a:pPr algn="ctr"/>
-            <a:endParaRPr lang="en-US"/>
-          </a:p>
-        </p:txBody>
-      </p:sp>
     </p:spTree>
     <p:extLst>
       <p:ext uri="{BB962C8B-B14F-4D97-AF65-F5344CB8AC3E}">
-        <p14:creationId xmlns:p14="http://schemas.microsoft.com/office/powerpoint/2010/main" val="793512761"/>
+        <p14:creationId xmlns:p14="http://schemas.microsoft.com/office/powerpoint/2010/main" val="3805306993"/>
       </p:ext>
     </p:extLst>
   </p:cSld>
@@ -4352,7 +6215,7 @@
         <p:spPr>
           <a:xfrm>
             <a:off x="1331640" y="1095133"/>
-            <a:ext cx="7632848" cy="461665"/>
+            <a:ext cx="7488832" cy="461665"/>
           </a:xfrm>
           <a:prstGeom prst="rect">
             <a:avLst/>
@@ -4376,7 +6239,7 @@
                 <a:effectLst/>
                 <a:latin typeface="Segoe UI" panose="020B0502040204020203" pitchFamily="34" charset="0"/>
               </a:rPr>
-              <a:t> Se </a:t>
+              <a:t> Se modifico</a:t>
             </a:r>
             <a:r>
               <a:rPr lang="es-ES" sz="1200" dirty="0" smtClean="0">
@@ -4385,7 +6248,7 @@
                 </a:solidFill>
                 <a:latin typeface="Segoe UI" panose="020B0502040204020203" pitchFamily="34" charset="0"/>
               </a:rPr>
-              <a:t>creo pantalla para </a:t>
+              <a:t> Ficha para la captura </a:t>
             </a:r>
             <a:r>
               <a:rPr lang="es-ES" sz="1200" dirty="0" smtClean="0">
@@ -4394,9 +6257,36 @@
                 </a:solidFill>
                 <a:latin typeface="Segoe UI" panose="020B0502040204020203" pitchFamily="34" charset="0"/>
               </a:rPr>
-              <a:t>mostrar/Listar los artículos/No. Parte que contiene la orden de compra para su inspección.</a:t>
-            </a:r>
-            <a:endParaRPr lang="es-ES" sz="1200" b="0" i="0" dirty="0">
+              <a:t>de cada </a:t>
+            </a:r>
+            <a:r>
+              <a:rPr lang="es-ES" sz="1200" dirty="0" smtClean="0">
+                <a:solidFill>
+                  <a:srgbClr val="222222"/>
+                </a:solidFill>
+                <a:latin typeface="Segoe UI" panose="020B0502040204020203" pitchFamily="34" charset="0"/>
+              </a:rPr>
+              <a:t>una de las </a:t>
+            </a:r>
+            <a:r>
+              <a:rPr lang="es-ES" sz="1200" dirty="0" smtClean="0">
+                <a:solidFill>
+                  <a:srgbClr val="222222"/>
+                </a:solidFill>
+                <a:latin typeface="Segoe UI" panose="020B0502040204020203" pitchFamily="34" charset="0"/>
+              </a:rPr>
+              <a:t>inspecciones para el numero de parte </a:t>
+            </a:r>
+            <a:r>
+              <a:rPr lang="es-ES" sz="1200" b="1" dirty="0" smtClean="0">
+                <a:solidFill>
+                  <a:srgbClr val="222222"/>
+                </a:solidFill>
+                <a:latin typeface="Segoe UI" panose="020B0502040204020203" pitchFamily="34" charset="0"/>
+              </a:rPr>
+              <a:t>[Opción Múltiple].</a:t>
+            </a:r>
+            <a:endParaRPr lang="es-ES" sz="1200" b="1" i="0" dirty="0">
               <a:solidFill>
                 <a:srgbClr val="222222"/>
               </a:solidFill>
@@ -4408,7 +6298,7 @@
       </p:sp>
       <p:pic>
         <p:nvPicPr>
-          <p:cNvPr id="2050" name="Picture 2" descr="C:\Users\Francisco Esteban\Documents\CONTROL_QUALITY\imagenes\LISTADO_ORDEN.png"/>
+          <p:cNvPr id="2050" name="Picture 2" descr="C:\Users\Francisco Esteban\Documents\CONTROL_QUALITY\imagenes\FICHA_No_Parte.png"/>
           <p:cNvPicPr>
             <a:picLocks noChangeAspect="1" noChangeArrowheads="1"/>
           </p:cNvPicPr>
@@ -4429,8 +6319,8 @@
         </p:blipFill>
         <p:spPr bwMode="auto">
           <a:xfrm>
-            <a:off x="1403648" y="1556798"/>
-            <a:ext cx="7416823" cy="5184570"/>
+            <a:off x="1331640" y="1556798"/>
+            <a:ext cx="7560840" cy="5099590"/>
           </a:xfrm>
           <a:prstGeom prst="rect">
             <a:avLst/>
@@ -4450,7 +6340,7 @@
     </p:spTree>
     <p:extLst>
       <p:ext uri="{BB962C8B-B14F-4D97-AF65-F5344CB8AC3E}">
-        <p14:creationId xmlns:p14="http://schemas.microsoft.com/office/powerpoint/2010/main" val="1651901033"/>
+        <p14:creationId xmlns:p14="http://schemas.microsoft.com/office/powerpoint/2010/main" val="4269241169"/>
       </p:ext>
     </p:extLst>
   </p:cSld>
@@ -4713,7 +6603,7 @@
         <p:spPr>
           <a:xfrm>
             <a:off x="1331640" y="1095133"/>
-            <a:ext cx="7632848" cy="276999"/>
+            <a:ext cx="7488832" cy="461665"/>
           </a:xfrm>
           <a:prstGeom prst="rect">
             <a:avLst/>
@@ -4737,17 +6627,16 @@
                 <a:effectLst/>
                 <a:latin typeface="Segoe UI" panose="020B0502040204020203" pitchFamily="34" charset="0"/>
               </a:rPr>
-              <a:t> </a:t>
-            </a:r>
-            <a:r>
-              <a:rPr lang="es-ES" sz="1200" b="0" i="0" dirty="0" smtClean="0">
+              <a:t> Se modifico</a:t>
+            </a:r>
+            <a:r>
+              <a:rPr lang="es-ES" sz="1200" dirty="0" smtClean="0">
                 <a:solidFill>
                   <a:srgbClr val="222222"/>
                 </a:solidFill>
-                <a:effectLst/>
                 <a:latin typeface="Segoe UI" panose="020B0502040204020203" pitchFamily="34" charset="0"/>
               </a:rPr>
-              <a:t>Se </a:t>
+              <a:t> Ficha para la captura </a:t>
             </a:r>
             <a:r>
               <a:rPr lang="es-ES" sz="1200" dirty="0" smtClean="0">
@@ -4756,7 +6645,7 @@
                 </a:solidFill>
                 <a:latin typeface="Segoe UI" panose="020B0502040204020203" pitchFamily="34" charset="0"/>
               </a:rPr>
-              <a:t>creo </a:t>
+              <a:t>de cada </a:t>
             </a:r>
             <a:r>
               <a:rPr lang="es-ES" sz="1200" dirty="0" smtClean="0">
@@ -4765,7 +6654,7 @@
                 </a:solidFill>
                 <a:latin typeface="Segoe UI" panose="020B0502040204020203" pitchFamily="34" charset="0"/>
               </a:rPr>
-              <a:t>Ficha </a:t>
+              <a:t>una de las </a:t>
             </a:r>
             <a:r>
               <a:rPr lang="es-ES" sz="1200" dirty="0" smtClean="0">
@@ -4774,27 +6663,18 @@
                 </a:solidFill>
                 <a:latin typeface="Segoe UI" panose="020B0502040204020203" pitchFamily="34" charset="0"/>
               </a:rPr>
-              <a:t>para </a:t>
-            </a:r>
-            <a:r>
-              <a:rPr lang="es-ES" sz="1200" dirty="0" smtClean="0">
+              <a:t>inspecciones para el numero de parte </a:t>
+            </a:r>
+            <a:r>
+              <a:rPr lang="es-ES" sz="1200" b="1" dirty="0" smtClean="0">
                 <a:solidFill>
                   <a:srgbClr val="222222"/>
                 </a:solidFill>
                 <a:latin typeface="Segoe UI" panose="020B0502040204020203" pitchFamily="34" charset="0"/>
               </a:rPr>
-              <a:t>la</a:t>
-            </a:r>
-            <a:r>
-              <a:rPr lang="es-ES" sz="1200" dirty="0" smtClean="0">
-                <a:solidFill>
-                  <a:srgbClr val="222222"/>
-                </a:solidFill>
-                <a:latin typeface="Segoe UI" panose="020B0502040204020203" pitchFamily="34" charset="0"/>
-              </a:rPr>
-              <a:t> realización de las diferentes inspecciones para cada numero de parte en la orden.</a:t>
-            </a:r>
-            <a:endParaRPr lang="es-ES" sz="1200" b="0" i="0" dirty="0">
+              <a:t>[Opción Evaluación].</a:t>
+            </a:r>
+            <a:endParaRPr lang="es-ES" sz="1200" b="1" i="0" dirty="0">
               <a:solidFill>
                 <a:srgbClr val="222222"/>
               </a:solidFill>
@@ -4806,7 +6686,7 @@
       </p:sp>
       <p:pic>
         <p:nvPicPr>
-          <p:cNvPr id="3074" name="Picture 2" descr="C:\Users\Francisco Esteban\Documents\CONTROL_QUALITY\imagenes\FICHA_INSPECCION.png"/>
+          <p:cNvPr id="3074" name="Picture 2" descr="C:\Users\Francisco Esteban\Documents\CONTROL_QUALITY\imagenes\FICHA_No_Parte_opc2.png"/>
           <p:cNvPicPr>
             <a:picLocks noChangeAspect="1" noChangeArrowheads="1"/>
           </p:cNvPicPr>
@@ -4827,8 +6707,8 @@
         </p:blipFill>
         <p:spPr bwMode="auto">
           <a:xfrm>
-            <a:off x="1403648" y="1412777"/>
-            <a:ext cx="7488832" cy="5256584"/>
+            <a:off x="1331640" y="1556797"/>
+            <a:ext cx="7488832" cy="5037677"/>
           </a:xfrm>
           <a:prstGeom prst="rect">
             <a:avLst/>
@@ -4848,7 +6728,7 @@
     </p:spTree>
     <p:extLst>
       <p:ext uri="{BB962C8B-B14F-4D97-AF65-F5344CB8AC3E}">
-        <p14:creationId xmlns:p14="http://schemas.microsoft.com/office/powerpoint/2010/main" val="2151361561"/>
+        <p14:creationId xmlns:p14="http://schemas.microsoft.com/office/powerpoint/2010/main" val="3115154970"/>
       </p:ext>
     </p:extLst>
   </p:cSld>
@@ -4884,7 +6764,7 @@
       </p:grpSpPr>
       <p:sp>
         <p:nvSpPr>
-          <p:cNvPr id="5" name="Title 1"/>
+          <p:cNvPr id="8" name="Title 1"/>
           <p:cNvSpPr txBox="1">
             <a:spLocks/>
           </p:cNvSpPr>
@@ -4892,56 +6772,342 @@
         </p:nvSpPr>
         <p:spPr>
           <a:xfrm>
-            <a:off x="1187624" y="2564904"/>
-            <a:ext cx="7772400" cy="1470025"/>
+            <a:off x="1087408" y="274638"/>
+            <a:ext cx="7229008" cy="634082"/>
           </a:xfrm>
           <a:prstGeom prst="rect">
             <a:avLst/>
           </a:prstGeom>
         </p:spPr>
         <p:txBody>
-          <a:bodyPr vert="horz" lIns="91440" tIns="45720" rIns="91440" bIns="45720" rtlCol="0" anchor="ctr">
+          <a:bodyPr/>
+          <a:lstStyle>
+            <a:lvl1pPr algn="ctr" defTabSz="914400" rtl="0" eaLnBrk="1" latinLnBrk="0" hangingPunct="1">
+              <a:spcBef>
+                <a:spcPct val="0"/>
+              </a:spcBef>
+              <a:buNone/>
+              <a:defRPr sz="4400" kern="1200">
+                <a:solidFill>
+                  <a:schemeClr val="tx1"/>
+                </a:solidFill>
+                <a:latin typeface="+mj-lt"/>
+                <a:ea typeface="+mj-ea"/>
+                <a:cs typeface="+mj-cs"/>
+              </a:defRPr>
+            </a:lvl1pPr>
+          </a:lstStyle>
+          <a:p>
+            <a:pPr algn="l"/>
+            <a:r>
+              <a:rPr lang="es-ES" sz="2000" dirty="0" smtClean="0">
+                <a:solidFill>
+                  <a:srgbClr val="3F1900"/>
+                </a:solidFill>
+              </a:rPr>
+              <a:t>QA: Inspección de Material Recibido.</a:t>
+            </a:r>
+            <a:endParaRPr lang="en-US" sz="2000" dirty="0">
+              <a:solidFill>
+                <a:srgbClr val="3F1900"/>
+              </a:solidFill>
+            </a:endParaRPr>
+          </a:p>
+        </p:txBody>
+      </p:sp>
+      <p:sp>
+        <p:nvSpPr>
+          <p:cNvPr id="4" name="Content Placeholder 3"/>
+          <p:cNvSpPr txBox="1">
+            <a:spLocks/>
+          </p:cNvSpPr>
+          <p:nvPr/>
+        </p:nvSpPr>
+        <p:spPr>
+          <a:xfrm>
+            <a:off x="1331640" y="1196753"/>
+            <a:ext cx="7488832" cy="5137780"/>
+          </a:xfrm>
+          <a:prstGeom prst="rect">
+            <a:avLst/>
+          </a:prstGeom>
+        </p:spPr>
+        <p:txBody>
+          <a:bodyPr>
             <a:normAutofit/>
           </a:bodyPr>
           <a:lstStyle>
-            <a:lvl1pPr algn="ctr" defTabSz="914400" rtl="0" eaLnBrk="1" latinLnBrk="0" hangingPunct="1">
-              <a:spcBef>
-                <a:spcPct val="0"/>
-              </a:spcBef>
+            <a:lvl1pPr marL="342900" indent="-342900" algn="l" defTabSz="914400" rtl="0" eaLnBrk="1" latinLnBrk="0" hangingPunct="1">
+              <a:spcBef>
+                <a:spcPct val="20000"/>
+              </a:spcBef>
+              <a:buFont typeface="Arial" panose="020B0604020202020204" pitchFamily="34" charset="0"/>
+              <a:buChar char="•"/>
+              <a:defRPr sz="3200" kern="1200">
+                <a:solidFill>
+                  <a:schemeClr val="tx1"/>
+                </a:solidFill>
+                <a:latin typeface="+mn-lt"/>
+                <a:ea typeface="+mn-ea"/>
+                <a:cs typeface="+mn-cs"/>
+              </a:defRPr>
+            </a:lvl1pPr>
+            <a:lvl2pPr marL="742950" indent="-285750" algn="l" defTabSz="914400" rtl="0" eaLnBrk="1" latinLnBrk="0" hangingPunct="1">
+              <a:spcBef>
+                <a:spcPct val="20000"/>
+              </a:spcBef>
+              <a:buFont typeface="Arial" panose="020B0604020202020204" pitchFamily="34" charset="0"/>
+              <a:buChar char="–"/>
+              <a:defRPr sz="2800" kern="1200">
+                <a:solidFill>
+                  <a:schemeClr val="tx1"/>
+                </a:solidFill>
+                <a:latin typeface="+mn-lt"/>
+                <a:ea typeface="+mn-ea"/>
+                <a:cs typeface="+mn-cs"/>
+              </a:defRPr>
+            </a:lvl2pPr>
+            <a:lvl3pPr marL="1143000" indent="-228600" algn="l" defTabSz="914400" rtl="0" eaLnBrk="1" latinLnBrk="0" hangingPunct="1">
+              <a:spcBef>
+                <a:spcPct val="20000"/>
+              </a:spcBef>
+              <a:buFont typeface="Arial" panose="020B0604020202020204" pitchFamily="34" charset="0"/>
+              <a:buChar char="•"/>
+              <a:defRPr sz="2400" kern="1200">
+                <a:solidFill>
+                  <a:schemeClr val="tx1"/>
+                </a:solidFill>
+                <a:latin typeface="+mn-lt"/>
+                <a:ea typeface="+mn-ea"/>
+                <a:cs typeface="+mn-cs"/>
+              </a:defRPr>
+            </a:lvl3pPr>
+            <a:lvl4pPr marL="1600200" indent="-228600" algn="l" defTabSz="914400" rtl="0" eaLnBrk="1" latinLnBrk="0" hangingPunct="1">
+              <a:spcBef>
+                <a:spcPct val="20000"/>
+              </a:spcBef>
+              <a:buFont typeface="Arial" panose="020B0604020202020204" pitchFamily="34" charset="0"/>
+              <a:buChar char="–"/>
+              <a:defRPr sz="2000" kern="1200">
+                <a:solidFill>
+                  <a:schemeClr val="tx1"/>
+                </a:solidFill>
+                <a:latin typeface="+mn-lt"/>
+                <a:ea typeface="+mn-ea"/>
+                <a:cs typeface="+mn-cs"/>
+              </a:defRPr>
+            </a:lvl4pPr>
+            <a:lvl5pPr marL="2057400" indent="-228600" algn="l" defTabSz="914400" rtl="0" eaLnBrk="1" latinLnBrk="0" hangingPunct="1">
+              <a:spcBef>
+                <a:spcPct val="20000"/>
+              </a:spcBef>
+              <a:buFont typeface="Arial" panose="020B0604020202020204" pitchFamily="34" charset="0"/>
+              <a:buChar char="»"/>
+              <a:defRPr sz="2000" kern="1200">
+                <a:solidFill>
+                  <a:schemeClr val="tx1"/>
+                </a:solidFill>
+                <a:latin typeface="+mn-lt"/>
+                <a:ea typeface="+mn-ea"/>
+                <a:cs typeface="+mn-cs"/>
+              </a:defRPr>
+            </a:lvl5pPr>
+            <a:lvl6pPr marL="2514600" indent="-228600" algn="l" defTabSz="914400" rtl="0" eaLnBrk="1" latinLnBrk="0" hangingPunct="1">
+              <a:spcBef>
+                <a:spcPct val="20000"/>
+              </a:spcBef>
+              <a:buFont typeface="Arial" panose="020B0604020202020204" pitchFamily="34" charset="0"/>
+              <a:buChar char="•"/>
+              <a:defRPr sz="2000" kern="1200">
+                <a:solidFill>
+                  <a:schemeClr val="tx1"/>
+                </a:solidFill>
+                <a:latin typeface="+mn-lt"/>
+                <a:ea typeface="+mn-ea"/>
+                <a:cs typeface="+mn-cs"/>
+              </a:defRPr>
+            </a:lvl6pPr>
+            <a:lvl7pPr marL="2971800" indent="-228600" algn="l" defTabSz="914400" rtl="0" eaLnBrk="1" latinLnBrk="0" hangingPunct="1">
+              <a:spcBef>
+                <a:spcPct val="20000"/>
+              </a:spcBef>
+              <a:buFont typeface="Arial" panose="020B0604020202020204" pitchFamily="34" charset="0"/>
+              <a:buChar char="•"/>
+              <a:defRPr sz="2000" kern="1200">
+                <a:solidFill>
+                  <a:schemeClr val="tx1"/>
+                </a:solidFill>
+                <a:latin typeface="+mn-lt"/>
+                <a:ea typeface="+mn-ea"/>
+                <a:cs typeface="+mn-cs"/>
+              </a:defRPr>
+            </a:lvl7pPr>
+            <a:lvl8pPr marL="3429000" indent="-228600" algn="l" defTabSz="914400" rtl="0" eaLnBrk="1" latinLnBrk="0" hangingPunct="1">
+              <a:spcBef>
+                <a:spcPct val="20000"/>
+              </a:spcBef>
+              <a:buFont typeface="Arial" panose="020B0604020202020204" pitchFamily="34" charset="0"/>
+              <a:buChar char="•"/>
+              <a:defRPr sz="2000" kern="1200">
+                <a:solidFill>
+                  <a:schemeClr val="tx1"/>
+                </a:solidFill>
+                <a:latin typeface="+mn-lt"/>
+                <a:ea typeface="+mn-ea"/>
+                <a:cs typeface="+mn-cs"/>
+              </a:defRPr>
+            </a:lvl8pPr>
+            <a:lvl9pPr marL="3886200" indent="-228600" algn="l" defTabSz="914400" rtl="0" eaLnBrk="1" latinLnBrk="0" hangingPunct="1">
+              <a:spcBef>
+                <a:spcPct val="20000"/>
+              </a:spcBef>
+              <a:buFont typeface="Arial" panose="020B0604020202020204" pitchFamily="34" charset="0"/>
+              <a:buChar char="•"/>
+              <a:defRPr sz="2000" kern="1200">
+                <a:solidFill>
+                  <a:schemeClr val="tx1"/>
+                </a:solidFill>
+                <a:latin typeface="+mn-lt"/>
+                <a:ea typeface="+mn-ea"/>
+                <a:cs typeface="+mn-cs"/>
+              </a:defRPr>
+            </a:lvl9pPr>
+          </a:lstStyle>
+          <a:p>
+            <a:pPr marL="0" indent="0" algn="just">
+              <a:buFont typeface="Arial" panose="020B0604020202020204" pitchFamily="34" charset="0"/>
               <a:buNone/>
-              <a:defRPr sz="4400" kern="1200">
-                <a:solidFill>
-                  <a:schemeClr val="tx1"/>
-                </a:solidFill>
-                <a:latin typeface="+mj-lt"/>
-                <a:ea typeface="+mj-ea"/>
-                <a:cs typeface="+mj-cs"/>
-              </a:defRPr>
-            </a:lvl1pPr>
-          </a:lstStyle>
-          <a:p>
-            <a:r>
-              <a:rPr lang="es-MX" b="1" dirty="0">
-                <a:latin typeface="Century Gothic" panose="020B0502020202020204" pitchFamily="34" charset="0"/>
+            </a:pPr>
+            <a:endParaRPr lang="en-US" sz="2000" i="1"/>
+          </a:p>
+        </p:txBody>
+      </p:sp>
+      <p:sp>
+        <p:nvSpPr>
+          <p:cNvPr id="10" name="Rectangle 9"/>
+          <p:cNvSpPr/>
+          <p:nvPr/>
+        </p:nvSpPr>
+        <p:spPr>
+          <a:xfrm>
+            <a:off x="1331640" y="1095133"/>
+            <a:ext cx="7632848" cy="461665"/>
+          </a:xfrm>
+          <a:prstGeom prst="rect">
+            <a:avLst/>
+          </a:prstGeom>
+        </p:spPr>
+        <p:txBody>
+          <a:bodyPr wrap="square">
+            <a:spAutoFit/>
+          </a:bodyPr>
+          <a:lstStyle/>
+          <a:p>
+            <a:pPr>
+              <a:buFont typeface="Arial" panose="020B0604020202020204" pitchFamily="34" charset="0"/>
+              <a:buChar char="•"/>
+            </a:pPr>
+            <a:r>
+              <a:rPr lang="es-ES" sz="1200" b="0" i="0" dirty="0" smtClean="0">
+                <a:solidFill>
+                  <a:srgbClr val="222222"/>
+                </a:solidFill>
+                <a:effectLst/>
+                <a:latin typeface="Segoe UI" panose="020B0502040204020203" pitchFamily="34" charset="0"/>
               </a:rPr>
-              <a:t>2</a:t>
-            </a:r>
-            <a:r>
-              <a:rPr lang="es-MX" b="1" dirty="0" smtClean="0">
-                <a:latin typeface="Century Gothic" panose="020B0502020202020204" pitchFamily="34" charset="0"/>
+              <a:t> Se </a:t>
+            </a:r>
+            <a:r>
+              <a:rPr lang="es-ES" sz="1200" dirty="0" smtClean="0">
+                <a:solidFill>
+                  <a:srgbClr val="222222"/>
+                </a:solidFill>
+                <a:latin typeface="Segoe UI" panose="020B0502040204020203" pitchFamily="34" charset="0"/>
               </a:rPr>
-              <a:t>1/08/2020 – 27/08/2020</a:t>
-            </a:r>
-            <a:endParaRPr lang="es-MX" dirty="0">
-              <a:latin typeface="Century Gothic" panose="020B0502020202020204" pitchFamily="34" charset="0"/>
+              <a:t>Modifico pantalla </a:t>
+            </a:r>
+            <a:r>
+              <a:rPr lang="es-ES" sz="1200" dirty="0" smtClean="0">
+                <a:solidFill>
+                  <a:srgbClr val="222222"/>
+                </a:solidFill>
+                <a:latin typeface="Segoe UI" panose="020B0502040204020203" pitchFamily="34" charset="0"/>
+              </a:rPr>
+              <a:t>para </a:t>
+            </a:r>
+            <a:r>
+              <a:rPr lang="es-ES" sz="1200" dirty="0" smtClean="0">
+                <a:solidFill>
+                  <a:srgbClr val="222222"/>
+                </a:solidFill>
+                <a:latin typeface="Segoe UI" panose="020B0502040204020203" pitchFamily="34" charset="0"/>
+              </a:rPr>
+              <a:t>Mostrar/Listar </a:t>
+            </a:r>
+            <a:r>
+              <a:rPr lang="es-ES" sz="1200" dirty="0" smtClean="0">
+                <a:solidFill>
+                  <a:srgbClr val="222222"/>
+                </a:solidFill>
+                <a:latin typeface="Segoe UI" panose="020B0502040204020203" pitchFamily="34" charset="0"/>
+              </a:rPr>
+              <a:t>los artículos/No. Parte que contiene la orden de compra para su inspección.</a:t>
+            </a:r>
+            <a:endParaRPr lang="es-ES" sz="1200" b="0" i="0" dirty="0">
+              <a:solidFill>
+                <a:srgbClr val="222222"/>
+              </a:solidFill>
+              <a:effectLst/>
+              <a:latin typeface="Segoe UI" panose="020B0502040204020203" pitchFamily="34" charset="0"/>
             </a:endParaRPr>
           </a:p>
         </p:txBody>
       </p:sp>
+      <p:pic>
+        <p:nvPicPr>
+          <p:cNvPr id="4099" name="Picture 3" descr="C:\Users\Francisco Esteban\Documents\CONTROL_QUALITY\imagenes\LISTADO_ORDEN_v2.png"/>
+          <p:cNvPicPr>
+            <a:picLocks noChangeAspect="1" noChangeArrowheads="1"/>
+          </p:cNvPicPr>
+          <p:nvPr/>
+        </p:nvPicPr>
+        <p:blipFill>
+          <a:blip r:embed="rId2">
+            <a:extLst>
+              <a:ext uri="{28A0092B-C50C-407E-A947-70E740481C1C}">
+                <a14:useLocalDpi xmlns:a14="http://schemas.microsoft.com/office/drawing/2010/main" val="0"/>
+              </a:ext>
+            </a:extLst>
+          </a:blip>
+          <a:srcRect/>
+          <a:stretch>
+            <a:fillRect/>
+          </a:stretch>
+        </p:blipFill>
+        <p:spPr bwMode="auto">
+          <a:xfrm>
+            <a:off x="1331641" y="1628800"/>
+            <a:ext cx="7488832" cy="5040560"/>
+          </a:xfrm>
+          <a:prstGeom prst="rect">
+            <a:avLst/>
+          </a:prstGeom>
+          <a:noFill/>
+          <a:extLst>
+            <a:ext uri="{909E8E84-426E-40DD-AFC4-6F175D3DCCD1}">
+              <a14:hiddenFill xmlns:a14="http://schemas.microsoft.com/office/drawing/2010/main">
+                <a:solidFill>
+                  <a:srgbClr val="FFFFFF"/>
+                </a:solidFill>
+              </a14:hiddenFill>
+            </a:ext>
+          </a:extLst>
+        </p:spPr>
+      </p:pic>
     </p:spTree>
     <p:extLst>
       <p:ext uri="{BB962C8B-B14F-4D97-AF65-F5344CB8AC3E}">
-        <p14:creationId xmlns:p14="http://schemas.microsoft.com/office/powerpoint/2010/main" val="2896469538"/>
+        <p14:creationId xmlns:p14="http://schemas.microsoft.com/office/powerpoint/2010/main" val="2477851298"/>
       </p:ext>
     </p:extLst>
   </p:cSld>
@@ -5237,7 +7403,16 @@
                 </a:solidFill>
                 <a:latin typeface="Segoe UI" panose="020B0502040204020203" pitchFamily="34" charset="0"/>
               </a:rPr>
-              <a:t>creo pantalla para mostrar los mostrar los números de parte que serán configurados para inspección.</a:t>
+              <a:t>modifico Ficha </a:t>
+            </a:r>
+            <a:r>
+              <a:rPr lang="es-ES" sz="1200" dirty="0" smtClean="0">
+                <a:solidFill>
+                  <a:srgbClr val="222222"/>
+                </a:solidFill>
+                <a:latin typeface="Segoe UI" panose="020B0502040204020203" pitchFamily="34" charset="0"/>
+              </a:rPr>
+              <a:t>para la realización de las diferentes inspecciones para cada numero de parte en la orden.</a:t>
             </a:r>
             <a:endParaRPr lang="es-ES" sz="1200" b="0" i="0" dirty="0">
               <a:solidFill>
@@ -5251,7 +7426,7 @@
       </p:sp>
       <p:pic>
         <p:nvPicPr>
-          <p:cNvPr id="1027" name="Picture 3" descr="C:\Users\Francisco Esteban\Documents\CONTROL_QUALITY\imagenes\LISTADO.png"/>
+          <p:cNvPr id="5122" name="Picture 2" descr="C:\Users\Francisco Esteban\Documents\CONTROL_QUALITY\imagenes\FICHA_V3.png"/>
           <p:cNvPicPr>
             <a:picLocks noChangeAspect="1" noChangeArrowheads="1"/>
           </p:cNvPicPr>
@@ -5272,8 +7447,8 @@
         </p:blipFill>
         <p:spPr bwMode="auto">
           <a:xfrm>
-            <a:off x="1346634" y="1372132"/>
-            <a:ext cx="7458844" cy="5190480"/>
+            <a:off x="1475655" y="1445054"/>
+            <a:ext cx="7366896" cy="5152298"/>
           </a:xfrm>
           <a:prstGeom prst="rect">
             <a:avLst/>
@@ -5293,7 +7468,7 @@
     </p:spTree>
     <p:extLst>
       <p:ext uri="{BB962C8B-B14F-4D97-AF65-F5344CB8AC3E}">
-        <p14:creationId xmlns:p14="http://schemas.microsoft.com/office/powerpoint/2010/main" val="866398614"/>
+        <p14:creationId xmlns:p14="http://schemas.microsoft.com/office/powerpoint/2010/main" val="1456996479"/>
       </p:ext>
     </p:extLst>
   </p:cSld>
@@ -5589,7 +7764,16 @@
                 </a:solidFill>
                 <a:latin typeface="Segoe UI" panose="020B0502040204020203" pitchFamily="34" charset="0"/>
               </a:rPr>
-              <a:t>creo Ficha para capturar revisiones/inspección que se le realizara al numero de parte.</a:t>
+              <a:t>modifico Ficha </a:t>
+            </a:r>
+            <a:r>
+              <a:rPr lang="es-ES" sz="1200" dirty="0" smtClean="0">
+                <a:solidFill>
+                  <a:srgbClr val="222222"/>
+                </a:solidFill>
+                <a:latin typeface="Segoe UI" panose="020B0502040204020203" pitchFamily="34" charset="0"/>
+              </a:rPr>
+              <a:t>para la realización de las diferentes inspecciones para cada numero de parte en la orden.</a:t>
             </a:r>
             <a:endParaRPr lang="es-ES" sz="1200" b="0" i="0" dirty="0">
               <a:solidFill>
@@ -5603,7 +7787,7 @@
       </p:sp>
       <p:pic>
         <p:nvPicPr>
-          <p:cNvPr id="2050" name="Picture 2" descr="C:\Users\Francisco Esteban\Documents\CONTROL_QUALITY\imagenes\FICHA.png"/>
+          <p:cNvPr id="6147" name="Picture 3" descr="C:\Users\Francisco Esteban\Documents\CONTROL_QUALITY\imagenes\FICHA_V3_opc_mul.png"/>
           <p:cNvPicPr>
             <a:picLocks noChangeAspect="1" noChangeArrowheads="1"/>
           </p:cNvPicPr>
@@ -5624,8 +7808,8 @@
         </p:blipFill>
         <p:spPr bwMode="auto">
           <a:xfrm>
-            <a:off x="1259632" y="1422344"/>
-            <a:ext cx="7634179" cy="5247016"/>
+            <a:off x="1331641" y="1503090"/>
+            <a:ext cx="7488832" cy="5166269"/>
           </a:xfrm>
           <a:prstGeom prst="rect">
             <a:avLst/>
@@ -5645,7 +7829,562 @@
     </p:spTree>
     <p:extLst>
       <p:ext uri="{BB962C8B-B14F-4D97-AF65-F5344CB8AC3E}">
-        <p14:creationId xmlns:p14="http://schemas.microsoft.com/office/powerpoint/2010/main" val="1233991869"/>
+        <p14:creationId xmlns:p14="http://schemas.microsoft.com/office/powerpoint/2010/main" val="3341180063"/>
+      </p:ext>
+    </p:extLst>
+  </p:cSld>
+  <p:clrMapOvr>
+    <a:masterClrMapping/>
+  </p:clrMapOvr>
+  <p:timing>
+    <p:tnLst>
+      <p:par>
+        <p:cTn id="1" dur="indefinite" restart="never" nodeType="tmRoot"/>
+      </p:par>
+    </p:tnLst>
+  </p:timing>
+</p:sld>
+</file>
+
+<file path=ppt/slides/slide8.xml><?xml version="1.0" encoding="utf-8"?>
+<p:sld xmlns:a="http://schemas.openxmlformats.org/drawingml/2006/main" xmlns:r="http://schemas.openxmlformats.org/officeDocument/2006/relationships" xmlns:p="http://schemas.openxmlformats.org/presentationml/2006/main">
+  <p:cSld>
+    <p:spTree>
+      <p:nvGrpSpPr>
+        <p:cNvPr id="1" name=""/>
+        <p:cNvGrpSpPr/>
+        <p:nvPr/>
+      </p:nvGrpSpPr>
+      <p:grpSpPr>
+        <a:xfrm>
+          <a:off x="0" y="0"/>
+          <a:ext cx="0" cy="0"/>
+          <a:chOff x="0" y="0"/>
+          <a:chExt cx="0" cy="0"/>
+        </a:xfrm>
+      </p:grpSpPr>
+      <p:sp>
+        <p:nvSpPr>
+          <p:cNvPr id="8" name="Title 1"/>
+          <p:cNvSpPr txBox="1">
+            <a:spLocks/>
+          </p:cNvSpPr>
+          <p:nvPr/>
+        </p:nvSpPr>
+        <p:spPr>
+          <a:xfrm>
+            <a:off x="1087408" y="274638"/>
+            <a:ext cx="7229008" cy="634082"/>
+          </a:xfrm>
+          <a:prstGeom prst="rect">
+            <a:avLst/>
+          </a:prstGeom>
+        </p:spPr>
+        <p:txBody>
+          <a:bodyPr/>
+          <a:lstStyle>
+            <a:lvl1pPr algn="ctr" defTabSz="914400" rtl="0" eaLnBrk="1" latinLnBrk="0" hangingPunct="1">
+              <a:spcBef>
+                <a:spcPct val="0"/>
+              </a:spcBef>
+              <a:buNone/>
+              <a:defRPr sz="4400" kern="1200">
+                <a:solidFill>
+                  <a:schemeClr val="tx1"/>
+                </a:solidFill>
+                <a:latin typeface="+mj-lt"/>
+                <a:ea typeface="+mj-ea"/>
+                <a:cs typeface="+mj-cs"/>
+              </a:defRPr>
+            </a:lvl1pPr>
+          </a:lstStyle>
+          <a:p>
+            <a:pPr algn="l"/>
+            <a:r>
+              <a:rPr lang="es-ES" sz="2000" dirty="0" smtClean="0">
+                <a:solidFill>
+                  <a:srgbClr val="3F1900"/>
+                </a:solidFill>
+              </a:rPr>
+              <a:t>QA: Inspección de Material Recibido.</a:t>
+            </a:r>
+            <a:endParaRPr lang="en-US" sz="2000" dirty="0">
+              <a:solidFill>
+                <a:srgbClr val="3F1900"/>
+              </a:solidFill>
+            </a:endParaRPr>
+          </a:p>
+        </p:txBody>
+      </p:sp>
+      <p:sp>
+        <p:nvSpPr>
+          <p:cNvPr id="4" name="Content Placeholder 3"/>
+          <p:cNvSpPr txBox="1">
+            <a:spLocks/>
+          </p:cNvSpPr>
+          <p:nvPr/>
+        </p:nvSpPr>
+        <p:spPr>
+          <a:xfrm>
+            <a:off x="1331640" y="1196753"/>
+            <a:ext cx="7488832" cy="5137780"/>
+          </a:xfrm>
+          <a:prstGeom prst="rect">
+            <a:avLst/>
+          </a:prstGeom>
+        </p:spPr>
+        <p:txBody>
+          <a:bodyPr>
+            <a:normAutofit/>
+          </a:bodyPr>
+          <a:lstStyle>
+            <a:lvl1pPr marL="342900" indent="-342900" algn="l" defTabSz="914400" rtl="0" eaLnBrk="1" latinLnBrk="0" hangingPunct="1">
+              <a:spcBef>
+                <a:spcPct val="20000"/>
+              </a:spcBef>
+              <a:buFont typeface="Arial" panose="020B0604020202020204" pitchFamily="34" charset="0"/>
+              <a:buChar char="•"/>
+              <a:defRPr sz="3200" kern="1200">
+                <a:solidFill>
+                  <a:schemeClr val="tx1"/>
+                </a:solidFill>
+                <a:latin typeface="+mn-lt"/>
+                <a:ea typeface="+mn-ea"/>
+                <a:cs typeface="+mn-cs"/>
+              </a:defRPr>
+            </a:lvl1pPr>
+            <a:lvl2pPr marL="742950" indent="-285750" algn="l" defTabSz="914400" rtl="0" eaLnBrk="1" latinLnBrk="0" hangingPunct="1">
+              <a:spcBef>
+                <a:spcPct val="20000"/>
+              </a:spcBef>
+              <a:buFont typeface="Arial" panose="020B0604020202020204" pitchFamily="34" charset="0"/>
+              <a:buChar char="–"/>
+              <a:defRPr sz="2800" kern="1200">
+                <a:solidFill>
+                  <a:schemeClr val="tx1"/>
+                </a:solidFill>
+                <a:latin typeface="+mn-lt"/>
+                <a:ea typeface="+mn-ea"/>
+                <a:cs typeface="+mn-cs"/>
+              </a:defRPr>
+            </a:lvl2pPr>
+            <a:lvl3pPr marL="1143000" indent="-228600" algn="l" defTabSz="914400" rtl="0" eaLnBrk="1" latinLnBrk="0" hangingPunct="1">
+              <a:spcBef>
+                <a:spcPct val="20000"/>
+              </a:spcBef>
+              <a:buFont typeface="Arial" panose="020B0604020202020204" pitchFamily="34" charset="0"/>
+              <a:buChar char="•"/>
+              <a:defRPr sz="2400" kern="1200">
+                <a:solidFill>
+                  <a:schemeClr val="tx1"/>
+                </a:solidFill>
+                <a:latin typeface="+mn-lt"/>
+                <a:ea typeface="+mn-ea"/>
+                <a:cs typeface="+mn-cs"/>
+              </a:defRPr>
+            </a:lvl3pPr>
+            <a:lvl4pPr marL="1600200" indent="-228600" algn="l" defTabSz="914400" rtl="0" eaLnBrk="1" latinLnBrk="0" hangingPunct="1">
+              <a:spcBef>
+                <a:spcPct val="20000"/>
+              </a:spcBef>
+              <a:buFont typeface="Arial" panose="020B0604020202020204" pitchFamily="34" charset="0"/>
+              <a:buChar char="–"/>
+              <a:defRPr sz="2000" kern="1200">
+                <a:solidFill>
+                  <a:schemeClr val="tx1"/>
+                </a:solidFill>
+                <a:latin typeface="+mn-lt"/>
+                <a:ea typeface="+mn-ea"/>
+                <a:cs typeface="+mn-cs"/>
+              </a:defRPr>
+            </a:lvl4pPr>
+            <a:lvl5pPr marL="2057400" indent="-228600" algn="l" defTabSz="914400" rtl="0" eaLnBrk="1" latinLnBrk="0" hangingPunct="1">
+              <a:spcBef>
+                <a:spcPct val="20000"/>
+              </a:spcBef>
+              <a:buFont typeface="Arial" panose="020B0604020202020204" pitchFamily="34" charset="0"/>
+              <a:buChar char="»"/>
+              <a:defRPr sz="2000" kern="1200">
+                <a:solidFill>
+                  <a:schemeClr val="tx1"/>
+                </a:solidFill>
+                <a:latin typeface="+mn-lt"/>
+                <a:ea typeface="+mn-ea"/>
+                <a:cs typeface="+mn-cs"/>
+              </a:defRPr>
+            </a:lvl5pPr>
+            <a:lvl6pPr marL="2514600" indent="-228600" algn="l" defTabSz="914400" rtl="0" eaLnBrk="1" latinLnBrk="0" hangingPunct="1">
+              <a:spcBef>
+                <a:spcPct val="20000"/>
+              </a:spcBef>
+              <a:buFont typeface="Arial" panose="020B0604020202020204" pitchFamily="34" charset="0"/>
+              <a:buChar char="•"/>
+              <a:defRPr sz="2000" kern="1200">
+                <a:solidFill>
+                  <a:schemeClr val="tx1"/>
+                </a:solidFill>
+                <a:latin typeface="+mn-lt"/>
+                <a:ea typeface="+mn-ea"/>
+                <a:cs typeface="+mn-cs"/>
+              </a:defRPr>
+            </a:lvl6pPr>
+            <a:lvl7pPr marL="2971800" indent="-228600" algn="l" defTabSz="914400" rtl="0" eaLnBrk="1" latinLnBrk="0" hangingPunct="1">
+              <a:spcBef>
+                <a:spcPct val="20000"/>
+              </a:spcBef>
+              <a:buFont typeface="Arial" panose="020B0604020202020204" pitchFamily="34" charset="0"/>
+              <a:buChar char="•"/>
+              <a:defRPr sz="2000" kern="1200">
+                <a:solidFill>
+                  <a:schemeClr val="tx1"/>
+                </a:solidFill>
+                <a:latin typeface="+mn-lt"/>
+                <a:ea typeface="+mn-ea"/>
+                <a:cs typeface="+mn-cs"/>
+              </a:defRPr>
+            </a:lvl7pPr>
+            <a:lvl8pPr marL="3429000" indent="-228600" algn="l" defTabSz="914400" rtl="0" eaLnBrk="1" latinLnBrk="0" hangingPunct="1">
+              <a:spcBef>
+                <a:spcPct val="20000"/>
+              </a:spcBef>
+              <a:buFont typeface="Arial" panose="020B0604020202020204" pitchFamily="34" charset="0"/>
+              <a:buChar char="•"/>
+              <a:defRPr sz="2000" kern="1200">
+                <a:solidFill>
+                  <a:schemeClr val="tx1"/>
+                </a:solidFill>
+                <a:latin typeface="+mn-lt"/>
+                <a:ea typeface="+mn-ea"/>
+                <a:cs typeface="+mn-cs"/>
+              </a:defRPr>
+            </a:lvl8pPr>
+            <a:lvl9pPr marL="3886200" indent="-228600" algn="l" defTabSz="914400" rtl="0" eaLnBrk="1" latinLnBrk="0" hangingPunct="1">
+              <a:spcBef>
+                <a:spcPct val="20000"/>
+              </a:spcBef>
+              <a:buFont typeface="Arial" panose="020B0604020202020204" pitchFamily="34" charset="0"/>
+              <a:buChar char="•"/>
+              <a:defRPr sz="2000" kern="1200">
+                <a:solidFill>
+                  <a:schemeClr val="tx1"/>
+                </a:solidFill>
+                <a:latin typeface="+mn-lt"/>
+                <a:ea typeface="+mn-ea"/>
+                <a:cs typeface="+mn-cs"/>
+              </a:defRPr>
+            </a:lvl9pPr>
+          </a:lstStyle>
+          <a:p>
+            <a:pPr marL="0" indent="0" algn="just">
+              <a:buFont typeface="Arial" panose="020B0604020202020204" pitchFamily="34" charset="0"/>
+              <a:buNone/>
+            </a:pPr>
+            <a:endParaRPr lang="en-US" sz="2000" i="1"/>
+          </a:p>
+        </p:txBody>
+      </p:sp>
+      <p:sp>
+        <p:nvSpPr>
+          <p:cNvPr id="10" name="Rectangle 9"/>
+          <p:cNvSpPr/>
+          <p:nvPr/>
+        </p:nvSpPr>
+        <p:spPr>
+          <a:xfrm>
+            <a:off x="1331640" y="1095133"/>
+            <a:ext cx="7632848" cy="276999"/>
+          </a:xfrm>
+          <a:prstGeom prst="rect">
+            <a:avLst/>
+          </a:prstGeom>
+        </p:spPr>
+        <p:txBody>
+          <a:bodyPr wrap="square">
+            <a:spAutoFit/>
+          </a:bodyPr>
+          <a:lstStyle/>
+          <a:p>
+            <a:pPr>
+              <a:buFont typeface="Arial" panose="020B0604020202020204" pitchFamily="34" charset="0"/>
+              <a:buChar char="•"/>
+            </a:pPr>
+            <a:r>
+              <a:rPr lang="es-ES" sz="1200" b="0" i="0" dirty="0" smtClean="0">
+                <a:solidFill>
+                  <a:srgbClr val="222222"/>
+                </a:solidFill>
+                <a:effectLst/>
+                <a:latin typeface="Segoe UI" panose="020B0502040204020203" pitchFamily="34" charset="0"/>
+              </a:rPr>
+              <a:t> Se </a:t>
+            </a:r>
+            <a:r>
+              <a:rPr lang="es-ES" sz="1200" dirty="0" smtClean="0">
+                <a:solidFill>
+                  <a:srgbClr val="222222"/>
+                </a:solidFill>
+                <a:latin typeface="Segoe UI" panose="020B0502040204020203" pitchFamily="34" charset="0"/>
+              </a:rPr>
+              <a:t>creo pantalla </a:t>
+            </a:r>
+            <a:r>
+              <a:rPr lang="es-ES" sz="1200" dirty="0" smtClean="0">
+                <a:solidFill>
+                  <a:srgbClr val="222222"/>
+                </a:solidFill>
+                <a:latin typeface="Segoe UI" panose="020B0502040204020203" pitchFamily="34" charset="0"/>
+              </a:rPr>
+              <a:t>para </a:t>
+            </a:r>
+            <a:r>
+              <a:rPr lang="es-ES" sz="1200" dirty="0" smtClean="0">
+                <a:solidFill>
+                  <a:srgbClr val="222222"/>
+                </a:solidFill>
+                <a:latin typeface="Segoe UI" panose="020B0502040204020203" pitchFamily="34" charset="0"/>
+              </a:rPr>
+              <a:t>Autorizar de manera manual </a:t>
+            </a:r>
+            <a:r>
+              <a:rPr lang="es-ES" sz="1200" dirty="0" smtClean="0">
+                <a:solidFill>
+                  <a:srgbClr val="222222"/>
+                </a:solidFill>
+                <a:latin typeface="Segoe UI" panose="020B0502040204020203" pitchFamily="34" charset="0"/>
+              </a:rPr>
+              <a:t>los artículos/No. Parte </a:t>
+            </a:r>
+            <a:r>
+              <a:rPr lang="es-ES" sz="1200" dirty="0" smtClean="0">
+                <a:solidFill>
+                  <a:srgbClr val="222222"/>
+                </a:solidFill>
+                <a:latin typeface="Segoe UI" panose="020B0502040204020203" pitchFamily="34" charset="0"/>
+              </a:rPr>
+              <a:t>con estatus </a:t>
+            </a:r>
+            <a:r>
+              <a:rPr lang="es-ES" sz="1200" b="1" dirty="0" smtClean="0">
+                <a:solidFill>
+                  <a:srgbClr val="222222"/>
+                </a:solidFill>
+                <a:latin typeface="Segoe UI" panose="020B0502040204020203" pitchFamily="34" charset="0"/>
+              </a:rPr>
+              <a:t>Rechazado</a:t>
+            </a:r>
+            <a:r>
+              <a:rPr lang="es-ES" sz="1200" dirty="0" smtClean="0">
+                <a:solidFill>
+                  <a:srgbClr val="222222"/>
+                </a:solidFill>
+                <a:latin typeface="Segoe UI" panose="020B0502040204020203" pitchFamily="34" charset="0"/>
+              </a:rPr>
+              <a:t>.</a:t>
+            </a:r>
+            <a:endParaRPr lang="es-ES" sz="1200" b="0" i="0" dirty="0">
+              <a:solidFill>
+                <a:srgbClr val="222222"/>
+              </a:solidFill>
+              <a:effectLst/>
+              <a:latin typeface="Segoe UI" panose="020B0502040204020203" pitchFamily="34" charset="0"/>
+            </a:endParaRPr>
+          </a:p>
+        </p:txBody>
+      </p:sp>
+      <p:pic>
+        <p:nvPicPr>
+          <p:cNvPr id="7172" name="Picture 4"/>
+          <p:cNvPicPr>
+            <a:picLocks noChangeAspect="1" noChangeArrowheads="1"/>
+          </p:cNvPicPr>
+          <p:nvPr/>
+        </p:nvPicPr>
+        <p:blipFill rotWithShape="1">
+          <a:blip r:embed="rId2">
+            <a:extLst>
+              <a:ext uri="{28A0092B-C50C-407E-A947-70E740481C1C}">
+                <a14:useLocalDpi xmlns:a14="http://schemas.microsoft.com/office/drawing/2010/main" val="0"/>
+              </a:ext>
+            </a:extLst>
+          </a:blip>
+          <a:srcRect l="12009" t="2499" r="52398" b="24785"/>
+          <a:stretch/>
+        </p:blipFill>
+        <p:spPr bwMode="auto">
+          <a:xfrm>
+            <a:off x="1331640" y="1484784"/>
+            <a:ext cx="7632848" cy="5112568"/>
+          </a:xfrm>
+          <a:prstGeom prst="rect">
+            <a:avLst/>
+          </a:prstGeom>
+          <a:noFill/>
+          <a:ln w="9525">
+            <a:solidFill>
+              <a:srgbClr val="00B050"/>
+            </a:solidFill>
+            <a:miter lim="800000"/>
+            <a:headEnd/>
+            <a:tailEnd/>
+          </a:ln>
+          <a:extLst>
+            <a:ext uri="{909E8E84-426E-40DD-AFC4-6F175D3DCCD1}">
+              <a14:hiddenFill xmlns:a14="http://schemas.microsoft.com/office/drawing/2010/main">
+                <a:solidFill>
+                  <a:schemeClr val="accent1"/>
+                </a:solidFill>
+              </a14:hiddenFill>
+            </a:ext>
+          </a:extLst>
+        </p:spPr>
+      </p:pic>
+      <p:pic>
+        <p:nvPicPr>
+          <p:cNvPr id="7171" name="Picture 3" descr="C:\Users\Francisco Esteban\Documents\CONTROL_QUALITY\imagenes\Pantalla_autorizar.png"/>
+          <p:cNvPicPr>
+            <a:picLocks noChangeAspect="1" noChangeArrowheads="1"/>
+          </p:cNvPicPr>
+          <p:nvPr/>
+        </p:nvPicPr>
+        <p:blipFill rotWithShape="1">
+          <a:blip r:embed="rId3">
+            <a:extLst>
+              <a:ext uri="{28A0092B-C50C-407E-A947-70E740481C1C}">
+                <a14:useLocalDpi xmlns:a14="http://schemas.microsoft.com/office/drawing/2010/main" val="0"/>
+              </a:ext>
+            </a:extLst>
+          </a:blip>
+          <a:srcRect t="36121"/>
+          <a:stretch/>
+        </p:blipFill>
+        <p:spPr bwMode="auto">
+          <a:xfrm>
+            <a:off x="1412859" y="3717032"/>
+            <a:ext cx="7488832" cy="3096344"/>
+          </a:xfrm>
+          <a:prstGeom prst="rect">
+            <a:avLst/>
+          </a:prstGeom>
+          <a:noFill/>
+          <a:ln>
+            <a:solidFill>
+              <a:srgbClr val="FF0000"/>
+            </a:solidFill>
+          </a:ln>
+          <a:extLst>
+            <a:ext uri="{909E8E84-426E-40DD-AFC4-6F175D3DCCD1}">
+              <a14:hiddenFill xmlns:a14="http://schemas.microsoft.com/office/drawing/2010/main">
+                <a:solidFill>
+                  <a:srgbClr val="FFFFFF"/>
+                </a:solidFill>
+              </a14:hiddenFill>
+            </a:ext>
+          </a:extLst>
+        </p:spPr>
+      </p:pic>
+    </p:spTree>
+    <p:extLst>
+      <p:ext uri="{BB962C8B-B14F-4D97-AF65-F5344CB8AC3E}">
+        <p14:creationId xmlns:p14="http://schemas.microsoft.com/office/powerpoint/2010/main" val="1368698826"/>
+      </p:ext>
+    </p:extLst>
+  </p:cSld>
+  <p:clrMapOvr>
+    <a:masterClrMapping/>
+  </p:clrMapOvr>
+  <p:timing>
+    <p:tnLst>
+      <p:par>
+        <p:cTn id="1" dur="indefinite" restart="never" nodeType="tmRoot"/>
+      </p:par>
+    </p:tnLst>
+  </p:timing>
+</p:sld>
+</file>
+
+<file path=ppt/slides/slide9.xml><?xml version="1.0" encoding="utf-8"?>
+<p:sld xmlns:a="http://schemas.openxmlformats.org/drawingml/2006/main" xmlns:r="http://schemas.openxmlformats.org/officeDocument/2006/relationships" xmlns:p="http://schemas.openxmlformats.org/presentationml/2006/main">
+  <p:cSld>
+    <p:spTree>
+      <p:nvGrpSpPr>
+        <p:cNvPr id="1" name=""/>
+        <p:cNvGrpSpPr/>
+        <p:nvPr/>
+      </p:nvGrpSpPr>
+      <p:grpSpPr>
+        <a:xfrm>
+          <a:off x="0" y="0"/>
+          <a:ext cx="0" cy="0"/>
+          <a:chOff x="0" y="0"/>
+          <a:chExt cx="0" cy="0"/>
+        </a:xfrm>
+      </p:grpSpPr>
+      <p:sp>
+        <p:nvSpPr>
+          <p:cNvPr id="5" name="Title 1"/>
+          <p:cNvSpPr txBox="1">
+            <a:spLocks/>
+          </p:cNvSpPr>
+          <p:nvPr/>
+        </p:nvSpPr>
+        <p:spPr>
+          <a:xfrm>
+            <a:off x="1187624" y="2564904"/>
+            <a:ext cx="7772400" cy="1470025"/>
+          </a:xfrm>
+          <a:prstGeom prst="rect">
+            <a:avLst/>
+          </a:prstGeom>
+        </p:spPr>
+        <p:txBody>
+          <a:bodyPr vert="horz" lIns="91440" tIns="45720" rIns="91440" bIns="45720" rtlCol="0" anchor="ctr">
+            <a:normAutofit/>
+          </a:bodyPr>
+          <a:lstStyle>
+            <a:lvl1pPr algn="ctr" defTabSz="914400" rtl="0" eaLnBrk="1" latinLnBrk="0" hangingPunct="1">
+              <a:spcBef>
+                <a:spcPct val="0"/>
+              </a:spcBef>
+              <a:buNone/>
+              <a:defRPr sz="4400" kern="1200">
+                <a:solidFill>
+                  <a:schemeClr val="tx1"/>
+                </a:solidFill>
+                <a:latin typeface="+mj-lt"/>
+                <a:ea typeface="+mj-ea"/>
+                <a:cs typeface="+mj-cs"/>
+              </a:defRPr>
+            </a:lvl1pPr>
+          </a:lstStyle>
+          <a:p>
+            <a:r>
+              <a:rPr lang="es-MX" b="1" dirty="0" smtClean="0">
+                <a:latin typeface="Century Gothic" panose="020B0502020202020204" pitchFamily="34" charset="0"/>
+              </a:rPr>
+              <a:t>2</a:t>
+            </a:r>
+            <a:r>
+              <a:rPr lang="es-MX" b="1" dirty="0">
+                <a:latin typeface="Century Gothic" panose="020B0502020202020204" pitchFamily="34" charset="0"/>
+              </a:rPr>
+              <a:t>8</a:t>
+            </a:r>
+            <a:r>
+              <a:rPr lang="es-MX" b="1" dirty="0" smtClean="0">
+                <a:latin typeface="Century Gothic" panose="020B0502020202020204" pitchFamily="34" charset="0"/>
+              </a:rPr>
+              <a:t>/08/2020 – 03/09/2020</a:t>
+            </a:r>
+            <a:endParaRPr lang="es-MX" dirty="0">
+              <a:latin typeface="Century Gothic" panose="020B0502020202020204" pitchFamily="34" charset="0"/>
+            </a:endParaRPr>
+          </a:p>
+        </p:txBody>
+      </p:sp>
+    </p:spTree>
+    <p:extLst>
+      <p:ext uri="{BB962C8B-B14F-4D97-AF65-F5344CB8AC3E}">
+        <p14:creationId xmlns:p14="http://schemas.microsoft.com/office/powerpoint/2010/main" val="1449075767"/>
       </p:ext>
     </p:extLst>
   </p:cSld>
@@ -6202,7 +8941,7 @@
   <a:extraClrSchemeLst/>
   <a:extLst>
     <a:ext uri="{05A4C25C-085E-4340-85A3-A5531E510DB2}">
-      <thm15:themeFamily xmlns:thm15="http://schemas.microsoft.com/office/thememl/2012/main" xmlns="" name="Office Theme" id="{62F939B6-93AF-4DB8-9C6B-D6C7DFDC589F}" vid="{4A3C46E8-61CC-4603-A589-7422A47A8E4A}"/>
+      <thm15:themeFamily xmlns="" xmlns:thm15="http://schemas.microsoft.com/office/thememl/2012/main" name="Office Theme" id="{62F939B6-93AF-4DB8-9C6B-D6C7DFDC589F}" vid="{4A3C46E8-61CC-4603-A589-7422A47A8E4A}"/>
     </a:ext>
   </a:extLst>
 </a:theme>

</xml_diff>